<commit_message>
continuing the chapter Grundlagen in SL1
</commit_message>
<xml_diff>
--- a/LaTeX B.Sc. LRT/Strömungslehre 1/images/SL1-Images.pptx
+++ b/LaTeX B.Sc. LRT/Strömungslehre 1/images/SL1-Images.pptx
@@ -6,7 +6,9 @@
   </p:sldMasterIdLst>
   <p:sldIdLst>
     <p:sldId id="256" r:id="rId2"/>
-    <p:sldId id="257" r:id="rId3"/>
+    <p:sldId id="258" r:id="rId3"/>
+    <p:sldId id="259" r:id="rId4"/>
+    <p:sldId id="257" r:id="rId5"/>
   </p:sldIdLst>
   <p:sldSz cx="3600450" cy="3600450"/>
   <p:notesSz cx="6858000" cy="9144000"/>
@@ -105,6 +107,11 @@
       </a:defRPr>
     </a:lvl9pPr>
   </p:defaultTextStyle>
+  <p:extLst>
+    <p:ext uri="{EFAFB233-063F-42B5-8137-9DF3F51BA10A}">
+      <p15:sldGuideLst xmlns:p15="http://schemas.microsoft.com/office/powerpoint/2012/main"/>
+    </p:ext>
+  </p:extLst>
 </p:presentation>
 </file>
 
@@ -239,7 +246,7 @@
           <a:p>
             <a:fld id="{0F04D7A0-D8C8-4B74-9611-9A000801FA36}" type="datetimeFigureOut">
               <a:rPr lang="de-DE" smtClean="0"/>
-              <a:t>04.09.2026</a:t>
+              <a:t>06.09.2026</a:t>
             </a:fld>
             <a:endParaRPr lang="de-DE"/>
           </a:p>
@@ -409,7 +416,7 @@
           <a:p>
             <a:fld id="{0F04D7A0-D8C8-4B74-9611-9A000801FA36}" type="datetimeFigureOut">
               <a:rPr lang="de-DE" smtClean="0"/>
-              <a:t>04.09.2026</a:t>
+              <a:t>06.09.2026</a:t>
             </a:fld>
             <a:endParaRPr lang="de-DE"/>
           </a:p>
@@ -589,7 +596,7 @@
           <a:p>
             <a:fld id="{0F04D7A0-D8C8-4B74-9611-9A000801FA36}" type="datetimeFigureOut">
               <a:rPr lang="de-DE" smtClean="0"/>
-              <a:t>04.09.2026</a:t>
+              <a:t>06.09.2026</a:t>
             </a:fld>
             <a:endParaRPr lang="de-DE"/>
           </a:p>
@@ -759,7 +766,7 @@
           <a:p>
             <a:fld id="{0F04D7A0-D8C8-4B74-9611-9A000801FA36}" type="datetimeFigureOut">
               <a:rPr lang="de-DE" smtClean="0"/>
-              <a:t>04.09.2026</a:t>
+              <a:t>06.09.2026</a:t>
             </a:fld>
             <a:endParaRPr lang="de-DE"/>
           </a:p>
@@ -1005,7 +1012,7 @@
           <a:p>
             <a:fld id="{0F04D7A0-D8C8-4B74-9611-9A000801FA36}" type="datetimeFigureOut">
               <a:rPr lang="de-DE" smtClean="0"/>
-              <a:t>04.09.2026</a:t>
+              <a:t>06.09.2026</a:t>
             </a:fld>
             <a:endParaRPr lang="de-DE"/>
           </a:p>
@@ -1237,7 +1244,7 @@
           <a:p>
             <a:fld id="{0F04D7A0-D8C8-4B74-9611-9A000801FA36}" type="datetimeFigureOut">
               <a:rPr lang="de-DE" smtClean="0"/>
-              <a:t>04.09.2026</a:t>
+              <a:t>06.09.2026</a:t>
             </a:fld>
             <a:endParaRPr lang="de-DE"/>
           </a:p>
@@ -1604,7 +1611,7 @@
           <a:p>
             <a:fld id="{0F04D7A0-D8C8-4B74-9611-9A000801FA36}" type="datetimeFigureOut">
               <a:rPr lang="de-DE" smtClean="0"/>
-              <a:t>04.09.2026</a:t>
+              <a:t>06.09.2026</a:t>
             </a:fld>
             <a:endParaRPr lang="de-DE"/>
           </a:p>
@@ -1722,7 +1729,7 @@
           <a:p>
             <a:fld id="{0F04D7A0-D8C8-4B74-9611-9A000801FA36}" type="datetimeFigureOut">
               <a:rPr lang="de-DE" smtClean="0"/>
-              <a:t>04.09.2026</a:t>
+              <a:t>06.09.2026</a:t>
             </a:fld>
             <a:endParaRPr lang="de-DE"/>
           </a:p>
@@ -1817,7 +1824,7 @@
           <a:p>
             <a:fld id="{0F04D7A0-D8C8-4B74-9611-9A000801FA36}" type="datetimeFigureOut">
               <a:rPr lang="de-DE" smtClean="0"/>
-              <a:t>04.09.2026</a:t>
+              <a:t>06.09.2026</a:t>
             </a:fld>
             <a:endParaRPr lang="de-DE"/>
           </a:p>
@@ -2094,7 +2101,7 @@
           <a:p>
             <a:fld id="{0F04D7A0-D8C8-4B74-9611-9A000801FA36}" type="datetimeFigureOut">
               <a:rPr lang="de-DE" smtClean="0"/>
-              <a:t>04.09.2026</a:t>
+              <a:t>06.09.2026</a:t>
             </a:fld>
             <a:endParaRPr lang="de-DE"/>
           </a:p>
@@ -2351,7 +2358,7 @@
           <a:p>
             <a:fld id="{0F04D7A0-D8C8-4B74-9611-9A000801FA36}" type="datetimeFigureOut">
               <a:rPr lang="de-DE" smtClean="0"/>
-              <a:t>04.09.2026</a:t>
+              <a:t>06.09.2026</a:t>
             </a:fld>
             <a:endParaRPr lang="de-DE"/>
           </a:p>
@@ -2564,7 +2571,7 @@
           <a:p>
             <a:fld id="{0F04D7A0-D8C8-4B74-9611-9A000801FA36}" type="datetimeFigureOut">
               <a:rPr lang="de-DE" smtClean="0"/>
-              <a:t>04.09.2026</a:t>
+              <a:t>06.09.2026</a:t>
             </a:fld>
             <a:endParaRPr lang="de-DE"/>
           </a:p>
@@ -3179,7 +3186,7 @@
             <a:schemeClr val="tx2">
               <a:lumMod val="75000"/>
               <a:lumOff val="25000"/>
-              <a:alpha val="30000"/>
+              <a:alpha val="10000"/>
             </a:schemeClr>
           </a:solidFill>
           <a:ln cap="rnd">
@@ -4026,6 +4033,2730 @@
 </file>
 
 <file path=ppt/slides/slide2.xml><?xml version="1.0" encoding="utf-8"?>
+<p:sld xmlns:a="http://schemas.openxmlformats.org/drawingml/2006/main" xmlns:r="http://schemas.openxmlformats.org/officeDocument/2006/relationships" xmlns:p="http://schemas.openxmlformats.org/presentationml/2006/main">
+  <p:cSld>
+    <p:spTree>
+      <p:nvGrpSpPr>
+        <p:cNvPr id="1" name="">
+          <a:extLst>
+            <a:ext uri="{FF2B5EF4-FFF2-40B4-BE49-F238E27FC236}">
+              <a16:creationId xmlns:a16="http://schemas.microsoft.com/office/drawing/2014/main" id="{3099CE05-2D76-C0E2-F59D-97B5BEB1D808}"/>
+            </a:ext>
+          </a:extLst>
+        </p:cNvPr>
+        <p:cNvGrpSpPr/>
+        <p:nvPr/>
+      </p:nvGrpSpPr>
+      <p:grpSpPr>
+        <a:xfrm>
+          <a:off x="0" y="0"/>
+          <a:ext cx="0" cy="0"/>
+          <a:chOff x="0" y="0"/>
+          <a:chExt cx="0" cy="0"/>
+        </a:xfrm>
+      </p:grpSpPr>
+      <p:cxnSp>
+        <p:nvCxnSpPr>
+          <p:cNvPr id="11" name="Gerade Verbindung mit Pfeil 10">
+            <a:extLst>
+              <a:ext uri="{FF2B5EF4-FFF2-40B4-BE49-F238E27FC236}">
+                <a16:creationId xmlns:a16="http://schemas.microsoft.com/office/drawing/2014/main" id="{B7125028-A672-8195-345B-DE95AD9BBD06}"/>
+              </a:ext>
+            </a:extLst>
+          </p:cNvPr>
+          <p:cNvCxnSpPr>
+            <a:cxnSpLocks/>
+          </p:cNvCxnSpPr>
+          <p:nvPr/>
+        </p:nvCxnSpPr>
+        <p:spPr>
+          <a:xfrm flipV="1">
+            <a:off x="426720" y="2078831"/>
+            <a:ext cx="757236" cy="757236"/>
+          </a:xfrm>
+          <a:prstGeom prst="straightConnector1">
+            <a:avLst/>
+          </a:prstGeom>
+          <a:ln cap="rnd">
+            <a:solidFill>
+              <a:schemeClr val="tx1"/>
+            </a:solidFill>
+            <a:round/>
+            <a:headEnd type="triangle"/>
+            <a:tailEnd type="none"/>
+          </a:ln>
+        </p:spPr>
+        <p:style>
+          <a:lnRef idx="2">
+            <a:schemeClr val="accent1"/>
+          </a:lnRef>
+          <a:fillRef idx="0">
+            <a:schemeClr val="accent1"/>
+          </a:fillRef>
+          <a:effectRef idx="1">
+            <a:schemeClr val="accent1"/>
+          </a:effectRef>
+          <a:fontRef idx="minor">
+            <a:schemeClr val="tx1"/>
+          </a:fontRef>
+        </p:style>
+      </p:cxnSp>
+      <p:cxnSp>
+        <p:nvCxnSpPr>
+          <p:cNvPr id="6" name="Gerade Verbindung mit Pfeil 5">
+            <a:extLst>
+              <a:ext uri="{FF2B5EF4-FFF2-40B4-BE49-F238E27FC236}">
+                <a16:creationId xmlns:a16="http://schemas.microsoft.com/office/drawing/2014/main" id="{B7FA81D2-27B7-BCFA-F958-CDA7162FCF4D}"/>
+              </a:ext>
+            </a:extLst>
+          </p:cNvPr>
+          <p:cNvCxnSpPr>
+            <a:cxnSpLocks/>
+          </p:cNvCxnSpPr>
+          <p:nvPr/>
+        </p:nvCxnSpPr>
+        <p:spPr>
+          <a:xfrm flipV="1">
+            <a:off x="1183958" y="639366"/>
+            <a:ext cx="0" cy="1439465"/>
+          </a:xfrm>
+          <a:prstGeom prst="straightConnector1">
+            <a:avLst/>
+          </a:prstGeom>
+          <a:ln cap="rnd">
+            <a:solidFill>
+              <a:schemeClr val="tx1"/>
+            </a:solidFill>
+            <a:round/>
+            <a:tailEnd type="triangle"/>
+          </a:ln>
+        </p:spPr>
+        <p:style>
+          <a:lnRef idx="2">
+            <a:schemeClr val="accent1"/>
+          </a:lnRef>
+          <a:fillRef idx="0">
+            <a:schemeClr val="accent1"/>
+          </a:fillRef>
+          <a:effectRef idx="1">
+            <a:schemeClr val="accent1"/>
+          </a:effectRef>
+          <a:fontRef idx="minor">
+            <a:schemeClr val="tx1"/>
+          </a:fontRef>
+        </p:style>
+      </p:cxnSp>
+      <p:cxnSp>
+        <p:nvCxnSpPr>
+          <p:cNvPr id="7" name="Gerade Verbindung mit Pfeil 6">
+            <a:extLst>
+              <a:ext uri="{FF2B5EF4-FFF2-40B4-BE49-F238E27FC236}">
+                <a16:creationId xmlns:a16="http://schemas.microsoft.com/office/drawing/2014/main" id="{A91FAB22-9AFF-0861-541E-B2292877DD30}"/>
+              </a:ext>
+            </a:extLst>
+          </p:cNvPr>
+          <p:cNvCxnSpPr>
+            <a:cxnSpLocks/>
+          </p:cNvCxnSpPr>
+          <p:nvPr/>
+        </p:nvCxnSpPr>
+        <p:spPr>
+          <a:xfrm>
+            <a:off x="1183958" y="2078831"/>
+            <a:ext cx="2039540" cy="0"/>
+          </a:xfrm>
+          <a:prstGeom prst="straightConnector1">
+            <a:avLst/>
+          </a:prstGeom>
+          <a:ln cap="rnd">
+            <a:solidFill>
+              <a:schemeClr val="tx1"/>
+            </a:solidFill>
+            <a:round/>
+            <a:tailEnd type="triangle"/>
+          </a:ln>
+        </p:spPr>
+        <p:style>
+          <a:lnRef idx="2">
+            <a:schemeClr val="accent1"/>
+          </a:lnRef>
+          <a:fillRef idx="0">
+            <a:schemeClr val="accent1"/>
+          </a:fillRef>
+          <a:effectRef idx="1">
+            <a:schemeClr val="accent1"/>
+          </a:effectRef>
+          <a:fontRef idx="minor">
+            <a:schemeClr val="tx1"/>
+          </a:fontRef>
+        </p:style>
+      </p:cxnSp>
+      <p:sp>
+        <p:nvSpPr>
+          <p:cNvPr id="20" name="Textfeld 19">
+            <a:extLst>
+              <a:ext uri="{FF2B5EF4-FFF2-40B4-BE49-F238E27FC236}">
+                <a16:creationId xmlns:a16="http://schemas.microsoft.com/office/drawing/2014/main" id="{50C2DEA0-D114-A1C2-7E61-710BD10C2870}"/>
+              </a:ext>
+            </a:extLst>
+          </p:cNvPr>
+          <p:cNvSpPr txBox="1"/>
+          <p:nvPr/>
+        </p:nvSpPr>
+        <p:spPr>
+          <a:xfrm>
+            <a:off x="1183956" y="454699"/>
+            <a:ext cx="317888" cy="369332"/>
+          </a:xfrm>
+          <a:prstGeom prst="rect">
+            <a:avLst/>
+          </a:prstGeom>
+          <a:noFill/>
+        </p:spPr>
+        <p:txBody>
+          <a:bodyPr wrap="square" rtlCol="0" anchor="ctr">
+            <a:spAutoFit/>
+          </a:bodyPr>
+          <a:lstStyle/>
+          <a:p>
+            <a:pPr algn="ctr"/>
+            <a:r>
+              <a:rPr lang="de-DE" i="1" dirty="0">
+                <a:latin typeface="CMU Serif" panose="02000603000000000000" pitchFamily="2" charset="0"/>
+                <a:ea typeface="CMU Serif" panose="02000603000000000000" pitchFamily="2" charset="0"/>
+                <a:cs typeface="CMU Serif" panose="02000603000000000000" pitchFamily="2" charset="0"/>
+              </a:rPr>
+              <a:t>z</a:t>
+            </a:r>
+          </a:p>
+        </p:txBody>
+      </p:sp>
+      <p:sp>
+        <p:nvSpPr>
+          <p:cNvPr id="22" name="Textfeld 21">
+            <a:extLst>
+              <a:ext uri="{FF2B5EF4-FFF2-40B4-BE49-F238E27FC236}">
+                <a16:creationId xmlns:a16="http://schemas.microsoft.com/office/drawing/2014/main" id="{56056F5A-FADC-8A3F-59F6-509B60616016}"/>
+              </a:ext>
+            </a:extLst>
+          </p:cNvPr>
+          <p:cNvSpPr txBox="1"/>
+          <p:nvPr/>
+        </p:nvSpPr>
+        <p:spPr>
+          <a:xfrm>
+            <a:off x="3064554" y="2055196"/>
+            <a:ext cx="317888" cy="369332"/>
+          </a:xfrm>
+          <a:prstGeom prst="rect">
+            <a:avLst/>
+          </a:prstGeom>
+          <a:noFill/>
+        </p:spPr>
+        <p:txBody>
+          <a:bodyPr wrap="square" rtlCol="0" anchor="ctr">
+            <a:spAutoFit/>
+          </a:bodyPr>
+          <a:lstStyle/>
+          <a:p>
+            <a:pPr algn="ctr"/>
+            <a:r>
+              <a:rPr lang="de-DE" i="1" dirty="0">
+                <a:latin typeface="CMU Serif" panose="02000603000000000000" pitchFamily="2" charset="0"/>
+                <a:ea typeface="CMU Serif" panose="02000603000000000000" pitchFamily="2" charset="0"/>
+                <a:cs typeface="CMU Serif" panose="02000603000000000000" pitchFamily="2" charset="0"/>
+              </a:rPr>
+              <a:t>y</a:t>
+            </a:r>
+          </a:p>
+        </p:txBody>
+      </p:sp>
+      <p:sp>
+        <p:nvSpPr>
+          <p:cNvPr id="24" name="Textfeld 23">
+            <a:extLst>
+              <a:ext uri="{FF2B5EF4-FFF2-40B4-BE49-F238E27FC236}">
+                <a16:creationId xmlns:a16="http://schemas.microsoft.com/office/drawing/2014/main" id="{08E48622-2C7C-2DEE-78E6-B4E9D81F8A13}"/>
+              </a:ext>
+            </a:extLst>
+          </p:cNvPr>
+          <p:cNvSpPr txBox="1"/>
+          <p:nvPr/>
+        </p:nvSpPr>
+        <p:spPr>
+          <a:xfrm>
+            <a:off x="502690" y="2635367"/>
+            <a:ext cx="317888" cy="369332"/>
+          </a:xfrm>
+          <a:prstGeom prst="rect">
+            <a:avLst/>
+          </a:prstGeom>
+          <a:noFill/>
+        </p:spPr>
+        <p:txBody>
+          <a:bodyPr wrap="square" rtlCol="0" anchor="ctr">
+            <a:spAutoFit/>
+          </a:bodyPr>
+          <a:lstStyle/>
+          <a:p>
+            <a:pPr algn="ctr"/>
+            <a:r>
+              <a:rPr lang="de-DE" i="1" dirty="0">
+                <a:latin typeface="CMU Serif" panose="02000603000000000000" pitchFamily="2" charset="0"/>
+                <a:ea typeface="CMU Serif" panose="02000603000000000000" pitchFamily="2" charset="0"/>
+                <a:cs typeface="CMU Serif" panose="02000603000000000000" pitchFamily="2" charset="0"/>
+              </a:rPr>
+              <a:t>x</a:t>
+            </a:r>
+          </a:p>
+        </p:txBody>
+      </p:sp>
+      <p:cxnSp>
+        <p:nvCxnSpPr>
+          <p:cNvPr id="25" name="Gerade Verbindung mit Pfeil 24">
+            <a:extLst>
+              <a:ext uri="{FF2B5EF4-FFF2-40B4-BE49-F238E27FC236}">
+                <a16:creationId xmlns:a16="http://schemas.microsoft.com/office/drawing/2014/main" id="{8A67D595-68B8-B07C-9D78-906554936823}"/>
+              </a:ext>
+            </a:extLst>
+          </p:cNvPr>
+          <p:cNvCxnSpPr>
+            <a:cxnSpLocks/>
+          </p:cNvCxnSpPr>
+          <p:nvPr/>
+        </p:nvCxnSpPr>
+        <p:spPr>
+          <a:xfrm flipH="1" flipV="1">
+            <a:off x="2344289" y="1579338"/>
+            <a:ext cx="286516" cy="119922"/>
+          </a:xfrm>
+          <a:prstGeom prst="straightConnector1">
+            <a:avLst/>
+          </a:prstGeom>
+          <a:ln w="25400" cap="rnd">
+            <a:solidFill>
+              <a:schemeClr val="accent2">
+                <a:lumMod val="75000"/>
+              </a:schemeClr>
+            </a:solidFill>
+            <a:round/>
+            <a:headEnd type="triangle"/>
+            <a:tailEnd type="none"/>
+          </a:ln>
+        </p:spPr>
+        <p:style>
+          <a:lnRef idx="2">
+            <a:schemeClr val="accent1"/>
+          </a:lnRef>
+          <a:fillRef idx="0">
+            <a:schemeClr val="accent1"/>
+          </a:fillRef>
+          <a:effectRef idx="1">
+            <a:schemeClr val="accent1"/>
+          </a:effectRef>
+          <a:fontRef idx="minor">
+            <a:schemeClr val="tx1"/>
+          </a:fontRef>
+        </p:style>
+      </p:cxnSp>
+      <p:cxnSp>
+        <p:nvCxnSpPr>
+          <p:cNvPr id="27" name="Gerade Verbindung mit Pfeil 26">
+            <a:extLst>
+              <a:ext uri="{FF2B5EF4-FFF2-40B4-BE49-F238E27FC236}">
+                <a16:creationId xmlns:a16="http://schemas.microsoft.com/office/drawing/2014/main" id="{E2E3895B-A278-3871-06F9-CE28D285E7C6}"/>
+              </a:ext>
+            </a:extLst>
+          </p:cNvPr>
+          <p:cNvCxnSpPr>
+            <a:cxnSpLocks/>
+          </p:cNvCxnSpPr>
+          <p:nvPr/>
+        </p:nvCxnSpPr>
+        <p:spPr>
+          <a:xfrm rot="18900000" flipV="1">
+            <a:off x="2231179" y="1306732"/>
+            <a:ext cx="226218" cy="226218"/>
+          </a:xfrm>
+          <a:prstGeom prst="straightConnector1">
+            <a:avLst/>
+          </a:prstGeom>
+          <a:ln w="25400" cap="rnd">
+            <a:solidFill>
+              <a:schemeClr val="accent2">
+                <a:lumMod val="75000"/>
+              </a:schemeClr>
+            </a:solidFill>
+            <a:round/>
+            <a:headEnd type="none"/>
+            <a:tailEnd type="triangle"/>
+          </a:ln>
+        </p:spPr>
+        <p:style>
+          <a:lnRef idx="2">
+            <a:schemeClr val="accent1"/>
+          </a:lnRef>
+          <a:fillRef idx="0">
+            <a:schemeClr val="accent1"/>
+          </a:fillRef>
+          <a:effectRef idx="1">
+            <a:schemeClr val="accent1"/>
+          </a:effectRef>
+          <a:fontRef idx="minor">
+            <a:schemeClr val="tx1"/>
+          </a:fontRef>
+        </p:style>
+      </p:cxnSp>
+      <p:cxnSp>
+        <p:nvCxnSpPr>
+          <p:cNvPr id="29" name="Gerade Verbindung mit Pfeil 28">
+            <a:extLst>
+              <a:ext uri="{FF2B5EF4-FFF2-40B4-BE49-F238E27FC236}">
+                <a16:creationId xmlns:a16="http://schemas.microsoft.com/office/drawing/2014/main" id="{FB29789E-112C-983A-88AB-D8CE1E73BF05}"/>
+              </a:ext>
+            </a:extLst>
+          </p:cNvPr>
+          <p:cNvCxnSpPr>
+            <a:cxnSpLocks/>
+          </p:cNvCxnSpPr>
+          <p:nvPr/>
+        </p:nvCxnSpPr>
+        <p:spPr>
+          <a:xfrm flipV="1">
+            <a:off x="2342255" y="1390650"/>
+            <a:ext cx="274598" cy="188688"/>
+          </a:xfrm>
+          <a:prstGeom prst="straightConnector1">
+            <a:avLst/>
+          </a:prstGeom>
+          <a:ln w="25400" cap="rnd">
+            <a:solidFill>
+              <a:schemeClr val="accent2">
+                <a:lumMod val="75000"/>
+              </a:schemeClr>
+            </a:solidFill>
+            <a:round/>
+            <a:headEnd type="none"/>
+            <a:tailEnd type="triangle"/>
+          </a:ln>
+        </p:spPr>
+        <p:style>
+          <a:lnRef idx="2">
+            <a:schemeClr val="accent1"/>
+          </a:lnRef>
+          <a:fillRef idx="0">
+            <a:schemeClr val="accent1"/>
+          </a:fillRef>
+          <a:effectRef idx="1">
+            <a:schemeClr val="accent1"/>
+          </a:effectRef>
+          <a:fontRef idx="minor">
+            <a:schemeClr val="tx1"/>
+          </a:fontRef>
+        </p:style>
+      </p:cxnSp>
+      <p:grpSp>
+        <p:nvGrpSpPr>
+          <p:cNvPr id="18" name="Gruppieren 17">
+            <a:extLst>
+              <a:ext uri="{FF2B5EF4-FFF2-40B4-BE49-F238E27FC236}">
+                <a16:creationId xmlns:a16="http://schemas.microsoft.com/office/drawing/2014/main" id="{849DC932-C15C-8F2C-3E63-AA91B47C879C}"/>
+              </a:ext>
+            </a:extLst>
+          </p:cNvPr>
+          <p:cNvGrpSpPr/>
+          <p:nvPr/>
+        </p:nvGrpSpPr>
+        <p:grpSpPr>
+          <a:xfrm>
+            <a:off x="2558950" y="1556813"/>
+            <a:ext cx="416102" cy="369332"/>
+            <a:chOff x="2557858" y="765199"/>
+            <a:chExt cx="416102" cy="369332"/>
+          </a:xfrm>
+        </p:grpSpPr>
+        <p:sp>
+          <p:nvSpPr>
+            <p:cNvPr id="31" name="Textfeld 30">
+              <a:extLst>
+                <a:ext uri="{FF2B5EF4-FFF2-40B4-BE49-F238E27FC236}">
+                  <a16:creationId xmlns:a16="http://schemas.microsoft.com/office/drawing/2014/main" id="{764DDA0E-D565-30C5-2EA3-4E1FBC76C9FB}"/>
+                </a:ext>
+              </a:extLst>
+            </p:cNvPr>
+            <p:cNvSpPr txBox="1"/>
+            <p:nvPr/>
+          </p:nvSpPr>
+          <p:spPr>
+            <a:xfrm>
+              <a:off x="2557858" y="765199"/>
+              <a:ext cx="416102" cy="369332"/>
+            </a:xfrm>
+            <a:prstGeom prst="rect">
+              <a:avLst/>
+            </a:prstGeom>
+            <a:noFill/>
+          </p:spPr>
+          <p:txBody>
+            <a:bodyPr wrap="square" rtlCol="0" anchor="ctr">
+              <a:spAutoFit/>
+            </a:bodyPr>
+            <a:lstStyle/>
+            <a:p>
+              <a:pPr algn="ctr"/>
+              <a:r>
+                <a:rPr lang="de-DE" i="1" dirty="0">
+                  <a:solidFill>
+                    <a:schemeClr val="accent2">
+                      <a:lumMod val="75000"/>
+                    </a:schemeClr>
+                  </a:solidFill>
+                  <a:latin typeface="CMU Serif" panose="02000603000000000000" pitchFamily="2" charset="0"/>
+                  <a:ea typeface="CMU Serif" panose="02000603000000000000" pitchFamily="2" charset="0"/>
+                  <a:cs typeface="CMU Serif" panose="02000603000000000000" pitchFamily="2" charset="0"/>
+                </a:rPr>
+                <a:t>e</a:t>
+              </a:r>
+              <a:r>
+                <a:rPr lang="de-DE" i="1" baseline="-25000" dirty="0">
+                  <a:solidFill>
+                    <a:schemeClr val="accent2">
+                      <a:lumMod val="75000"/>
+                    </a:schemeClr>
+                  </a:solidFill>
+                  <a:latin typeface="CMU Serif" panose="02000603000000000000" pitchFamily="2" charset="0"/>
+                  <a:ea typeface="CMU Serif" panose="02000603000000000000" pitchFamily="2" charset="0"/>
+                  <a:cs typeface="CMU Serif" panose="02000603000000000000" pitchFamily="2" charset="0"/>
+                </a:rPr>
+                <a:t>r</a:t>
+              </a:r>
+            </a:p>
+          </p:txBody>
+        </p:sp>
+        <p:cxnSp>
+          <p:nvCxnSpPr>
+            <p:cNvPr id="36" name="Gerade Verbindung mit Pfeil 35">
+              <a:extLst>
+                <a:ext uri="{FF2B5EF4-FFF2-40B4-BE49-F238E27FC236}">
+                  <a16:creationId xmlns:a16="http://schemas.microsoft.com/office/drawing/2014/main" id="{76B3DCD9-76BF-44DB-9344-AF18ED5901DD}"/>
+                </a:ext>
+              </a:extLst>
+            </p:cNvPr>
+            <p:cNvCxnSpPr>
+              <a:cxnSpLocks/>
+            </p:cNvCxnSpPr>
+            <p:nvPr/>
+          </p:nvCxnSpPr>
+          <p:spPr>
+            <a:xfrm>
+              <a:off x="2706737" y="1030557"/>
+              <a:ext cx="64532" cy="0"/>
+            </a:xfrm>
+            <a:prstGeom prst="straightConnector1">
+              <a:avLst/>
+            </a:prstGeom>
+            <a:ln w="6350" cap="rnd">
+              <a:solidFill>
+                <a:schemeClr val="accent2">
+                  <a:lumMod val="75000"/>
+                </a:schemeClr>
+              </a:solidFill>
+              <a:round/>
+              <a:headEnd type="none"/>
+              <a:tailEnd type="none"/>
+            </a:ln>
+          </p:spPr>
+          <p:style>
+            <a:lnRef idx="2">
+              <a:schemeClr val="accent1"/>
+            </a:lnRef>
+            <a:fillRef idx="0">
+              <a:schemeClr val="accent1"/>
+            </a:fillRef>
+            <a:effectRef idx="1">
+              <a:schemeClr val="accent1"/>
+            </a:effectRef>
+            <a:fontRef idx="minor">
+              <a:schemeClr val="tx1"/>
+            </a:fontRef>
+          </p:style>
+        </p:cxnSp>
+      </p:grpSp>
+      <p:grpSp>
+        <p:nvGrpSpPr>
+          <p:cNvPr id="19" name="Gruppieren 18">
+            <a:extLst>
+              <a:ext uri="{FF2B5EF4-FFF2-40B4-BE49-F238E27FC236}">
+                <a16:creationId xmlns:a16="http://schemas.microsoft.com/office/drawing/2014/main" id="{E77C57D1-F9B2-2A46-F47F-49000E09F98A}"/>
+              </a:ext>
+            </a:extLst>
+          </p:cNvPr>
+          <p:cNvGrpSpPr/>
+          <p:nvPr/>
+        </p:nvGrpSpPr>
+        <p:grpSpPr>
+          <a:xfrm>
+            <a:off x="2566544" y="1123585"/>
+            <a:ext cx="416102" cy="369332"/>
+            <a:chOff x="2981580" y="636462"/>
+            <a:chExt cx="416102" cy="369332"/>
+          </a:xfrm>
+        </p:grpSpPr>
+        <p:sp>
+          <p:nvSpPr>
+            <p:cNvPr id="33" name="Textfeld 32">
+              <a:extLst>
+                <a:ext uri="{FF2B5EF4-FFF2-40B4-BE49-F238E27FC236}">
+                  <a16:creationId xmlns:a16="http://schemas.microsoft.com/office/drawing/2014/main" id="{8B858ED6-2DBB-3A9C-790A-4D558B7186C9}"/>
+                </a:ext>
+              </a:extLst>
+            </p:cNvPr>
+            <p:cNvSpPr txBox="1"/>
+            <p:nvPr/>
+          </p:nvSpPr>
+          <p:spPr>
+            <a:xfrm>
+              <a:off x="2981580" y="636462"/>
+              <a:ext cx="416102" cy="369332"/>
+            </a:xfrm>
+            <a:prstGeom prst="rect">
+              <a:avLst/>
+            </a:prstGeom>
+            <a:noFill/>
+          </p:spPr>
+          <p:txBody>
+            <a:bodyPr wrap="square" rtlCol="0" anchor="ctr">
+              <a:spAutoFit/>
+            </a:bodyPr>
+            <a:lstStyle/>
+            <a:p>
+              <a:pPr algn="ctr"/>
+              <a:r>
+                <a:rPr lang="de-DE" i="1" dirty="0" err="1">
+                  <a:solidFill>
+                    <a:schemeClr val="accent2">
+                      <a:lumMod val="75000"/>
+                    </a:schemeClr>
+                  </a:solidFill>
+                  <a:latin typeface="CMU Serif" panose="02000603000000000000" pitchFamily="2" charset="0"/>
+                  <a:ea typeface="CMU Serif" panose="02000603000000000000" pitchFamily="2" charset="0"/>
+                  <a:cs typeface="CMU Serif" panose="02000603000000000000" pitchFamily="2" charset="0"/>
+                </a:rPr>
+                <a:t>e</a:t>
+              </a:r>
+              <a:r>
+                <a:rPr lang="de-DE" i="1" baseline="-25000" dirty="0" err="1">
+                  <a:solidFill>
+                    <a:schemeClr val="accent2">
+                      <a:lumMod val="75000"/>
+                    </a:schemeClr>
+                  </a:solidFill>
+                  <a:latin typeface="Latin Modern Math" panose="02000503000000000000" pitchFamily="50" charset="0"/>
+                  <a:ea typeface="Latin Modern Math" panose="02000503000000000000" pitchFamily="50" charset="0"/>
+                  <a:cs typeface="CMU Serif" panose="02000603000000000000" pitchFamily="2" charset="0"/>
+                </a:rPr>
+                <a:t>φ</a:t>
+              </a:r>
+              <a:endParaRPr lang="de-DE" i="1" baseline="-25000" dirty="0">
+                <a:solidFill>
+                  <a:schemeClr val="accent2">
+                    <a:lumMod val="75000"/>
+                  </a:schemeClr>
+                </a:solidFill>
+                <a:latin typeface="Latin Modern Math" panose="02000503000000000000" pitchFamily="50" charset="0"/>
+                <a:ea typeface="Latin Modern Math" panose="02000503000000000000" pitchFamily="50" charset="0"/>
+                <a:cs typeface="CMU Serif" panose="02000603000000000000" pitchFamily="2" charset="0"/>
+              </a:endParaRPr>
+            </a:p>
+          </p:txBody>
+        </p:sp>
+        <p:cxnSp>
+          <p:nvCxnSpPr>
+            <p:cNvPr id="39" name="Gerade Verbindung mit Pfeil 38">
+              <a:extLst>
+                <a:ext uri="{FF2B5EF4-FFF2-40B4-BE49-F238E27FC236}">
+                  <a16:creationId xmlns:a16="http://schemas.microsoft.com/office/drawing/2014/main" id="{53AA06B3-8D36-49B9-45B7-D24881FEA458}"/>
+                </a:ext>
+              </a:extLst>
+            </p:cNvPr>
+            <p:cNvCxnSpPr>
+              <a:cxnSpLocks/>
+            </p:cNvCxnSpPr>
+            <p:nvPr/>
+          </p:nvCxnSpPr>
+          <p:spPr>
+            <a:xfrm>
+              <a:off x="3114873" y="899112"/>
+              <a:ext cx="64532" cy="0"/>
+            </a:xfrm>
+            <a:prstGeom prst="straightConnector1">
+              <a:avLst/>
+            </a:prstGeom>
+            <a:ln w="6350" cap="rnd">
+              <a:solidFill>
+                <a:schemeClr val="accent2">
+                  <a:lumMod val="75000"/>
+                </a:schemeClr>
+              </a:solidFill>
+              <a:round/>
+              <a:headEnd type="none"/>
+              <a:tailEnd type="none"/>
+            </a:ln>
+          </p:spPr>
+          <p:style>
+            <a:lnRef idx="2">
+              <a:schemeClr val="accent1"/>
+            </a:lnRef>
+            <a:fillRef idx="0">
+              <a:schemeClr val="accent1"/>
+            </a:fillRef>
+            <a:effectRef idx="1">
+              <a:schemeClr val="accent1"/>
+            </a:effectRef>
+            <a:fontRef idx="minor">
+              <a:schemeClr val="tx1"/>
+            </a:fontRef>
+          </p:style>
+        </p:cxnSp>
+      </p:grpSp>
+      <p:grpSp>
+        <p:nvGrpSpPr>
+          <p:cNvPr id="21" name="Gruppieren 20">
+            <a:extLst>
+              <a:ext uri="{FF2B5EF4-FFF2-40B4-BE49-F238E27FC236}">
+                <a16:creationId xmlns:a16="http://schemas.microsoft.com/office/drawing/2014/main" id="{E5295FA1-601F-BB1B-D2CC-B82803FD3A8F}"/>
+              </a:ext>
+            </a:extLst>
+          </p:cNvPr>
+          <p:cNvGrpSpPr/>
+          <p:nvPr/>
+        </p:nvGrpSpPr>
+        <p:grpSpPr>
+          <a:xfrm>
+            <a:off x="2134204" y="911327"/>
+            <a:ext cx="416102" cy="369332"/>
+            <a:chOff x="2751245" y="144198"/>
+            <a:chExt cx="416102" cy="369332"/>
+          </a:xfrm>
+        </p:grpSpPr>
+        <p:sp>
+          <p:nvSpPr>
+            <p:cNvPr id="35" name="Textfeld 34">
+              <a:extLst>
+                <a:ext uri="{FF2B5EF4-FFF2-40B4-BE49-F238E27FC236}">
+                  <a16:creationId xmlns:a16="http://schemas.microsoft.com/office/drawing/2014/main" id="{E142B692-749E-0C38-6471-CCEA527D94CD}"/>
+                </a:ext>
+              </a:extLst>
+            </p:cNvPr>
+            <p:cNvSpPr txBox="1"/>
+            <p:nvPr/>
+          </p:nvSpPr>
+          <p:spPr>
+            <a:xfrm>
+              <a:off x="2751245" y="144198"/>
+              <a:ext cx="416102" cy="369332"/>
+            </a:xfrm>
+            <a:prstGeom prst="rect">
+              <a:avLst/>
+            </a:prstGeom>
+            <a:noFill/>
+          </p:spPr>
+          <p:txBody>
+            <a:bodyPr wrap="square" rtlCol="0" anchor="ctr">
+              <a:spAutoFit/>
+            </a:bodyPr>
+            <a:lstStyle/>
+            <a:p>
+              <a:pPr algn="ctr"/>
+              <a:r>
+                <a:rPr lang="de-DE" i="1" dirty="0" err="1">
+                  <a:solidFill>
+                    <a:schemeClr val="accent2">
+                      <a:lumMod val="75000"/>
+                    </a:schemeClr>
+                  </a:solidFill>
+                  <a:latin typeface="CMU Serif" panose="02000603000000000000" pitchFamily="2" charset="0"/>
+                  <a:ea typeface="CMU Serif" panose="02000603000000000000" pitchFamily="2" charset="0"/>
+                  <a:cs typeface="CMU Serif" panose="02000603000000000000" pitchFamily="2" charset="0"/>
+                </a:rPr>
+                <a:t>e</a:t>
+              </a:r>
+              <a:r>
+                <a:rPr lang="de-DE" i="1" baseline="-25000" dirty="0" err="1">
+                  <a:solidFill>
+                    <a:schemeClr val="accent2">
+                      <a:lumMod val="75000"/>
+                    </a:schemeClr>
+                  </a:solidFill>
+                  <a:latin typeface="CMU Serif" panose="02000603000000000000" pitchFamily="2" charset="0"/>
+                  <a:ea typeface="CMU Serif" panose="02000603000000000000" pitchFamily="2" charset="0"/>
+                  <a:cs typeface="CMU Serif" panose="02000603000000000000" pitchFamily="2" charset="0"/>
+                </a:rPr>
+                <a:t>z</a:t>
+              </a:r>
+              <a:endParaRPr lang="de-DE" i="1" baseline="-25000" dirty="0">
+                <a:solidFill>
+                  <a:schemeClr val="accent2">
+                    <a:lumMod val="75000"/>
+                  </a:schemeClr>
+                </a:solidFill>
+                <a:latin typeface="CMU Serif" panose="02000603000000000000" pitchFamily="2" charset="0"/>
+                <a:ea typeface="CMU Serif" panose="02000603000000000000" pitchFamily="2" charset="0"/>
+                <a:cs typeface="CMU Serif" panose="02000603000000000000" pitchFamily="2" charset="0"/>
+              </a:endParaRPr>
+            </a:p>
+          </p:txBody>
+        </p:sp>
+        <p:cxnSp>
+          <p:nvCxnSpPr>
+            <p:cNvPr id="40" name="Gerade Verbindung mit Pfeil 39">
+              <a:extLst>
+                <a:ext uri="{FF2B5EF4-FFF2-40B4-BE49-F238E27FC236}">
+                  <a16:creationId xmlns:a16="http://schemas.microsoft.com/office/drawing/2014/main" id="{7A65D8D0-DD17-2A45-DEB3-DBEFE2623444}"/>
+                </a:ext>
+              </a:extLst>
+            </p:cNvPr>
+            <p:cNvCxnSpPr>
+              <a:cxnSpLocks/>
+            </p:cNvCxnSpPr>
+            <p:nvPr/>
+          </p:nvCxnSpPr>
+          <p:spPr>
+            <a:xfrm>
+              <a:off x="2901808" y="410584"/>
+              <a:ext cx="64532" cy="0"/>
+            </a:xfrm>
+            <a:prstGeom prst="straightConnector1">
+              <a:avLst/>
+            </a:prstGeom>
+            <a:ln w="6350" cap="rnd">
+              <a:solidFill>
+                <a:schemeClr val="accent2">
+                  <a:lumMod val="75000"/>
+                </a:schemeClr>
+              </a:solidFill>
+              <a:round/>
+              <a:headEnd type="none"/>
+              <a:tailEnd type="none"/>
+            </a:ln>
+          </p:spPr>
+          <p:style>
+            <a:lnRef idx="2">
+              <a:schemeClr val="accent1"/>
+            </a:lnRef>
+            <a:fillRef idx="0">
+              <a:schemeClr val="accent1"/>
+            </a:fillRef>
+            <a:effectRef idx="1">
+              <a:schemeClr val="accent1"/>
+            </a:effectRef>
+            <a:fontRef idx="minor">
+              <a:schemeClr val="tx1"/>
+            </a:fontRef>
+          </p:style>
+        </p:cxnSp>
+      </p:grpSp>
+      <p:cxnSp>
+        <p:nvCxnSpPr>
+          <p:cNvPr id="43" name="Gerade Verbindung mit Pfeil 42">
+            <a:extLst>
+              <a:ext uri="{FF2B5EF4-FFF2-40B4-BE49-F238E27FC236}">
+                <a16:creationId xmlns:a16="http://schemas.microsoft.com/office/drawing/2014/main" id="{9E4BBF2B-5B12-D2D1-E5EC-1BD5BE4886D5}"/>
+              </a:ext>
+            </a:extLst>
+          </p:cNvPr>
+          <p:cNvCxnSpPr>
+            <a:cxnSpLocks/>
+          </p:cNvCxnSpPr>
+          <p:nvPr/>
+        </p:nvCxnSpPr>
+        <p:spPr>
+          <a:xfrm>
+            <a:off x="1183640" y="2075180"/>
+            <a:ext cx="1170940" cy="473710"/>
+          </a:xfrm>
+          <a:prstGeom prst="straightConnector1">
+            <a:avLst/>
+          </a:prstGeom>
+          <a:ln cap="rnd">
+            <a:solidFill>
+              <a:schemeClr val="accent5">
+                <a:lumMod val="75000"/>
+              </a:schemeClr>
+            </a:solidFill>
+            <a:round/>
+            <a:tailEnd type="triangle"/>
+          </a:ln>
+        </p:spPr>
+        <p:style>
+          <a:lnRef idx="2">
+            <a:schemeClr val="accent1"/>
+          </a:lnRef>
+          <a:fillRef idx="0">
+            <a:schemeClr val="accent1"/>
+          </a:fillRef>
+          <a:effectRef idx="1">
+            <a:schemeClr val="accent1"/>
+          </a:effectRef>
+          <a:fontRef idx="minor">
+            <a:schemeClr val="tx1"/>
+          </a:fontRef>
+        </p:style>
+      </p:cxnSp>
+      <p:cxnSp>
+        <p:nvCxnSpPr>
+          <p:cNvPr id="45" name="Gerade Verbindung mit Pfeil 44">
+            <a:extLst>
+              <a:ext uri="{FF2B5EF4-FFF2-40B4-BE49-F238E27FC236}">
+                <a16:creationId xmlns:a16="http://schemas.microsoft.com/office/drawing/2014/main" id="{0BED058C-53D1-1F9B-A070-4F96535A517B}"/>
+              </a:ext>
+            </a:extLst>
+          </p:cNvPr>
+          <p:cNvCxnSpPr>
+            <a:cxnSpLocks/>
+          </p:cNvCxnSpPr>
+          <p:nvPr/>
+        </p:nvCxnSpPr>
+        <p:spPr>
+          <a:xfrm flipV="1">
+            <a:off x="2345055" y="1609725"/>
+            <a:ext cx="0" cy="929637"/>
+          </a:xfrm>
+          <a:prstGeom prst="straightConnector1">
+            <a:avLst/>
+          </a:prstGeom>
+          <a:ln cap="rnd">
+            <a:solidFill>
+              <a:schemeClr val="accent5">
+                <a:lumMod val="75000"/>
+              </a:schemeClr>
+            </a:solidFill>
+            <a:round/>
+            <a:tailEnd type="triangle"/>
+          </a:ln>
+        </p:spPr>
+        <p:style>
+          <a:lnRef idx="2">
+            <a:schemeClr val="accent1"/>
+          </a:lnRef>
+          <a:fillRef idx="0">
+            <a:schemeClr val="accent1"/>
+          </a:fillRef>
+          <a:effectRef idx="1">
+            <a:schemeClr val="accent1"/>
+          </a:effectRef>
+          <a:fontRef idx="minor">
+            <a:schemeClr val="tx1"/>
+          </a:fontRef>
+        </p:style>
+      </p:cxnSp>
+      <p:sp>
+        <p:nvSpPr>
+          <p:cNvPr id="48" name="Ellipse 47">
+            <a:extLst>
+              <a:ext uri="{FF2B5EF4-FFF2-40B4-BE49-F238E27FC236}">
+                <a16:creationId xmlns:a16="http://schemas.microsoft.com/office/drawing/2014/main" id="{4824D4FB-C639-5AC0-E333-7233EDC82869}"/>
+              </a:ext>
+            </a:extLst>
+          </p:cNvPr>
+          <p:cNvSpPr/>
+          <p:nvPr/>
+        </p:nvSpPr>
+        <p:spPr>
+          <a:xfrm>
+            <a:off x="2304204" y="1542214"/>
+            <a:ext cx="77892" cy="77892"/>
+          </a:xfrm>
+          <a:prstGeom prst="ellipse">
+            <a:avLst/>
+          </a:prstGeom>
+          <a:solidFill>
+            <a:schemeClr val="accent5">
+              <a:lumMod val="75000"/>
+            </a:schemeClr>
+          </a:solidFill>
+          <a:ln>
+            <a:noFill/>
+          </a:ln>
+        </p:spPr>
+        <p:style>
+          <a:lnRef idx="2">
+            <a:schemeClr val="accent1">
+              <a:shade val="15000"/>
+            </a:schemeClr>
+          </a:lnRef>
+          <a:fillRef idx="1">
+            <a:schemeClr val="accent1"/>
+          </a:fillRef>
+          <a:effectRef idx="0">
+            <a:schemeClr val="accent1"/>
+          </a:effectRef>
+          <a:fontRef idx="minor">
+            <a:schemeClr val="lt1"/>
+          </a:fontRef>
+        </p:style>
+        <p:txBody>
+          <a:bodyPr rtlCol="0" anchor="ctr"/>
+          <a:lstStyle/>
+          <a:p>
+            <a:pPr algn="ctr"/>
+            <a:endParaRPr lang="de-DE"/>
+          </a:p>
+        </p:txBody>
+      </p:sp>
+      <p:sp>
+        <p:nvSpPr>
+          <p:cNvPr id="51" name="Textfeld 50">
+            <a:extLst>
+              <a:ext uri="{FF2B5EF4-FFF2-40B4-BE49-F238E27FC236}">
+                <a16:creationId xmlns:a16="http://schemas.microsoft.com/office/drawing/2014/main" id="{1C3CB345-69B1-12D6-082D-4EADC74E22DE}"/>
+              </a:ext>
+            </a:extLst>
+          </p:cNvPr>
+          <p:cNvSpPr txBox="1"/>
+          <p:nvPr/>
+        </p:nvSpPr>
+        <p:spPr>
+          <a:xfrm>
+            <a:off x="2004325" y="1541924"/>
+            <a:ext cx="317888" cy="369332"/>
+          </a:xfrm>
+          <a:prstGeom prst="rect">
+            <a:avLst/>
+          </a:prstGeom>
+          <a:noFill/>
+        </p:spPr>
+        <p:txBody>
+          <a:bodyPr wrap="square" rtlCol="0" anchor="ctr">
+            <a:spAutoFit/>
+          </a:bodyPr>
+          <a:lstStyle/>
+          <a:p>
+            <a:pPr algn="ctr"/>
+            <a:r>
+              <a:rPr lang="de-DE" i="1" dirty="0">
+                <a:solidFill>
+                  <a:schemeClr val="accent5">
+                    <a:lumMod val="75000"/>
+                  </a:schemeClr>
+                </a:solidFill>
+                <a:latin typeface="CMU Serif" panose="02000603000000000000" pitchFamily="2" charset="0"/>
+                <a:ea typeface="CMU Serif" panose="02000603000000000000" pitchFamily="2" charset="0"/>
+                <a:cs typeface="CMU Serif" panose="02000603000000000000" pitchFamily="2" charset="0"/>
+              </a:rPr>
+              <a:t>P</a:t>
+            </a:r>
+          </a:p>
+        </p:txBody>
+      </p:sp>
+      <p:sp>
+        <p:nvSpPr>
+          <p:cNvPr id="8" name="Bogen 7">
+            <a:extLst>
+              <a:ext uri="{FF2B5EF4-FFF2-40B4-BE49-F238E27FC236}">
+                <a16:creationId xmlns:a16="http://schemas.microsoft.com/office/drawing/2014/main" id="{1590F742-10BB-E20C-4E0C-56C064DC06CA}"/>
+              </a:ext>
+            </a:extLst>
+          </p:cNvPr>
+          <p:cNvSpPr/>
+          <p:nvPr/>
+        </p:nvSpPr>
+        <p:spPr>
+          <a:xfrm>
+            <a:off x="567056" y="1761486"/>
+            <a:ext cx="1233168" cy="626114"/>
+          </a:xfrm>
+          <a:prstGeom prst="arc">
+            <a:avLst>
+              <a:gd name="adj1" fmla="val 1332851"/>
+              <a:gd name="adj2" fmla="val 8117967"/>
+            </a:avLst>
+          </a:prstGeom>
+          <a:ln>
+            <a:solidFill>
+              <a:schemeClr val="accent5">
+                <a:lumMod val="75000"/>
+              </a:schemeClr>
+            </a:solidFill>
+            <a:headEnd type="triangle"/>
+            <a:tailEnd type="triangle"/>
+          </a:ln>
+        </p:spPr>
+        <p:style>
+          <a:lnRef idx="2">
+            <a:schemeClr val="accent1"/>
+          </a:lnRef>
+          <a:fillRef idx="0">
+            <a:schemeClr val="accent1"/>
+          </a:fillRef>
+          <a:effectRef idx="1">
+            <a:schemeClr val="accent1"/>
+          </a:effectRef>
+          <a:fontRef idx="minor">
+            <a:schemeClr val="tx1"/>
+          </a:fontRef>
+        </p:style>
+        <p:txBody>
+          <a:bodyPr rtlCol="0" anchor="ctr"/>
+          <a:lstStyle/>
+          <a:p>
+            <a:pPr algn="ctr"/>
+            <a:endParaRPr lang="de-DE"/>
+          </a:p>
+        </p:txBody>
+      </p:sp>
+      <p:sp>
+        <p:nvSpPr>
+          <p:cNvPr id="12" name="Textfeld 11">
+            <a:extLst>
+              <a:ext uri="{FF2B5EF4-FFF2-40B4-BE49-F238E27FC236}">
+                <a16:creationId xmlns:a16="http://schemas.microsoft.com/office/drawing/2014/main" id="{75CA23E4-5747-9A95-CD74-7094376B54E4}"/>
+              </a:ext>
+            </a:extLst>
+          </p:cNvPr>
+          <p:cNvSpPr txBox="1"/>
+          <p:nvPr/>
+        </p:nvSpPr>
+        <p:spPr>
+          <a:xfrm>
+            <a:off x="2234194" y="2066037"/>
+            <a:ext cx="558658" cy="369332"/>
+          </a:xfrm>
+          <a:prstGeom prst="rect">
+            <a:avLst/>
+          </a:prstGeom>
+          <a:noFill/>
+        </p:spPr>
+        <p:txBody>
+          <a:bodyPr wrap="square" rtlCol="0" anchor="ctr">
+            <a:spAutoFit/>
+          </a:bodyPr>
+          <a:lstStyle/>
+          <a:p>
+            <a:pPr algn="ctr"/>
+            <a:r>
+              <a:rPr lang="de-DE" i="1" dirty="0" err="1">
+                <a:solidFill>
+                  <a:schemeClr val="accent5">
+                    <a:lumMod val="75000"/>
+                  </a:schemeClr>
+                </a:solidFill>
+                <a:latin typeface="CMU Serif" panose="02000603000000000000" pitchFamily="2" charset="0"/>
+                <a:ea typeface="CMU Serif" panose="02000603000000000000" pitchFamily="2" charset="0"/>
+                <a:cs typeface="CMU Serif" panose="02000603000000000000" pitchFamily="2" charset="0"/>
+              </a:rPr>
+              <a:t>z</a:t>
+            </a:r>
+            <a:r>
+              <a:rPr lang="de-DE" i="1" baseline="-25000" dirty="0" err="1">
+                <a:solidFill>
+                  <a:schemeClr val="accent5">
+                    <a:lumMod val="75000"/>
+                  </a:schemeClr>
+                </a:solidFill>
+                <a:latin typeface="CMU Serif" panose="02000603000000000000" pitchFamily="2" charset="0"/>
+                <a:ea typeface="CMU Serif" panose="02000603000000000000" pitchFamily="2" charset="0"/>
+                <a:cs typeface="CMU Serif" panose="02000603000000000000" pitchFamily="2" charset="0"/>
+              </a:rPr>
+              <a:t>P</a:t>
+            </a:r>
+            <a:endParaRPr lang="de-DE" i="1" baseline="-25000" dirty="0">
+              <a:solidFill>
+                <a:schemeClr val="accent5">
+                  <a:lumMod val="75000"/>
+                </a:schemeClr>
+              </a:solidFill>
+              <a:latin typeface="CMU Serif" panose="02000603000000000000" pitchFamily="2" charset="0"/>
+              <a:ea typeface="CMU Serif" panose="02000603000000000000" pitchFamily="2" charset="0"/>
+              <a:cs typeface="CMU Serif" panose="02000603000000000000" pitchFamily="2" charset="0"/>
+            </a:endParaRPr>
+          </a:p>
+        </p:txBody>
+      </p:sp>
+      <p:sp>
+        <p:nvSpPr>
+          <p:cNvPr id="14" name="Textfeld 13">
+            <a:extLst>
+              <a:ext uri="{FF2B5EF4-FFF2-40B4-BE49-F238E27FC236}">
+                <a16:creationId xmlns:a16="http://schemas.microsoft.com/office/drawing/2014/main" id="{3DF24F3D-4FCA-D94C-6721-58405D0F3736}"/>
+              </a:ext>
+            </a:extLst>
+          </p:cNvPr>
+          <p:cNvSpPr txBox="1"/>
+          <p:nvPr/>
+        </p:nvSpPr>
+        <p:spPr>
+          <a:xfrm>
+            <a:off x="1710020" y="2343445"/>
+            <a:ext cx="558658" cy="369332"/>
+          </a:xfrm>
+          <a:prstGeom prst="rect">
+            <a:avLst/>
+          </a:prstGeom>
+          <a:noFill/>
+        </p:spPr>
+        <p:txBody>
+          <a:bodyPr wrap="square" rtlCol="0" anchor="ctr">
+            <a:spAutoFit/>
+          </a:bodyPr>
+          <a:lstStyle/>
+          <a:p>
+            <a:pPr algn="ctr"/>
+            <a:r>
+              <a:rPr lang="de-DE" i="1" dirty="0" err="1">
+                <a:solidFill>
+                  <a:schemeClr val="accent5">
+                    <a:lumMod val="75000"/>
+                  </a:schemeClr>
+                </a:solidFill>
+                <a:latin typeface="CMU Serif" panose="02000603000000000000" pitchFamily="2" charset="0"/>
+                <a:ea typeface="CMU Serif" panose="02000603000000000000" pitchFamily="2" charset="0"/>
+                <a:cs typeface="CMU Serif" panose="02000603000000000000" pitchFamily="2" charset="0"/>
+              </a:rPr>
+              <a:t>r</a:t>
+            </a:r>
+            <a:r>
+              <a:rPr lang="de-DE" i="1" baseline="-25000" dirty="0" err="1">
+                <a:solidFill>
+                  <a:schemeClr val="accent5">
+                    <a:lumMod val="75000"/>
+                  </a:schemeClr>
+                </a:solidFill>
+                <a:latin typeface="CMU Serif" panose="02000603000000000000" pitchFamily="2" charset="0"/>
+                <a:ea typeface="CMU Serif" panose="02000603000000000000" pitchFamily="2" charset="0"/>
+                <a:cs typeface="CMU Serif" panose="02000603000000000000" pitchFamily="2" charset="0"/>
+              </a:rPr>
+              <a:t>P</a:t>
+            </a:r>
+            <a:endParaRPr lang="de-DE" i="1" baseline="-25000" dirty="0">
+              <a:solidFill>
+                <a:schemeClr val="accent5">
+                  <a:lumMod val="75000"/>
+                </a:schemeClr>
+              </a:solidFill>
+              <a:latin typeface="CMU Serif" panose="02000603000000000000" pitchFamily="2" charset="0"/>
+              <a:ea typeface="CMU Serif" panose="02000603000000000000" pitchFamily="2" charset="0"/>
+              <a:cs typeface="CMU Serif" panose="02000603000000000000" pitchFamily="2" charset="0"/>
+            </a:endParaRPr>
+          </a:p>
+        </p:txBody>
+      </p:sp>
+      <p:sp>
+        <p:nvSpPr>
+          <p:cNvPr id="16" name="Textfeld 15">
+            <a:extLst>
+              <a:ext uri="{FF2B5EF4-FFF2-40B4-BE49-F238E27FC236}">
+                <a16:creationId xmlns:a16="http://schemas.microsoft.com/office/drawing/2014/main" id="{0019A17E-C9D2-9D7D-8200-5A30CE02C597}"/>
+              </a:ext>
+            </a:extLst>
+          </p:cNvPr>
+          <p:cNvSpPr txBox="1"/>
+          <p:nvPr/>
+        </p:nvSpPr>
+        <p:spPr>
+          <a:xfrm>
+            <a:off x="1015488" y="2357318"/>
+            <a:ext cx="558658" cy="369332"/>
+          </a:xfrm>
+          <a:prstGeom prst="rect">
+            <a:avLst/>
+          </a:prstGeom>
+          <a:noFill/>
+        </p:spPr>
+        <p:txBody>
+          <a:bodyPr wrap="square" rtlCol="0" anchor="ctr">
+            <a:spAutoFit/>
+          </a:bodyPr>
+          <a:lstStyle/>
+          <a:p>
+            <a:pPr algn="ctr"/>
+            <a:r>
+              <a:rPr lang="de-DE" i="1" dirty="0" err="1">
+                <a:solidFill>
+                  <a:schemeClr val="accent5">
+                    <a:lumMod val="75000"/>
+                  </a:schemeClr>
+                </a:solidFill>
+                <a:latin typeface="Latin Modern Math" panose="02000503000000000000" pitchFamily="50" charset="0"/>
+                <a:ea typeface="Latin Modern Math" panose="02000503000000000000" pitchFamily="50" charset="0"/>
+                <a:cs typeface="CMU Serif" panose="02000603000000000000" pitchFamily="2" charset="0"/>
+              </a:rPr>
+              <a:t>φ</a:t>
+            </a:r>
+            <a:r>
+              <a:rPr lang="de-DE" i="1" baseline="-25000" dirty="0" err="1">
+                <a:solidFill>
+                  <a:schemeClr val="accent5">
+                    <a:lumMod val="75000"/>
+                  </a:schemeClr>
+                </a:solidFill>
+                <a:latin typeface="CMU Serif" panose="02000603000000000000" pitchFamily="2" charset="0"/>
+                <a:ea typeface="CMU Serif" panose="02000603000000000000" pitchFamily="2" charset="0"/>
+                <a:cs typeface="CMU Serif" panose="02000603000000000000" pitchFamily="2" charset="0"/>
+              </a:rPr>
+              <a:t>P</a:t>
+            </a:r>
+            <a:endParaRPr lang="de-DE" i="1" baseline="-25000" dirty="0">
+              <a:solidFill>
+                <a:schemeClr val="accent5">
+                  <a:lumMod val="75000"/>
+                </a:schemeClr>
+              </a:solidFill>
+              <a:latin typeface="CMU Serif" panose="02000603000000000000" pitchFamily="2" charset="0"/>
+              <a:ea typeface="CMU Serif" panose="02000603000000000000" pitchFamily="2" charset="0"/>
+              <a:cs typeface="CMU Serif" panose="02000603000000000000" pitchFamily="2" charset="0"/>
+            </a:endParaRPr>
+          </a:p>
+        </p:txBody>
+      </p:sp>
+      <p:cxnSp>
+        <p:nvCxnSpPr>
+          <p:cNvPr id="26" name="Gerade Verbindung mit Pfeil 25">
+            <a:extLst>
+              <a:ext uri="{FF2B5EF4-FFF2-40B4-BE49-F238E27FC236}">
+                <a16:creationId xmlns:a16="http://schemas.microsoft.com/office/drawing/2014/main" id="{324C3A91-0C3D-A06C-9E31-2FF7188270D8}"/>
+              </a:ext>
+            </a:extLst>
+          </p:cNvPr>
+          <p:cNvCxnSpPr>
+            <a:cxnSpLocks/>
+          </p:cNvCxnSpPr>
+          <p:nvPr/>
+        </p:nvCxnSpPr>
+        <p:spPr>
+          <a:xfrm>
+            <a:off x="1183004" y="1111249"/>
+            <a:ext cx="1170940" cy="473710"/>
+          </a:xfrm>
+          <a:prstGeom prst="straightConnector1">
+            <a:avLst/>
+          </a:prstGeom>
+          <a:ln w="12700" cap="rnd">
+            <a:solidFill>
+              <a:schemeClr val="accent5">
+                <a:lumMod val="75000"/>
+              </a:schemeClr>
+            </a:solidFill>
+            <a:prstDash val="sysDash"/>
+            <a:round/>
+            <a:tailEnd type="none"/>
+          </a:ln>
+        </p:spPr>
+        <p:style>
+          <a:lnRef idx="2">
+            <a:schemeClr val="accent1"/>
+          </a:lnRef>
+          <a:fillRef idx="0">
+            <a:schemeClr val="accent1"/>
+          </a:fillRef>
+          <a:effectRef idx="1">
+            <a:schemeClr val="accent1"/>
+          </a:effectRef>
+          <a:fontRef idx="minor">
+            <a:schemeClr val="tx1"/>
+          </a:fontRef>
+        </p:style>
+      </p:cxnSp>
+    </p:spTree>
+    <p:extLst>
+      <p:ext uri="{BB962C8B-B14F-4D97-AF65-F5344CB8AC3E}">
+        <p14:creationId xmlns:p14="http://schemas.microsoft.com/office/powerpoint/2010/main" val="3508746441"/>
+      </p:ext>
+    </p:extLst>
+  </p:cSld>
+  <p:clrMapOvr>
+    <a:masterClrMapping/>
+  </p:clrMapOvr>
+</p:sld>
+</file>
+
+<file path=ppt/slides/slide3.xml><?xml version="1.0" encoding="utf-8"?>
+<p:sld xmlns:a="http://schemas.openxmlformats.org/drawingml/2006/main" xmlns:r="http://schemas.openxmlformats.org/officeDocument/2006/relationships" xmlns:p="http://schemas.openxmlformats.org/presentationml/2006/main">
+  <p:cSld>
+    <p:spTree>
+      <p:nvGrpSpPr>
+        <p:cNvPr id="1" name="">
+          <a:extLst>
+            <a:ext uri="{FF2B5EF4-FFF2-40B4-BE49-F238E27FC236}">
+              <a16:creationId xmlns:a16="http://schemas.microsoft.com/office/drawing/2014/main" id="{A1E24FC0-CB0D-C88E-04DD-C2B32DBA8211}"/>
+            </a:ext>
+          </a:extLst>
+        </p:cNvPr>
+        <p:cNvGrpSpPr/>
+        <p:nvPr/>
+      </p:nvGrpSpPr>
+      <p:grpSpPr>
+        <a:xfrm>
+          <a:off x="0" y="0"/>
+          <a:ext cx="0" cy="0"/>
+          <a:chOff x="0" y="0"/>
+          <a:chExt cx="0" cy="0"/>
+        </a:xfrm>
+      </p:grpSpPr>
+      <p:cxnSp>
+        <p:nvCxnSpPr>
+          <p:cNvPr id="11" name="Gerade Verbindung mit Pfeil 10">
+            <a:extLst>
+              <a:ext uri="{FF2B5EF4-FFF2-40B4-BE49-F238E27FC236}">
+                <a16:creationId xmlns:a16="http://schemas.microsoft.com/office/drawing/2014/main" id="{2EA23F6E-7E2E-3CA1-0085-00D838C541A8}"/>
+              </a:ext>
+            </a:extLst>
+          </p:cNvPr>
+          <p:cNvCxnSpPr>
+            <a:cxnSpLocks/>
+          </p:cNvCxnSpPr>
+          <p:nvPr/>
+        </p:nvCxnSpPr>
+        <p:spPr>
+          <a:xfrm flipV="1">
+            <a:off x="426720" y="2078831"/>
+            <a:ext cx="757236" cy="757236"/>
+          </a:xfrm>
+          <a:prstGeom prst="straightConnector1">
+            <a:avLst/>
+          </a:prstGeom>
+          <a:ln cap="rnd">
+            <a:solidFill>
+              <a:schemeClr val="tx1"/>
+            </a:solidFill>
+            <a:round/>
+            <a:headEnd type="triangle"/>
+            <a:tailEnd type="none"/>
+          </a:ln>
+        </p:spPr>
+        <p:style>
+          <a:lnRef idx="2">
+            <a:schemeClr val="accent1"/>
+          </a:lnRef>
+          <a:fillRef idx="0">
+            <a:schemeClr val="accent1"/>
+          </a:fillRef>
+          <a:effectRef idx="1">
+            <a:schemeClr val="accent1"/>
+          </a:effectRef>
+          <a:fontRef idx="minor">
+            <a:schemeClr val="tx1"/>
+          </a:fontRef>
+        </p:style>
+      </p:cxnSp>
+      <p:cxnSp>
+        <p:nvCxnSpPr>
+          <p:cNvPr id="6" name="Gerade Verbindung mit Pfeil 5">
+            <a:extLst>
+              <a:ext uri="{FF2B5EF4-FFF2-40B4-BE49-F238E27FC236}">
+                <a16:creationId xmlns:a16="http://schemas.microsoft.com/office/drawing/2014/main" id="{DE68E3DD-AEA8-1C07-A0DE-F120671C1191}"/>
+              </a:ext>
+            </a:extLst>
+          </p:cNvPr>
+          <p:cNvCxnSpPr>
+            <a:cxnSpLocks/>
+          </p:cNvCxnSpPr>
+          <p:nvPr/>
+        </p:nvCxnSpPr>
+        <p:spPr>
+          <a:xfrm flipV="1">
+            <a:off x="1183958" y="639366"/>
+            <a:ext cx="0" cy="1439465"/>
+          </a:xfrm>
+          <a:prstGeom prst="straightConnector1">
+            <a:avLst/>
+          </a:prstGeom>
+          <a:ln cap="rnd">
+            <a:solidFill>
+              <a:schemeClr val="tx1"/>
+            </a:solidFill>
+            <a:round/>
+            <a:tailEnd type="triangle"/>
+          </a:ln>
+        </p:spPr>
+        <p:style>
+          <a:lnRef idx="2">
+            <a:schemeClr val="accent1"/>
+          </a:lnRef>
+          <a:fillRef idx="0">
+            <a:schemeClr val="accent1"/>
+          </a:fillRef>
+          <a:effectRef idx="1">
+            <a:schemeClr val="accent1"/>
+          </a:effectRef>
+          <a:fontRef idx="minor">
+            <a:schemeClr val="tx1"/>
+          </a:fontRef>
+        </p:style>
+      </p:cxnSp>
+      <p:cxnSp>
+        <p:nvCxnSpPr>
+          <p:cNvPr id="7" name="Gerade Verbindung mit Pfeil 6">
+            <a:extLst>
+              <a:ext uri="{FF2B5EF4-FFF2-40B4-BE49-F238E27FC236}">
+                <a16:creationId xmlns:a16="http://schemas.microsoft.com/office/drawing/2014/main" id="{1E2ADA72-F865-DA3D-DB9C-4D3CB86FD0C9}"/>
+              </a:ext>
+            </a:extLst>
+          </p:cNvPr>
+          <p:cNvCxnSpPr>
+            <a:cxnSpLocks/>
+          </p:cNvCxnSpPr>
+          <p:nvPr/>
+        </p:nvCxnSpPr>
+        <p:spPr>
+          <a:xfrm>
+            <a:off x="1183958" y="2078831"/>
+            <a:ext cx="2039540" cy="0"/>
+          </a:xfrm>
+          <a:prstGeom prst="straightConnector1">
+            <a:avLst/>
+          </a:prstGeom>
+          <a:ln cap="rnd">
+            <a:solidFill>
+              <a:schemeClr val="tx1"/>
+            </a:solidFill>
+            <a:round/>
+            <a:tailEnd type="triangle"/>
+          </a:ln>
+        </p:spPr>
+        <p:style>
+          <a:lnRef idx="2">
+            <a:schemeClr val="accent1"/>
+          </a:lnRef>
+          <a:fillRef idx="0">
+            <a:schemeClr val="accent1"/>
+          </a:fillRef>
+          <a:effectRef idx="1">
+            <a:schemeClr val="accent1"/>
+          </a:effectRef>
+          <a:fontRef idx="minor">
+            <a:schemeClr val="tx1"/>
+          </a:fontRef>
+        </p:style>
+      </p:cxnSp>
+      <p:sp>
+        <p:nvSpPr>
+          <p:cNvPr id="20" name="Textfeld 19">
+            <a:extLst>
+              <a:ext uri="{FF2B5EF4-FFF2-40B4-BE49-F238E27FC236}">
+                <a16:creationId xmlns:a16="http://schemas.microsoft.com/office/drawing/2014/main" id="{B873F0DD-9F2C-546D-5066-B3AAF8CF0669}"/>
+              </a:ext>
+            </a:extLst>
+          </p:cNvPr>
+          <p:cNvSpPr txBox="1"/>
+          <p:nvPr/>
+        </p:nvSpPr>
+        <p:spPr>
+          <a:xfrm>
+            <a:off x="1183956" y="454699"/>
+            <a:ext cx="317888" cy="369332"/>
+          </a:xfrm>
+          <a:prstGeom prst="rect">
+            <a:avLst/>
+          </a:prstGeom>
+          <a:noFill/>
+        </p:spPr>
+        <p:txBody>
+          <a:bodyPr wrap="square" rtlCol="0" anchor="ctr">
+            <a:spAutoFit/>
+          </a:bodyPr>
+          <a:lstStyle/>
+          <a:p>
+            <a:pPr algn="ctr"/>
+            <a:r>
+              <a:rPr lang="de-DE" i="1" dirty="0">
+                <a:latin typeface="CMU Serif" panose="02000603000000000000" pitchFamily="2" charset="0"/>
+                <a:ea typeface="CMU Serif" panose="02000603000000000000" pitchFamily="2" charset="0"/>
+                <a:cs typeface="CMU Serif" panose="02000603000000000000" pitchFamily="2" charset="0"/>
+              </a:rPr>
+              <a:t>z</a:t>
+            </a:r>
+          </a:p>
+        </p:txBody>
+      </p:sp>
+      <p:sp>
+        <p:nvSpPr>
+          <p:cNvPr id="22" name="Textfeld 21">
+            <a:extLst>
+              <a:ext uri="{FF2B5EF4-FFF2-40B4-BE49-F238E27FC236}">
+                <a16:creationId xmlns:a16="http://schemas.microsoft.com/office/drawing/2014/main" id="{C681AAFA-C14E-42C9-F77F-D84C705B0CB9}"/>
+              </a:ext>
+            </a:extLst>
+          </p:cNvPr>
+          <p:cNvSpPr txBox="1"/>
+          <p:nvPr/>
+        </p:nvSpPr>
+        <p:spPr>
+          <a:xfrm>
+            <a:off x="3064554" y="2055196"/>
+            <a:ext cx="317888" cy="369332"/>
+          </a:xfrm>
+          <a:prstGeom prst="rect">
+            <a:avLst/>
+          </a:prstGeom>
+          <a:noFill/>
+        </p:spPr>
+        <p:txBody>
+          <a:bodyPr wrap="square" rtlCol="0" anchor="ctr">
+            <a:spAutoFit/>
+          </a:bodyPr>
+          <a:lstStyle/>
+          <a:p>
+            <a:pPr algn="ctr"/>
+            <a:r>
+              <a:rPr lang="de-DE" i="1" dirty="0">
+                <a:latin typeface="CMU Serif" panose="02000603000000000000" pitchFamily="2" charset="0"/>
+                <a:ea typeface="CMU Serif" panose="02000603000000000000" pitchFamily="2" charset="0"/>
+                <a:cs typeface="CMU Serif" panose="02000603000000000000" pitchFamily="2" charset="0"/>
+              </a:rPr>
+              <a:t>y</a:t>
+            </a:r>
+          </a:p>
+        </p:txBody>
+      </p:sp>
+      <p:sp>
+        <p:nvSpPr>
+          <p:cNvPr id="24" name="Textfeld 23">
+            <a:extLst>
+              <a:ext uri="{FF2B5EF4-FFF2-40B4-BE49-F238E27FC236}">
+                <a16:creationId xmlns:a16="http://schemas.microsoft.com/office/drawing/2014/main" id="{58326461-DC68-BECF-7EE3-389D5350FADC}"/>
+              </a:ext>
+            </a:extLst>
+          </p:cNvPr>
+          <p:cNvSpPr txBox="1"/>
+          <p:nvPr/>
+        </p:nvSpPr>
+        <p:spPr>
+          <a:xfrm>
+            <a:off x="502690" y="2635367"/>
+            <a:ext cx="317888" cy="369332"/>
+          </a:xfrm>
+          <a:prstGeom prst="rect">
+            <a:avLst/>
+          </a:prstGeom>
+          <a:noFill/>
+        </p:spPr>
+        <p:txBody>
+          <a:bodyPr wrap="square" rtlCol="0" anchor="ctr">
+            <a:spAutoFit/>
+          </a:bodyPr>
+          <a:lstStyle/>
+          <a:p>
+            <a:pPr algn="ctr"/>
+            <a:r>
+              <a:rPr lang="de-DE" i="1" dirty="0">
+                <a:latin typeface="CMU Serif" panose="02000603000000000000" pitchFamily="2" charset="0"/>
+                <a:ea typeface="CMU Serif" panose="02000603000000000000" pitchFamily="2" charset="0"/>
+                <a:cs typeface="CMU Serif" panose="02000603000000000000" pitchFamily="2" charset="0"/>
+              </a:rPr>
+              <a:t>x</a:t>
+            </a:r>
+          </a:p>
+        </p:txBody>
+      </p:sp>
+      <p:cxnSp>
+        <p:nvCxnSpPr>
+          <p:cNvPr id="25" name="Gerade Verbindung mit Pfeil 24">
+            <a:extLst>
+              <a:ext uri="{FF2B5EF4-FFF2-40B4-BE49-F238E27FC236}">
+                <a16:creationId xmlns:a16="http://schemas.microsoft.com/office/drawing/2014/main" id="{ED5E1C09-638A-CC66-7044-2BC961B45626}"/>
+              </a:ext>
+            </a:extLst>
+          </p:cNvPr>
+          <p:cNvCxnSpPr>
+            <a:cxnSpLocks/>
+          </p:cNvCxnSpPr>
+          <p:nvPr/>
+        </p:nvCxnSpPr>
+        <p:spPr>
+          <a:xfrm flipH="1" flipV="1">
+            <a:off x="2265465" y="1198842"/>
+            <a:ext cx="201510" cy="226098"/>
+          </a:xfrm>
+          <a:prstGeom prst="straightConnector1">
+            <a:avLst/>
+          </a:prstGeom>
+          <a:ln w="25400" cap="rnd">
+            <a:solidFill>
+              <a:schemeClr val="accent2">
+                <a:lumMod val="75000"/>
+              </a:schemeClr>
+            </a:solidFill>
+            <a:round/>
+            <a:headEnd type="triangle"/>
+            <a:tailEnd type="none"/>
+          </a:ln>
+        </p:spPr>
+        <p:style>
+          <a:lnRef idx="2">
+            <a:schemeClr val="accent1"/>
+          </a:lnRef>
+          <a:fillRef idx="0">
+            <a:schemeClr val="accent1"/>
+          </a:fillRef>
+          <a:effectRef idx="1">
+            <a:schemeClr val="accent1"/>
+          </a:effectRef>
+          <a:fontRef idx="minor">
+            <a:schemeClr val="tx1"/>
+          </a:fontRef>
+        </p:style>
+      </p:cxnSp>
+      <p:cxnSp>
+        <p:nvCxnSpPr>
+          <p:cNvPr id="27" name="Gerade Verbindung mit Pfeil 26">
+            <a:extLst>
+              <a:ext uri="{FF2B5EF4-FFF2-40B4-BE49-F238E27FC236}">
+                <a16:creationId xmlns:a16="http://schemas.microsoft.com/office/drawing/2014/main" id="{D950D463-9AE2-168F-ECA5-D300F672987C}"/>
+              </a:ext>
+            </a:extLst>
+          </p:cNvPr>
+          <p:cNvCxnSpPr>
+            <a:cxnSpLocks/>
+          </p:cNvCxnSpPr>
+          <p:nvPr/>
+        </p:nvCxnSpPr>
+        <p:spPr>
+          <a:xfrm flipV="1">
+            <a:off x="2264891" y="997302"/>
+            <a:ext cx="242910" cy="195724"/>
+          </a:xfrm>
+          <a:prstGeom prst="straightConnector1">
+            <a:avLst/>
+          </a:prstGeom>
+          <a:ln w="25400" cap="rnd">
+            <a:solidFill>
+              <a:schemeClr val="accent2">
+                <a:lumMod val="75000"/>
+              </a:schemeClr>
+            </a:solidFill>
+            <a:round/>
+            <a:headEnd type="none"/>
+            <a:tailEnd type="triangle"/>
+          </a:ln>
+        </p:spPr>
+        <p:style>
+          <a:lnRef idx="2">
+            <a:schemeClr val="accent1"/>
+          </a:lnRef>
+          <a:fillRef idx="0">
+            <a:schemeClr val="accent1"/>
+          </a:fillRef>
+          <a:effectRef idx="1">
+            <a:schemeClr val="accent1"/>
+          </a:effectRef>
+          <a:fontRef idx="minor">
+            <a:schemeClr val="tx1"/>
+          </a:fontRef>
+        </p:style>
+      </p:cxnSp>
+      <p:cxnSp>
+        <p:nvCxnSpPr>
+          <p:cNvPr id="29" name="Gerade Verbindung mit Pfeil 28">
+            <a:extLst>
+              <a:ext uri="{FF2B5EF4-FFF2-40B4-BE49-F238E27FC236}">
+                <a16:creationId xmlns:a16="http://schemas.microsoft.com/office/drawing/2014/main" id="{3298D35F-8AAF-C399-18CB-AE054DA81E3E}"/>
+              </a:ext>
+            </a:extLst>
+          </p:cNvPr>
+          <p:cNvCxnSpPr>
+            <a:cxnSpLocks/>
+          </p:cNvCxnSpPr>
+          <p:nvPr/>
+        </p:nvCxnSpPr>
+        <p:spPr>
+          <a:xfrm flipV="1">
+            <a:off x="2263431" y="1091565"/>
+            <a:ext cx="296889" cy="107277"/>
+          </a:xfrm>
+          <a:prstGeom prst="straightConnector1">
+            <a:avLst/>
+          </a:prstGeom>
+          <a:ln w="25400" cap="rnd">
+            <a:solidFill>
+              <a:schemeClr val="accent2">
+                <a:lumMod val="75000"/>
+              </a:schemeClr>
+            </a:solidFill>
+            <a:round/>
+            <a:headEnd type="none"/>
+            <a:tailEnd type="triangle"/>
+          </a:ln>
+        </p:spPr>
+        <p:style>
+          <a:lnRef idx="2">
+            <a:schemeClr val="accent1"/>
+          </a:lnRef>
+          <a:fillRef idx="0">
+            <a:schemeClr val="accent1"/>
+          </a:fillRef>
+          <a:effectRef idx="1">
+            <a:schemeClr val="accent1"/>
+          </a:effectRef>
+          <a:fontRef idx="minor">
+            <a:schemeClr val="tx1"/>
+          </a:fontRef>
+        </p:style>
+      </p:cxnSp>
+      <p:grpSp>
+        <p:nvGrpSpPr>
+          <p:cNvPr id="18" name="Gruppieren 17">
+            <a:extLst>
+              <a:ext uri="{FF2B5EF4-FFF2-40B4-BE49-F238E27FC236}">
+                <a16:creationId xmlns:a16="http://schemas.microsoft.com/office/drawing/2014/main" id="{34205919-06CC-08C5-B918-90C3E64B05F5}"/>
+              </a:ext>
+            </a:extLst>
+          </p:cNvPr>
+          <p:cNvGrpSpPr/>
+          <p:nvPr/>
+        </p:nvGrpSpPr>
+        <p:grpSpPr>
+          <a:xfrm>
+            <a:off x="2336186" y="1322539"/>
+            <a:ext cx="416102" cy="369332"/>
+            <a:chOff x="2564122" y="765199"/>
+            <a:chExt cx="416102" cy="369332"/>
+          </a:xfrm>
+        </p:grpSpPr>
+        <p:sp>
+          <p:nvSpPr>
+            <p:cNvPr id="31" name="Textfeld 30">
+              <a:extLst>
+                <a:ext uri="{FF2B5EF4-FFF2-40B4-BE49-F238E27FC236}">
+                  <a16:creationId xmlns:a16="http://schemas.microsoft.com/office/drawing/2014/main" id="{1554DA27-5727-17A4-EA61-F54462A4DF2C}"/>
+                </a:ext>
+              </a:extLst>
+            </p:cNvPr>
+            <p:cNvSpPr txBox="1"/>
+            <p:nvPr/>
+          </p:nvSpPr>
+          <p:spPr>
+            <a:xfrm>
+              <a:off x="2564122" y="765199"/>
+              <a:ext cx="416102" cy="369332"/>
+            </a:xfrm>
+            <a:prstGeom prst="rect">
+              <a:avLst/>
+            </a:prstGeom>
+            <a:noFill/>
+          </p:spPr>
+          <p:txBody>
+            <a:bodyPr wrap="square" rtlCol="0" anchor="ctr">
+              <a:spAutoFit/>
+            </a:bodyPr>
+            <a:lstStyle/>
+            <a:p>
+              <a:pPr algn="ctr"/>
+              <a:r>
+                <a:rPr lang="de-DE" i="1" dirty="0">
+                  <a:solidFill>
+                    <a:schemeClr val="accent2">
+                      <a:lumMod val="75000"/>
+                    </a:schemeClr>
+                  </a:solidFill>
+                  <a:latin typeface="CMU Serif" panose="02000603000000000000" pitchFamily="2" charset="0"/>
+                  <a:ea typeface="CMU Serif" panose="02000603000000000000" pitchFamily="2" charset="0"/>
+                  <a:cs typeface="CMU Serif" panose="02000603000000000000" pitchFamily="2" charset="0"/>
+                </a:rPr>
+                <a:t>e</a:t>
+              </a:r>
+              <a:r>
+                <a:rPr lang="el-GR" i="1" baseline="-25000" dirty="0">
+                  <a:solidFill>
+                    <a:schemeClr val="accent2">
+                      <a:lumMod val="75000"/>
+                    </a:schemeClr>
+                  </a:solidFill>
+                  <a:latin typeface="CMU Serif" panose="02000603000000000000" pitchFamily="2" charset="0"/>
+                  <a:ea typeface="CMU Serif" panose="02000603000000000000" pitchFamily="2" charset="0"/>
+                  <a:cs typeface="CMU Serif" panose="02000603000000000000" pitchFamily="2" charset="0"/>
+                </a:rPr>
+                <a:t>ϑ</a:t>
+              </a:r>
+              <a:endParaRPr lang="de-DE" i="1" baseline="-25000" dirty="0">
+                <a:solidFill>
+                  <a:schemeClr val="accent2">
+                    <a:lumMod val="75000"/>
+                  </a:schemeClr>
+                </a:solidFill>
+                <a:latin typeface="CMU Serif" panose="02000603000000000000" pitchFamily="2" charset="0"/>
+                <a:ea typeface="CMU Serif" panose="02000603000000000000" pitchFamily="2" charset="0"/>
+                <a:cs typeface="CMU Serif" panose="02000603000000000000" pitchFamily="2" charset="0"/>
+              </a:endParaRPr>
+            </a:p>
+          </p:txBody>
+        </p:sp>
+        <p:cxnSp>
+          <p:nvCxnSpPr>
+            <p:cNvPr id="36" name="Gerade Verbindung mit Pfeil 35">
+              <a:extLst>
+                <a:ext uri="{FF2B5EF4-FFF2-40B4-BE49-F238E27FC236}">
+                  <a16:creationId xmlns:a16="http://schemas.microsoft.com/office/drawing/2014/main" id="{FCEC689C-5DCE-DDF5-D3D3-77025F6AE4C2}"/>
+                </a:ext>
+              </a:extLst>
+            </p:cNvPr>
+            <p:cNvCxnSpPr>
+              <a:cxnSpLocks/>
+            </p:cNvCxnSpPr>
+            <p:nvPr/>
+          </p:nvCxnSpPr>
+          <p:spPr>
+            <a:xfrm>
+              <a:off x="2706737" y="1030557"/>
+              <a:ext cx="64532" cy="0"/>
+            </a:xfrm>
+            <a:prstGeom prst="straightConnector1">
+              <a:avLst/>
+            </a:prstGeom>
+            <a:ln w="6350" cap="rnd">
+              <a:solidFill>
+                <a:schemeClr val="accent2">
+                  <a:lumMod val="75000"/>
+                </a:schemeClr>
+              </a:solidFill>
+              <a:round/>
+              <a:headEnd type="none"/>
+              <a:tailEnd type="none"/>
+            </a:ln>
+          </p:spPr>
+          <p:style>
+            <a:lnRef idx="2">
+              <a:schemeClr val="accent1"/>
+            </a:lnRef>
+            <a:fillRef idx="0">
+              <a:schemeClr val="accent1"/>
+            </a:fillRef>
+            <a:effectRef idx="1">
+              <a:schemeClr val="accent1"/>
+            </a:effectRef>
+            <a:fontRef idx="minor">
+              <a:schemeClr val="tx1"/>
+            </a:fontRef>
+          </p:style>
+        </p:cxnSp>
+      </p:grpSp>
+      <p:grpSp>
+        <p:nvGrpSpPr>
+          <p:cNvPr id="19" name="Gruppieren 18">
+            <a:extLst>
+              <a:ext uri="{FF2B5EF4-FFF2-40B4-BE49-F238E27FC236}">
+                <a16:creationId xmlns:a16="http://schemas.microsoft.com/office/drawing/2014/main" id="{90686A09-3635-EA48-4750-737DFF7D6463}"/>
+              </a:ext>
+            </a:extLst>
+          </p:cNvPr>
+          <p:cNvGrpSpPr/>
+          <p:nvPr/>
+        </p:nvGrpSpPr>
+        <p:grpSpPr>
+          <a:xfrm>
+            <a:off x="2490255" y="901220"/>
+            <a:ext cx="416102" cy="369332"/>
+            <a:chOff x="2981580" y="636462"/>
+            <a:chExt cx="416102" cy="369332"/>
+          </a:xfrm>
+        </p:grpSpPr>
+        <p:sp>
+          <p:nvSpPr>
+            <p:cNvPr id="33" name="Textfeld 32">
+              <a:extLst>
+                <a:ext uri="{FF2B5EF4-FFF2-40B4-BE49-F238E27FC236}">
+                  <a16:creationId xmlns:a16="http://schemas.microsoft.com/office/drawing/2014/main" id="{2861BDFE-D3C3-02CD-CC2F-4A4F5A268973}"/>
+                </a:ext>
+              </a:extLst>
+            </p:cNvPr>
+            <p:cNvSpPr txBox="1"/>
+            <p:nvPr/>
+          </p:nvSpPr>
+          <p:spPr>
+            <a:xfrm>
+              <a:off x="2981580" y="636462"/>
+              <a:ext cx="416102" cy="369332"/>
+            </a:xfrm>
+            <a:prstGeom prst="rect">
+              <a:avLst/>
+            </a:prstGeom>
+            <a:noFill/>
+          </p:spPr>
+          <p:txBody>
+            <a:bodyPr wrap="square" rtlCol="0" anchor="ctr">
+              <a:spAutoFit/>
+            </a:bodyPr>
+            <a:lstStyle/>
+            <a:p>
+              <a:pPr algn="ctr"/>
+              <a:r>
+                <a:rPr lang="de-DE" i="1" dirty="0" err="1">
+                  <a:solidFill>
+                    <a:schemeClr val="accent2">
+                      <a:lumMod val="75000"/>
+                    </a:schemeClr>
+                  </a:solidFill>
+                  <a:latin typeface="CMU Serif" panose="02000603000000000000" pitchFamily="2" charset="0"/>
+                  <a:ea typeface="CMU Serif" panose="02000603000000000000" pitchFamily="2" charset="0"/>
+                  <a:cs typeface="CMU Serif" panose="02000603000000000000" pitchFamily="2" charset="0"/>
+                </a:rPr>
+                <a:t>e</a:t>
+              </a:r>
+              <a:r>
+                <a:rPr lang="de-DE" i="1" baseline="-25000" dirty="0" err="1">
+                  <a:solidFill>
+                    <a:schemeClr val="accent2">
+                      <a:lumMod val="75000"/>
+                    </a:schemeClr>
+                  </a:solidFill>
+                  <a:latin typeface="Latin Modern Math" panose="02000503000000000000" pitchFamily="50" charset="0"/>
+                  <a:ea typeface="Latin Modern Math" panose="02000503000000000000" pitchFamily="50" charset="0"/>
+                  <a:cs typeface="CMU Serif" panose="02000603000000000000" pitchFamily="2" charset="0"/>
+                </a:rPr>
+                <a:t>φ</a:t>
+              </a:r>
+              <a:endParaRPr lang="de-DE" i="1" baseline="-25000" dirty="0">
+                <a:solidFill>
+                  <a:schemeClr val="accent2">
+                    <a:lumMod val="75000"/>
+                  </a:schemeClr>
+                </a:solidFill>
+                <a:latin typeface="Latin Modern Math" panose="02000503000000000000" pitchFamily="50" charset="0"/>
+                <a:ea typeface="Latin Modern Math" panose="02000503000000000000" pitchFamily="50" charset="0"/>
+                <a:cs typeface="CMU Serif" panose="02000603000000000000" pitchFamily="2" charset="0"/>
+              </a:endParaRPr>
+            </a:p>
+          </p:txBody>
+        </p:sp>
+        <p:cxnSp>
+          <p:nvCxnSpPr>
+            <p:cNvPr id="39" name="Gerade Verbindung mit Pfeil 38">
+              <a:extLst>
+                <a:ext uri="{FF2B5EF4-FFF2-40B4-BE49-F238E27FC236}">
+                  <a16:creationId xmlns:a16="http://schemas.microsoft.com/office/drawing/2014/main" id="{02E17160-797B-5AAE-4CAE-D25AE13BE813}"/>
+                </a:ext>
+              </a:extLst>
+            </p:cNvPr>
+            <p:cNvCxnSpPr>
+              <a:cxnSpLocks/>
+            </p:cNvCxnSpPr>
+            <p:nvPr/>
+          </p:nvCxnSpPr>
+          <p:spPr>
+            <a:xfrm>
+              <a:off x="3114873" y="899112"/>
+              <a:ext cx="64532" cy="0"/>
+            </a:xfrm>
+            <a:prstGeom prst="straightConnector1">
+              <a:avLst/>
+            </a:prstGeom>
+            <a:ln w="6350" cap="rnd">
+              <a:solidFill>
+                <a:schemeClr val="accent2">
+                  <a:lumMod val="75000"/>
+                </a:schemeClr>
+              </a:solidFill>
+              <a:round/>
+              <a:headEnd type="none"/>
+              <a:tailEnd type="none"/>
+            </a:ln>
+          </p:spPr>
+          <p:style>
+            <a:lnRef idx="2">
+              <a:schemeClr val="accent1"/>
+            </a:lnRef>
+            <a:fillRef idx="0">
+              <a:schemeClr val="accent1"/>
+            </a:fillRef>
+            <a:effectRef idx="1">
+              <a:schemeClr val="accent1"/>
+            </a:effectRef>
+            <a:fontRef idx="minor">
+              <a:schemeClr val="tx1"/>
+            </a:fontRef>
+          </p:style>
+        </p:cxnSp>
+      </p:grpSp>
+      <p:grpSp>
+        <p:nvGrpSpPr>
+          <p:cNvPr id="21" name="Gruppieren 20">
+            <a:extLst>
+              <a:ext uri="{FF2B5EF4-FFF2-40B4-BE49-F238E27FC236}">
+                <a16:creationId xmlns:a16="http://schemas.microsoft.com/office/drawing/2014/main" id="{F6D8AD88-68D3-DD29-EFAC-B8641D0CA1FE}"/>
+              </a:ext>
+            </a:extLst>
+          </p:cNvPr>
+          <p:cNvGrpSpPr/>
+          <p:nvPr/>
+        </p:nvGrpSpPr>
+        <p:grpSpPr>
+          <a:xfrm>
+            <a:off x="2323030" y="664567"/>
+            <a:ext cx="416102" cy="369332"/>
+            <a:chOff x="2751245" y="144198"/>
+            <a:chExt cx="416102" cy="369332"/>
+          </a:xfrm>
+        </p:grpSpPr>
+        <p:sp>
+          <p:nvSpPr>
+            <p:cNvPr id="35" name="Textfeld 34">
+              <a:extLst>
+                <a:ext uri="{FF2B5EF4-FFF2-40B4-BE49-F238E27FC236}">
+                  <a16:creationId xmlns:a16="http://schemas.microsoft.com/office/drawing/2014/main" id="{D294715F-BCFD-7F09-3F30-EB19EE651165}"/>
+                </a:ext>
+              </a:extLst>
+            </p:cNvPr>
+            <p:cNvSpPr txBox="1"/>
+            <p:nvPr/>
+          </p:nvSpPr>
+          <p:spPr>
+            <a:xfrm>
+              <a:off x="2751245" y="144198"/>
+              <a:ext cx="416102" cy="369332"/>
+            </a:xfrm>
+            <a:prstGeom prst="rect">
+              <a:avLst/>
+            </a:prstGeom>
+            <a:noFill/>
+          </p:spPr>
+          <p:txBody>
+            <a:bodyPr wrap="square" rtlCol="0" anchor="ctr">
+              <a:spAutoFit/>
+            </a:bodyPr>
+            <a:lstStyle/>
+            <a:p>
+              <a:pPr algn="ctr"/>
+              <a:r>
+                <a:rPr lang="de-DE" i="1" dirty="0">
+                  <a:solidFill>
+                    <a:schemeClr val="accent2">
+                      <a:lumMod val="75000"/>
+                    </a:schemeClr>
+                  </a:solidFill>
+                  <a:latin typeface="CMU Serif" panose="02000603000000000000" pitchFamily="2" charset="0"/>
+                  <a:ea typeface="CMU Serif" panose="02000603000000000000" pitchFamily="2" charset="0"/>
+                  <a:cs typeface="CMU Serif" panose="02000603000000000000" pitchFamily="2" charset="0"/>
+                </a:rPr>
+                <a:t>e</a:t>
+              </a:r>
+              <a:r>
+                <a:rPr lang="de-DE" i="1" baseline="-25000" dirty="0">
+                  <a:solidFill>
+                    <a:schemeClr val="accent2">
+                      <a:lumMod val="75000"/>
+                    </a:schemeClr>
+                  </a:solidFill>
+                  <a:latin typeface="CMU Serif" panose="02000603000000000000" pitchFamily="2" charset="0"/>
+                  <a:ea typeface="CMU Serif" panose="02000603000000000000" pitchFamily="2" charset="0"/>
+                  <a:cs typeface="CMU Serif" panose="02000603000000000000" pitchFamily="2" charset="0"/>
+                </a:rPr>
+                <a:t>r</a:t>
+              </a:r>
+            </a:p>
+          </p:txBody>
+        </p:sp>
+        <p:cxnSp>
+          <p:nvCxnSpPr>
+            <p:cNvPr id="40" name="Gerade Verbindung mit Pfeil 39">
+              <a:extLst>
+                <a:ext uri="{FF2B5EF4-FFF2-40B4-BE49-F238E27FC236}">
+                  <a16:creationId xmlns:a16="http://schemas.microsoft.com/office/drawing/2014/main" id="{CC8DAE07-DCF8-7CAC-DA8B-4E134D9737C9}"/>
+                </a:ext>
+              </a:extLst>
+            </p:cNvPr>
+            <p:cNvCxnSpPr>
+              <a:cxnSpLocks/>
+            </p:cNvCxnSpPr>
+            <p:nvPr/>
+          </p:nvCxnSpPr>
+          <p:spPr>
+            <a:xfrm>
+              <a:off x="2901808" y="410584"/>
+              <a:ext cx="64532" cy="0"/>
+            </a:xfrm>
+            <a:prstGeom prst="straightConnector1">
+              <a:avLst/>
+            </a:prstGeom>
+            <a:ln w="6350" cap="rnd">
+              <a:solidFill>
+                <a:schemeClr val="accent2">
+                  <a:lumMod val="75000"/>
+                </a:schemeClr>
+              </a:solidFill>
+              <a:round/>
+              <a:headEnd type="none"/>
+              <a:tailEnd type="none"/>
+            </a:ln>
+          </p:spPr>
+          <p:style>
+            <a:lnRef idx="2">
+              <a:schemeClr val="accent1"/>
+            </a:lnRef>
+            <a:fillRef idx="0">
+              <a:schemeClr val="accent1"/>
+            </a:fillRef>
+            <a:effectRef idx="1">
+              <a:schemeClr val="accent1"/>
+            </a:effectRef>
+            <a:fontRef idx="minor">
+              <a:schemeClr val="tx1"/>
+            </a:fontRef>
+          </p:style>
+        </p:cxnSp>
+      </p:grpSp>
+      <p:cxnSp>
+        <p:nvCxnSpPr>
+          <p:cNvPr id="43" name="Gerade Verbindung mit Pfeil 42">
+            <a:extLst>
+              <a:ext uri="{FF2B5EF4-FFF2-40B4-BE49-F238E27FC236}">
+                <a16:creationId xmlns:a16="http://schemas.microsoft.com/office/drawing/2014/main" id="{1A64220E-8D30-BAF7-BB5B-C936BF4AEC35}"/>
+              </a:ext>
+            </a:extLst>
+          </p:cNvPr>
+          <p:cNvCxnSpPr>
+            <a:cxnSpLocks/>
+          </p:cNvCxnSpPr>
+          <p:nvPr/>
+        </p:nvCxnSpPr>
+        <p:spPr>
+          <a:xfrm>
+            <a:off x="1183640" y="2075180"/>
+            <a:ext cx="1078438" cy="436288"/>
+          </a:xfrm>
+          <a:prstGeom prst="straightConnector1">
+            <a:avLst/>
+          </a:prstGeom>
+          <a:ln w="12700" cap="rnd">
+            <a:solidFill>
+              <a:schemeClr val="accent5">
+                <a:lumMod val="75000"/>
+              </a:schemeClr>
+            </a:solidFill>
+            <a:prstDash val="sysDash"/>
+            <a:round/>
+            <a:tailEnd type="none"/>
+          </a:ln>
+        </p:spPr>
+        <p:style>
+          <a:lnRef idx="2">
+            <a:schemeClr val="accent1"/>
+          </a:lnRef>
+          <a:fillRef idx="0">
+            <a:schemeClr val="accent1"/>
+          </a:fillRef>
+          <a:effectRef idx="1">
+            <a:schemeClr val="accent1"/>
+          </a:effectRef>
+          <a:fontRef idx="minor">
+            <a:schemeClr val="tx1"/>
+          </a:fontRef>
+        </p:style>
+      </p:cxnSp>
+      <p:cxnSp>
+        <p:nvCxnSpPr>
+          <p:cNvPr id="45" name="Gerade Verbindung mit Pfeil 44">
+            <a:extLst>
+              <a:ext uri="{FF2B5EF4-FFF2-40B4-BE49-F238E27FC236}">
+                <a16:creationId xmlns:a16="http://schemas.microsoft.com/office/drawing/2014/main" id="{CA5E373E-F674-6F99-BF71-649ECD375B52}"/>
+              </a:ext>
+            </a:extLst>
+          </p:cNvPr>
+          <p:cNvCxnSpPr>
+            <a:cxnSpLocks/>
+          </p:cNvCxnSpPr>
+          <p:nvPr/>
+        </p:nvCxnSpPr>
+        <p:spPr>
+          <a:xfrm flipV="1">
+            <a:off x="2265546" y="1239610"/>
+            <a:ext cx="0" cy="1268727"/>
+          </a:xfrm>
+          <a:prstGeom prst="straightConnector1">
+            <a:avLst/>
+          </a:prstGeom>
+          <a:ln w="12700" cap="rnd">
+            <a:solidFill>
+              <a:schemeClr val="accent5">
+                <a:lumMod val="75000"/>
+              </a:schemeClr>
+            </a:solidFill>
+            <a:prstDash val="sysDash"/>
+            <a:round/>
+            <a:tailEnd type="none"/>
+          </a:ln>
+        </p:spPr>
+        <p:style>
+          <a:lnRef idx="2">
+            <a:schemeClr val="accent1"/>
+          </a:lnRef>
+          <a:fillRef idx="0">
+            <a:schemeClr val="accent1"/>
+          </a:fillRef>
+          <a:effectRef idx="1">
+            <a:schemeClr val="accent1"/>
+          </a:effectRef>
+          <a:fontRef idx="minor">
+            <a:schemeClr val="tx1"/>
+          </a:fontRef>
+        </p:style>
+      </p:cxnSp>
+      <p:sp>
+        <p:nvSpPr>
+          <p:cNvPr id="48" name="Ellipse 47">
+            <a:extLst>
+              <a:ext uri="{FF2B5EF4-FFF2-40B4-BE49-F238E27FC236}">
+                <a16:creationId xmlns:a16="http://schemas.microsoft.com/office/drawing/2014/main" id="{641AF1FD-3363-6C19-3348-1B8C6ACEE2B4}"/>
+              </a:ext>
+            </a:extLst>
+          </p:cNvPr>
+          <p:cNvSpPr/>
+          <p:nvPr/>
+        </p:nvSpPr>
+        <p:spPr>
+          <a:xfrm>
+            <a:off x="2225380" y="1161718"/>
+            <a:ext cx="77892" cy="77892"/>
+          </a:xfrm>
+          <a:prstGeom prst="ellipse">
+            <a:avLst/>
+          </a:prstGeom>
+          <a:solidFill>
+            <a:schemeClr val="accent5">
+              <a:lumMod val="75000"/>
+            </a:schemeClr>
+          </a:solidFill>
+          <a:ln>
+            <a:noFill/>
+          </a:ln>
+        </p:spPr>
+        <p:style>
+          <a:lnRef idx="2">
+            <a:schemeClr val="accent1">
+              <a:shade val="15000"/>
+            </a:schemeClr>
+          </a:lnRef>
+          <a:fillRef idx="1">
+            <a:schemeClr val="accent1"/>
+          </a:fillRef>
+          <a:effectRef idx="0">
+            <a:schemeClr val="accent1"/>
+          </a:effectRef>
+          <a:fontRef idx="minor">
+            <a:schemeClr val="lt1"/>
+          </a:fontRef>
+        </p:style>
+        <p:txBody>
+          <a:bodyPr rtlCol="0" anchor="ctr"/>
+          <a:lstStyle/>
+          <a:p>
+            <a:pPr algn="ctr"/>
+            <a:endParaRPr lang="de-DE"/>
+          </a:p>
+        </p:txBody>
+      </p:sp>
+      <p:sp>
+        <p:nvSpPr>
+          <p:cNvPr id="51" name="Textfeld 50">
+            <a:extLst>
+              <a:ext uri="{FF2B5EF4-FFF2-40B4-BE49-F238E27FC236}">
+                <a16:creationId xmlns:a16="http://schemas.microsoft.com/office/drawing/2014/main" id="{317BEE9C-7BEE-5C69-884C-06AC02FF9584}"/>
+              </a:ext>
+            </a:extLst>
+          </p:cNvPr>
+          <p:cNvSpPr txBox="1"/>
+          <p:nvPr/>
+        </p:nvSpPr>
+        <p:spPr>
+          <a:xfrm>
+            <a:off x="1944526" y="903814"/>
+            <a:ext cx="317888" cy="369332"/>
+          </a:xfrm>
+          <a:prstGeom prst="rect">
+            <a:avLst/>
+          </a:prstGeom>
+          <a:noFill/>
+        </p:spPr>
+        <p:txBody>
+          <a:bodyPr wrap="square" rtlCol="0" anchor="ctr">
+            <a:spAutoFit/>
+          </a:bodyPr>
+          <a:lstStyle/>
+          <a:p>
+            <a:pPr algn="ctr"/>
+            <a:r>
+              <a:rPr lang="de-DE" i="1" dirty="0">
+                <a:solidFill>
+                  <a:schemeClr val="accent5">
+                    <a:lumMod val="75000"/>
+                  </a:schemeClr>
+                </a:solidFill>
+                <a:latin typeface="CMU Serif" panose="02000603000000000000" pitchFamily="2" charset="0"/>
+                <a:ea typeface="CMU Serif" panose="02000603000000000000" pitchFamily="2" charset="0"/>
+                <a:cs typeface="CMU Serif" panose="02000603000000000000" pitchFamily="2" charset="0"/>
+              </a:rPr>
+              <a:t>P</a:t>
+            </a:r>
+          </a:p>
+        </p:txBody>
+      </p:sp>
+      <p:sp>
+        <p:nvSpPr>
+          <p:cNvPr id="8" name="Bogen 7">
+            <a:extLst>
+              <a:ext uri="{FF2B5EF4-FFF2-40B4-BE49-F238E27FC236}">
+                <a16:creationId xmlns:a16="http://schemas.microsoft.com/office/drawing/2014/main" id="{E30B2FDC-E866-C811-1716-7336B17E350C}"/>
+              </a:ext>
+            </a:extLst>
+          </p:cNvPr>
+          <p:cNvSpPr/>
+          <p:nvPr/>
+        </p:nvSpPr>
+        <p:spPr>
+          <a:xfrm>
+            <a:off x="567056" y="1761486"/>
+            <a:ext cx="1233168" cy="626114"/>
+          </a:xfrm>
+          <a:prstGeom prst="arc">
+            <a:avLst>
+              <a:gd name="adj1" fmla="val 1332851"/>
+              <a:gd name="adj2" fmla="val 8117967"/>
+            </a:avLst>
+          </a:prstGeom>
+          <a:ln>
+            <a:solidFill>
+              <a:schemeClr val="accent5">
+                <a:lumMod val="75000"/>
+              </a:schemeClr>
+            </a:solidFill>
+            <a:headEnd type="triangle"/>
+            <a:tailEnd type="triangle"/>
+          </a:ln>
+        </p:spPr>
+        <p:style>
+          <a:lnRef idx="2">
+            <a:schemeClr val="accent1"/>
+          </a:lnRef>
+          <a:fillRef idx="0">
+            <a:schemeClr val="accent1"/>
+          </a:fillRef>
+          <a:effectRef idx="1">
+            <a:schemeClr val="accent1"/>
+          </a:effectRef>
+          <a:fontRef idx="minor">
+            <a:schemeClr val="tx1"/>
+          </a:fontRef>
+        </p:style>
+        <p:txBody>
+          <a:bodyPr rtlCol="0" anchor="ctr"/>
+          <a:lstStyle/>
+          <a:p>
+            <a:pPr algn="ctr"/>
+            <a:endParaRPr lang="de-DE"/>
+          </a:p>
+        </p:txBody>
+      </p:sp>
+      <p:sp>
+        <p:nvSpPr>
+          <p:cNvPr id="14" name="Textfeld 13">
+            <a:extLst>
+              <a:ext uri="{FF2B5EF4-FFF2-40B4-BE49-F238E27FC236}">
+                <a16:creationId xmlns:a16="http://schemas.microsoft.com/office/drawing/2014/main" id="{947186EE-1194-2EC4-160E-660BA9B3ABB8}"/>
+              </a:ext>
+            </a:extLst>
+          </p:cNvPr>
+          <p:cNvSpPr txBox="1"/>
+          <p:nvPr/>
+        </p:nvSpPr>
+        <p:spPr>
+          <a:xfrm>
+            <a:off x="1609073" y="1494526"/>
+            <a:ext cx="558658" cy="369332"/>
+          </a:xfrm>
+          <a:prstGeom prst="rect">
+            <a:avLst/>
+          </a:prstGeom>
+          <a:noFill/>
+        </p:spPr>
+        <p:txBody>
+          <a:bodyPr wrap="square" rtlCol="0" anchor="ctr">
+            <a:spAutoFit/>
+          </a:bodyPr>
+          <a:lstStyle/>
+          <a:p>
+            <a:pPr algn="ctr"/>
+            <a:r>
+              <a:rPr lang="de-DE" i="1" dirty="0" err="1">
+                <a:solidFill>
+                  <a:schemeClr val="accent5">
+                    <a:lumMod val="75000"/>
+                  </a:schemeClr>
+                </a:solidFill>
+                <a:latin typeface="CMU Serif" panose="02000603000000000000" pitchFamily="2" charset="0"/>
+                <a:ea typeface="CMU Serif" panose="02000603000000000000" pitchFamily="2" charset="0"/>
+                <a:cs typeface="CMU Serif" panose="02000603000000000000" pitchFamily="2" charset="0"/>
+              </a:rPr>
+              <a:t>r</a:t>
+            </a:r>
+            <a:r>
+              <a:rPr lang="de-DE" i="1" baseline="-25000" dirty="0" err="1">
+                <a:solidFill>
+                  <a:schemeClr val="accent5">
+                    <a:lumMod val="75000"/>
+                  </a:schemeClr>
+                </a:solidFill>
+                <a:latin typeface="CMU Serif" panose="02000603000000000000" pitchFamily="2" charset="0"/>
+                <a:ea typeface="CMU Serif" panose="02000603000000000000" pitchFamily="2" charset="0"/>
+                <a:cs typeface="CMU Serif" panose="02000603000000000000" pitchFamily="2" charset="0"/>
+              </a:rPr>
+              <a:t>P</a:t>
+            </a:r>
+            <a:endParaRPr lang="de-DE" i="1" baseline="-25000" dirty="0">
+              <a:solidFill>
+                <a:schemeClr val="accent5">
+                  <a:lumMod val="75000"/>
+                </a:schemeClr>
+              </a:solidFill>
+              <a:latin typeface="CMU Serif" panose="02000603000000000000" pitchFamily="2" charset="0"/>
+              <a:ea typeface="CMU Serif" panose="02000603000000000000" pitchFamily="2" charset="0"/>
+              <a:cs typeface="CMU Serif" panose="02000603000000000000" pitchFamily="2" charset="0"/>
+            </a:endParaRPr>
+          </a:p>
+        </p:txBody>
+      </p:sp>
+      <p:sp>
+        <p:nvSpPr>
+          <p:cNvPr id="16" name="Textfeld 15">
+            <a:extLst>
+              <a:ext uri="{FF2B5EF4-FFF2-40B4-BE49-F238E27FC236}">
+                <a16:creationId xmlns:a16="http://schemas.microsoft.com/office/drawing/2014/main" id="{45A3DA0F-B6A6-B717-BABC-F29B32A70F63}"/>
+              </a:ext>
+            </a:extLst>
+          </p:cNvPr>
+          <p:cNvSpPr txBox="1"/>
+          <p:nvPr/>
+        </p:nvSpPr>
+        <p:spPr>
+          <a:xfrm>
+            <a:off x="1015488" y="2357318"/>
+            <a:ext cx="558658" cy="369332"/>
+          </a:xfrm>
+          <a:prstGeom prst="rect">
+            <a:avLst/>
+          </a:prstGeom>
+          <a:noFill/>
+        </p:spPr>
+        <p:txBody>
+          <a:bodyPr wrap="square" rtlCol="0" anchor="ctr">
+            <a:spAutoFit/>
+          </a:bodyPr>
+          <a:lstStyle/>
+          <a:p>
+            <a:pPr algn="ctr"/>
+            <a:r>
+              <a:rPr lang="de-DE" i="1" dirty="0" err="1">
+                <a:solidFill>
+                  <a:schemeClr val="accent5">
+                    <a:lumMod val="75000"/>
+                  </a:schemeClr>
+                </a:solidFill>
+                <a:latin typeface="Latin Modern Math" panose="02000503000000000000" pitchFamily="50" charset="0"/>
+                <a:ea typeface="Latin Modern Math" panose="02000503000000000000" pitchFamily="50" charset="0"/>
+                <a:cs typeface="CMU Serif" panose="02000603000000000000" pitchFamily="2" charset="0"/>
+              </a:rPr>
+              <a:t>φ</a:t>
+            </a:r>
+            <a:r>
+              <a:rPr lang="de-DE" i="1" baseline="-25000" dirty="0" err="1">
+                <a:solidFill>
+                  <a:schemeClr val="accent5">
+                    <a:lumMod val="75000"/>
+                  </a:schemeClr>
+                </a:solidFill>
+                <a:latin typeface="CMU Serif" panose="02000603000000000000" pitchFamily="2" charset="0"/>
+                <a:ea typeface="CMU Serif" panose="02000603000000000000" pitchFamily="2" charset="0"/>
+                <a:cs typeface="CMU Serif" panose="02000603000000000000" pitchFamily="2" charset="0"/>
+              </a:rPr>
+              <a:t>P</a:t>
+            </a:r>
+            <a:endParaRPr lang="de-DE" i="1" baseline="-25000" dirty="0">
+              <a:solidFill>
+                <a:schemeClr val="accent5">
+                  <a:lumMod val="75000"/>
+                </a:schemeClr>
+              </a:solidFill>
+              <a:latin typeface="CMU Serif" panose="02000603000000000000" pitchFamily="2" charset="0"/>
+              <a:ea typeface="CMU Serif" panose="02000603000000000000" pitchFamily="2" charset="0"/>
+              <a:cs typeface="CMU Serif" panose="02000603000000000000" pitchFamily="2" charset="0"/>
+            </a:endParaRPr>
+          </a:p>
+        </p:txBody>
+      </p:sp>
+      <p:cxnSp>
+        <p:nvCxnSpPr>
+          <p:cNvPr id="26" name="Gerade Verbindung mit Pfeil 25">
+            <a:extLst>
+              <a:ext uri="{FF2B5EF4-FFF2-40B4-BE49-F238E27FC236}">
+                <a16:creationId xmlns:a16="http://schemas.microsoft.com/office/drawing/2014/main" id="{47BD4782-8C9C-714E-4909-56319848B585}"/>
+              </a:ext>
+            </a:extLst>
+          </p:cNvPr>
+          <p:cNvCxnSpPr>
+            <a:cxnSpLocks/>
+          </p:cNvCxnSpPr>
+          <p:nvPr/>
+        </p:nvCxnSpPr>
+        <p:spPr>
+          <a:xfrm flipV="1">
+            <a:off x="1183640" y="1219200"/>
+            <a:ext cx="1058545" cy="855980"/>
+          </a:xfrm>
+          <a:prstGeom prst="straightConnector1">
+            <a:avLst/>
+          </a:prstGeom>
+          <a:ln w="19050" cap="rnd">
+            <a:solidFill>
+              <a:schemeClr val="accent5">
+                <a:lumMod val="75000"/>
+              </a:schemeClr>
+            </a:solidFill>
+            <a:prstDash val="solid"/>
+            <a:round/>
+            <a:tailEnd type="triangle"/>
+          </a:ln>
+        </p:spPr>
+        <p:style>
+          <a:lnRef idx="2">
+            <a:schemeClr val="accent1"/>
+          </a:lnRef>
+          <a:fillRef idx="0">
+            <a:schemeClr val="accent1"/>
+          </a:fillRef>
+          <a:effectRef idx="1">
+            <a:schemeClr val="accent1"/>
+          </a:effectRef>
+          <a:fontRef idx="minor">
+            <a:schemeClr val="tx1"/>
+          </a:fontRef>
+        </p:style>
+      </p:cxnSp>
+      <p:sp>
+        <p:nvSpPr>
+          <p:cNvPr id="13" name="Bogen 12">
+            <a:extLst>
+              <a:ext uri="{FF2B5EF4-FFF2-40B4-BE49-F238E27FC236}">
+                <a16:creationId xmlns:a16="http://schemas.microsoft.com/office/drawing/2014/main" id="{71CC4B2C-0478-F131-48EC-B8BD7EB2799F}"/>
+              </a:ext>
+            </a:extLst>
+          </p:cNvPr>
+          <p:cNvSpPr/>
+          <p:nvPr/>
+        </p:nvSpPr>
+        <p:spPr>
+          <a:xfrm rot="5400000">
+            <a:off x="660366" y="1710389"/>
+            <a:ext cx="1045542" cy="732458"/>
+          </a:xfrm>
+          <a:prstGeom prst="arc">
+            <a:avLst>
+              <a:gd name="adj1" fmla="val 10775411"/>
+              <a:gd name="adj2" fmla="val 13856626"/>
+            </a:avLst>
+          </a:prstGeom>
+          <a:ln>
+            <a:solidFill>
+              <a:schemeClr val="accent5">
+                <a:lumMod val="75000"/>
+              </a:schemeClr>
+            </a:solidFill>
+            <a:headEnd type="triangle"/>
+            <a:tailEnd type="triangle"/>
+          </a:ln>
+        </p:spPr>
+        <p:style>
+          <a:lnRef idx="2">
+            <a:schemeClr val="accent1"/>
+          </a:lnRef>
+          <a:fillRef idx="0">
+            <a:schemeClr val="accent1"/>
+          </a:fillRef>
+          <a:effectRef idx="1">
+            <a:schemeClr val="accent1"/>
+          </a:effectRef>
+          <a:fontRef idx="minor">
+            <a:schemeClr val="tx1"/>
+          </a:fontRef>
+        </p:style>
+        <p:txBody>
+          <a:bodyPr rtlCol="0" anchor="ctr"/>
+          <a:lstStyle/>
+          <a:p>
+            <a:pPr algn="ctr"/>
+            <a:endParaRPr lang="de-DE"/>
+          </a:p>
+        </p:txBody>
+      </p:sp>
+      <p:sp>
+        <p:nvSpPr>
+          <p:cNvPr id="17" name="Textfeld 16">
+            <a:extLst>
+              <a:ext uri="{FF2B5EF4-FFF2-40B4-BE49-F238E27FC236}">
+                <a16:creationId xmlns:a16="http://schemas.microsoft.com/office/drawing/2014/main" id="{513336BC-A5B6-97A7-9E39-1244BCFCB9D7}"/>
+              </a:ext>
+            </a:extLst>
+          </p:cNvPr>
+          <p:cNvSpPr txBox="1"/>
+          <p:nvPr/>
+        </p:nvSpPr>
+        <p:spPr>
+          <a:xfrm>
+            <a:off x="1145915" y="1331353"/>
+            <a:ext cx="558658" cy="369332"/>
+          </a:xfrm>
+          <a:prstGeom prst="rect">
+            <a:avLst/>
+          </a:prstGeom>
+          <a:noFill/>
+        </p:spPr>
+        <p:txBody>
+          <a:bodyPr wrap="square" rtlCol="0" anchor="ctr">
+            <a:spAutoFit/>
+          </a:bodyPr>
+          <a:lstStyle/>
+          <a:p>
+            <a:pPr algn="ctr"/>
+            <a:r>
+              <a:rPr lang="el-GR" i="1" dirty="0">
+                <a:solidFill>
+                  <a:schemeClr val="accent5">
+                    <a:lumMod val="75000"/>
+                  </a:schemeClr>
+                </a:solidFill>
+                <a:latin typeface="Latin Modern Math" panose="02000503000000000000" pitchFamily="50" charset="0"/>
+                <a:ea typeface="Latin Modern Math" panose="02000503000000000000" pitchFamily="50" charset="0"/>
+                <a:cs typeface="CMU Serif" panose="02000603000000000000" pitchFamily="2" charset="0"/>
+              </a:rPr>
+              <a:t>ϑ</a:t>
+            </a:r>
+            <a:r>
+              <a:rPr lang="de-DE" i="1" baseline="-25000" dirty="0">
+                <a:solidFill>
+                  <a:schemeClr val="accent5">
+                    <a:lumMod val="75000"/>
+                  </a:schemeClr>
+                </a:solidFill>
+                <a:latin typeface="CMU Serif" panose="02000603000000000000" pitchFamily="2" charset="0"/>
+                <a:ea typeface="CMU Serif" panose="02000603000000000000" pitchFamily="2" charset="0"/>
+                <a:cs typeface="CMU Serif" panose="02000603000000000000" pitchFamily="2" charset="0"/>
+              </a:rPr>
+              <a:t>P</a:t>
+            </a:r>
+          </a:p>
+        </p:txBody>
+      </p:sp>
+    </p:spTree>
+    <p:extLst>
+      <p:ext uri="{BB962C8B-B14F-4D97-AF65-F5344CB8AC3E}">
+        <p14:creationId xmlns:p14="http://schemas.microsoft.com/office/powerpoint/2010/main" val="2287680251"/>
+      </p:ext>
+    </p:extLst>
+  </p:cSld>
+  <p:clrMapOvr>
+    <a:masterClrMapping/>
+  </p:clrMapOvr>
+</p:sld>
+</file>
+
+<file path=ppt/slides/slide4.xml><?xml version="1.0" encoding="utf-8"?>
 <p:sld xmlns:a="http://schemas.openxmlformats.org/drawingml/2006/main" xmlns:r="http://schemas.openxmlformats.org/officeDocument/2006/relationships" xmlns:p="http://schemas.openxmlformats.org/presentationml/2006/main">
   <p:cSld>
     <p:spTree>

</xml_diff>

<commit_message>
finished chapter Grundlagen in SL1
</commit_message>
<xml_diff>
--- a/LaTeX B.Sc. LRT/Strömungslehre 1/images/SL1-Images.pptx
+++ b/LaTeX B.Sc. LRT/Strömungslehre 1/images/SL1-Images.pptx
@@ -9,6 +9,7 @@
     <p:sldId id="258" r:id="rId3"/>
     <p:sldId id="259" r:id="rId4"/>
     <p:sldId id="257" r:id="rId5"/>
+    <p:sldId id="260" r:id="rId6"/>
   </p:sldIdLst>
   <p:sldSz cx="3600450" cy="3600450"/>
   <p:notesSz cx="6858000" cy="9144000"/>
@@ -246,7 +247,7 @@
           <a:p>
             <a:fld id="{0F04D7A0-D8C8-4B74-9611-9A000801FA36}" type="datetimeFigureOut">
               <a:rPr lang="de-DE" smtClean="0"/>
-              <a:t>06.09.2026</a:t>
+              <a:t>08.09.2026</a:t>
             </a:fld>
             <a:endParaRPr lang="de-DE"/>
           </a:p>
@@ -416,7 +417,7 @@
           <a:p>
             <a:fld id="{0F04D7A0-D8C8-4B74-9611-9A000801FA36}" type="datetimeFigureOut">
               <a:rPr lang="de-DE" smtClean="0"/>
-              <a:t>06.09.2026</a:t>
+              <a:t>08.09.2026</a:t>
             </a:fld>
             <a:endParaRPr lang="de-DE"/>
           </a:p>
@@ -596,7 +597,7 @@
           <a:p>
             <a:fld id="{0F04D7A0-D8C8-4B74-9611-9A000801FA36}" type="datetimeFigureOut">
               <a:rPr lang="de-DE" smtClean="0"/>
-              <a:t>06.09.2026</a:t>
+              <a:t>08.09.2026</a:t>
             </a:fld>
             <a:endParaRPr lang="de-DE"/>
           </a:p>
@@ -766,7 +767,7 @@
           <a:p>
             <a:fld id="{0F04D7A0-D8C8-4B74-9611-9A000801FA36}" type="datetimeFigureOut">
               <a:rPr lang="de-DE" smtClean="0"/>
-              <a:t>06.09.2026</a:t>
+              <a:t>08.09.2026</a:t>
             </a:fld>
             <a:endParaRPr lang="de-DE"/>
           </a:p>
@@ -1012,7 +1013,7 @@
           <a:p>
             <a:fld id="{0F04D7A0-D8C8-4B74-9611-9A000801FA36}" type="datetimeFigureOut">
               <a:rPr lang="de-DE" smtClean="0"/>
-              <a:t>06.09.2026</a:t>
+              <a:t>08.09.2026</a:t>
             </a:fld>
             <a:endParaRPr lang="de-DE"/>
           </a:p>
@@ -1244,7 +1245,7 @@
           <a:p>
             <a:fld id="{0F04D7A0-D8C8-4B74-9611-9A000801FA36}" type="datetimeFigureOut">
               <a:rPr lang="de-DE" smtClean="0"/>
-              <a:t>06.09.2026</a:t>
+              <a:t>08.09.2026</a:t>
             </a:fld>
             <a:endParaRPr lang="de-DE"/>
           </a:p>
@@ -1611,7 +1612,7 @@
           <a:p>
             <a:fld id="{0F04D7A0-D8C8-4B74-9611-9A000801FA36}" type="datetimeFigureOut">
               <a:rPr lang="de-DE" smtClean="0"/>
-              <a:t>06.09.2026</a:t>
+              <a:t>08.09.2026</a:t>
             </a:fld>
             <a:endParaRPr lang="de-DE"/>
           </a:p>
@@ -1729,7 +1730,7 @@
           <a:p>
             <a:fld id="{0F04D7A0-D8C8-4B74-9611-9A000801FA36}" type="datetimeFigureOut">
               <a:rPr lang="de-DE" smtClean="0"/>
-              <a:t>06.09.2026</a:t>
+              <a:t>08.09.2026</a:t>
             </a:fld>
             <a:endParaRPr lang="de-DE"/>
           </a:p>
@@ -1824,7 +1825,7 @@
           <a:p>
             <a:fld id="{0F04D7A0-D8C8-4B74-9611-9A000801FA36}" type="datetimeFigureOut">
               <a:rPr lang="de-DE" smtClean="0"/>
-              <a:t>06.09.2026</a:t>
+              <a:t>08.09.2026</a:t>
             </a:fld>
             <a:endParaRPr lang="de-DE"/>
           </a:p>
@@ -2101,7 +2102,7 @@
           <a:p>
             <a:fld id="{0F04D7A0-D8C8-4B74-9611-9A000801FA36}" type="datetimeFigureOut">
               <a:rPr lang="de-DE" smtClean="0"/>
-              <a:t>06.09.2026</a:t>
+              <a:t>08.09.2026</a:t>
             </a:fld>
             <a:endParaRPr lang="de-DE"/>
           </a:p>
@@ -2358,7 +2359,7 @@
           <a:p>
             <a:fld id="{0F04D7A0-D8C8-4B74-9611-9A000801FA36}" type="datetimeFigureOut">
               <a:rPr lang="de-DE" smtClean="0"/>
-              <a:t>06.09.2026</a:t>
+              <a:t>08.09.2026</a:t>
             </a:fld>
             <a:endParaRPr lang="de-DE"/>
           </a:p>
@@ -2571,7 +2572,7 @@
           <a:p>
             <a:fld id="{0F04D7A0-D8C8-4B74-9611-9A000801FA36}" type="datetimeFigureOut">
               <a:rPr lang="de-DE" smtClean="0"/>
-              <a:t>06.09.2026</a:t>
+              <a:t>08.09.2026</a:t>
             </a:fld>
             <a:endParaRPr lang="de-DE"/>
           </a:p>
@@ -6779,10 +6780,1124 @@
           <a:chExt cx="0" cy="0"/>
         </a:xfrm>
       </p:grpSpPr>
+      <p:cxnSp>
+        <p:nvCxnSpPr>
+          <p:cNvPr id="3" name="Gerade Verbindung mit Pfeil 2">
+            <a:extLst>
+              <a:ext uri="{FF2B5EF4-FFF2-40B4-BE49-F238E27FC236}">
+                <a16:creationId xmlns:a16="http://schemas.microsoft.com/office/drawing/2014/main" id="{786FB748-6542-5BE0-C45B-50BA2F299F1D}"/>
+              </a:ext>
+            </a:extLst>
+          </p:cNvPr>
+          <p:cNvCxnSpPr/>
+          <p:nvPr/>
+        </p:nvCxnSpPr>
+        <p:spPr>
+          <a:xfrm flipV="1">
+            <a:off x="442913" y="582216"/>
+            <a:ext cx="0" cy="2528887"/>
+          </a:xfrm>
+          <a:prstGeom prst="straightConnector1">
+            <a:avLst/>
+          </a:prstGeom>
+          <a:ln cap="rnd">
+            <a:solidFill>
+              <a:schemeClr val="tx1"/>
+            </a:solidFill>
+            <a:round/>
+            <a:tailEnd type="triangle"/>
+          </a:ln>
+        </p:spPr>
+        <p:style>
+          <a:lnRef idx="2">
+            <a:schemeClr val="accent1"/>
+          </a:lnRef>
+          <a:fillRef idx="0">
+            <a:schemeClr val="accent1"/>
+          </a:fillRef>
+          <a:effectRef idx="1">
+            <a:schemeClr val="accent1"/>
+          </a:effectRef>
+          <a:fontRef idx="minor">
+            <a:schemeClr val="tx1"/>
+          </a:fontRef>
+        </p:style>
+      </p:cxnSp>
+      <p:cxnSp>
+        <p:nvCxnSpPr>
+          <p:cNvPr id="4" name="Gerade Verbindung mit Pfeil 3">
+            <a:extLst>
+              <a:ext uri="{FF2B5EF4-FFF2-40B4-BE49-F238E27FC236}">
+                <a16:creationId xmlns:a16="http://schemas.microsoft.com/office/drawing/2014/main" id="{992FBAEA-5AE5-90CD-FE04-79A3BE8CC28F}"/>
+              </a:ext>
+            </a:extLst>
+          </p:cNvPr>
+          <p:cNvCxnSpPr>
+            <a:cxnSpLocks/>
+          </p:cNvCxnSpPr>
+          <p:nvPr/>
+        </p:nvCxnSpPr>
+        <p:spPr>
+          <a:xfrm rot="5400000" flipV="1">
+            <a:off x="1707358" y="1846660"/>
+            <a:ext cx="0" cy="2528887"/>
+          </a:xfrm>
+          <a:prstGeom prst="straightConnector1">
+            <a:avLst/>
+          </a:prstGeom>
+          <a:ln cap="rnd">
+            <a:solidFill>
+              <a:schemeClr val="tx1"/>
+            </a:solidFill>
+            <a:round/>
+            <a:tailEnd type="triangle"/>
+          </a:ln>
+        </p:spPr>
+        <p:style>
+          <a:lnRef idx="2">
+            <a:schemeClr val="accent1"/>
+          </a:lnRef>
+          <a:fillRef idx="0">
+            <a:schemeClr val="accent1"/>
+          </a:fillRef>
+          <a:effectRef idx="1">
+            <a:schemeClr val="accent1"/>
+          </a:effectRef>
+          <a:fontRef idx="minor">
+            <a:schemeClr val="tx1"/>
+          </a:fontRef>
+        </p:style>
+      </p:cxnSp>
+      <p:sp>
+        <p:nvSpPr>
+          <p:cNvPr id="6" name="Textfeld 5">
+            <a:extLst>
+              <a:ext uri="{FF2B5EF4-FFF2-40B4-BE49-F238E27FC236}">
+                <a16:creationId xmlns:a16="http://schemas.microsoft.com/office/drawing/2014/main" id="{8B99B377-4578-8ACA-DE19-5DB032388E03}"/>
+              </a:ext>
+            </a:extLst>
+          </p:cNvPr>
+          <p:cNvSpPr txBox="1"/>
+          <p:nvPr/>
+        </p:nvSpPr>
+        <p:spPr>
+          <a:xfrm>
+            <a:off x="91924" y="582216"/>
+            <a:ext cx="317888" cy="369332"/>
+          </a:xfrm>
+          <a:prstGeom prst="rect">
+            <a:avLst/>
+          </a:prstGeom>
+          <a:noFill/>
+        </p:spPr>
+        <p:txBody>
+          <a:bodyPr wrap="square" rtlCol="0" anchor="ctr">
+            <a:spAutoFit/>
+          </a:bodyPr>
+          <a:lstStyle/>
+          <a:p>
+            <a:pPr algn="ctr"/>
+            <a:r>
+              <a:rPr lang="de-DE" i="1" dirty="0">
+                <a:latin typeface="CMU Serif" panose="02000603000000000000" pitchFamily="2" charset="0"/>
+                <a:ea typeface="CMU Serif" panose="02000603000000000000" pitchFamily="2" charset="0"/>
+                <a:cs typeface="CMU Serif" panose="02000603000000000000" pitchFamily="2" charset="0"/>
+              </a:rPr>
+              <a:t>p</a:t>
+            </a:r>
+          </a:p>
+        </p:txBody>
+      </p:sp>
+      <p:sp>
+        <p:nvSpPr>
+          <p:cNvPr id="8" name="Textfeld 7">
+            <a:extLst>
+              <a:ext uri="{FF2B5EF4-FFF2-40B4-BE49-F238E27FC236}">
+                <a16:creationId xmlns:a16="http://schemas.microsoft.com/office/drawing/2014/main" id="{B2F8FD64-1C59-A8E8-3CE7-389109263076}"/>
+              </a:ext>
+            </a:extLst>
+          </p:cNvPr>
+          <p:cNvSpPr txBox="1"/>
+          <p:nvPr/>
+        </p:nvSpPr>
+        <p:spPr>
+          <a:xfrm>
+            <a:off x="2998592" y="2926437"/>
+            <a:ext cx="317888" cy="369332"/>
+          </a:xfrm>
+          <a:prstGeom prst="rect">
+            <a:avLst/>
+          </a:prstGeom>
+          <a:noFill/>
+        </p:spPr>
+        <p:txBody>
+          <a:bodyPr wrap="square" rtlCol="0" anchor="ctr">
+            <a:spAutoFit/>
+          </a:bodyPr>
+          <a:lstStyle/>
+          <a:p>
+            <a:pPr algn="ctr"/>
+            <a:r>
+              <a:rPr lang="de-DE" i="1" dirty="0">
+                <a:latin typeface="CMU Serif" panose="02000603000000000000" pitchFamily="2" charset="0"/>
+                <a:ea typeface="CMU Serif" panose="02000603000000000000" pitchFamily="2" charset="0"/>
+                <a:cs typeface="CMU Serif" panose="02000603000000000000" pitchFamily="2" charset="0"/>
+              </a:rPr>
+              <a:t>v</a:t>
+            </a:r>
+          </a:p>
+        </p:txBody>
+      </p:sp>
+      <p:cxnSp>
+        <p:nvCxnSpPr>
+          <p:cNvPr id="9" name="Gerade Verbindung mit Pfeil 8">
+            <a:extLst>
+              <a:ext uri="{FF2B5EF4-FFF2-40B4-BE49-F238E27FC236}">
+                <a16:creationId xmlns:a16="http://schemas.microsoft.com/office/drawing/2014/main" id="{9044FC24-9D30-02C3-87DD-389238368828}"/>
+              </a:ext>
+            </a:extLst>
+          </p:cNvPr>
+          <p:cNvCxnSpPr>
+            <a:cxnSpLocks/>
+          </p:cNvCxnSpPr>
+          <p:nvPr/>
+        </p:nvCxnSpPr>
+        <p:spPr>
+          <a:xfrm flipV="1">
+            <a:off x="1678188" y="859213"/>
+            <a:ext cx="0" cy="1974889"/>
+          </a:xfrm>
+          <a:prstGeom prst="straightConnector1">
+            <a:avLst/>
+          </a:prstGeom>
+          <a:ln w="15875" cap="rnd">
+            <a:solidFill>
+              <a:schemeClr val="tx1"/>
+            </a:solidFill>
+            <a:round/>
+            <a:tailEnd type="none"/>
+          </a:ln>
+        </p:spPr>
+        <p:style>
+          <a:lnRef idx="2">
+            <a:schemeClr val="accent1"/>
+          </a:lnRef>
+          <a:fillRef idx="0">
+            <a:schemeClr val="accent1"/>
+          </a:fillRef>
+          <a:effectRef idx="1">
+            <a:schemeClr val="accent1"/>
+          </a:effectRef>
+          <a:fontRef idx="minor">
+            <a:schemeClr val="tx1"/>
+          </a:fontRef>
+        </p:style>
+      </p:cxnSp>
+      <p:cxnSp>
+        <p:nvCxnSpPr>
+          <p:cNvPr id="11" name="Gerade Verbindung mit Pfeil 10">
+            <a:extLst>
+              <a:ext uri="{FF2B5EF4-FFF2-40B4-BE49-F238E27FC236}">
+                <a16:creationId xmlns:a16="http://schemas.microsoft.com/office/drawing/2014/main" id="{9BEB614E-A4FF-D563-16F0-C209AE4ABDA3}"/>
+              </a:ext>
+            </a:extLst>
+          </p:cNvPr>
+          <p:cNvCxnSpPr>
+            <a:cxnSpLocks/>
+          </p:cNvCxnSpPr>
+          <p:nvPr/>
+        </p:nvCxnSpPr>
+        <p:spPr>
+          <a:xfrm>
+            <a:off x="597696" y="1846658"/>
+            <a:ext cx="2170507" cy="0"/>
+          </a:xfrm>
+          <a:prstGeom prst="straightConnector1">
+            <a:avLst/>
+          </a:prstGeom>
+          <a:ln w="15875" cap="rnd">
+            <a:solidFill>
+              <a:srgbClr val="0070C0"/>
+            </a:solidFill>
+            <a:round/>
+            <a:tailEnd type="none"/>
+          </a:ln>
+        </p:spPr>
+        <p:style>
+          <a:lnRef idx="2">
+            <a:schemeClr val="accent1"/>
+          </a:lnRef>
+          <a:fillRef idx="0">
+            <a:schemeClr val="accent1"/>
+          </a:fillRef>
+          <a:effectRef idx="1">
+            <a:schemeClr val="accent1"/>
+          </a:effectRef>
+          <a:fontRef idx="minor">
+            <a:schemeClr val="tx1"/>
+          </a:fontRef>
+        </p:style>
+      </p:cxnSp>
+      <p:sp>
+        <p:nvSpPr>
+          <p:cNvPr id="15" name="Freihandform: Form 14">
+            <a:extLst>
+              <a:ext uri="{FF2B5EF4-FFF2-40B4-BE49-F238E27FC236}">
+                <a16:creationId xmlns:a16="http://schemas.microsoft.com/office/drawing/2014/main" id="{163E971B-3212-5CC0-95E8-D7EF53388FB6}"/>
+              </a:ext>
+            </a:extLst>
+          </p:cNvPr>
+          <p:cNvSpPr/>
+          <p:nvPr/>
+        </p:nvSpPr>
+        <p:spPr>
+          <a:xfrm>
+            <a:off x="1296591" y="867965"/>
+            <a:ext cx="1471612" cy="1568054"/>
+          </a:xfrm>
+          <a:custGeom>
+            <a:avLst/>
+            <a:gdLst>
+              <a:gd name="csX0" fmla="*/ 0 w 1471612"/>
+              <a:gd name="csY0" fmla="*/ 0 h 1568054"/>
+              <a:gd name="csX1" fmla="*/ 385762 w 1471612"/>
+              <a:gd name="csY1" fmla="*/ 982265 h 1568054"/>
+              <a:gd name="csX2" fmla="*/ 1471612 w 1471612"/>
+              <a:gd name="csY2" fmla="*/ 1568054 h 1568054"/>
+            </a:gdLst>
+            <a:ahLst/>
+            <a:cxnLst>
+              <a:cxn ang="0">
+                <a:pos x="csX0" y="csY0"/>
+              </a:cxn>
+              <a:cxn ang="0">
+                <a:pos x="csX1" y="csY1"/>
+              </a:cxn>
+              <a:cxn ang="0">
+                <a:pos x="csX2" y="csY2"/>
+              </a:cxn>
+            </a:cxnLst>
+            <a:rect l="l" t="t" r="r" b="b"/>
+            <a:pathLst>
+              <a:path w="1471612" h="1568054">
+                <a:moveTo>
+                  <a:pt x="0" y="0"/>
+                </a:moveTo>
+                <a:cubicBezTo>
+                  <a:pt x="31849" y="254496"/>
+                  <a:pt x="138707" y="662582"/>
+                  <a:pt x="385762" y="982265"/>
+                </a:cubicBezTo>
+                <a:cubicBezTo>
+                  <a:pt x="632817" y="1301948"/>
+                  <a:pt x="1116211" y="1488877"/>
+                  <a:pt x="1471612" y="1568054"/>
+                </a:cubicBezTo>
+              </a:path>
+            </a:pathLst>
+          </a:custGeom>
+          <a:noFill/>
+          <a:ln w="15875" cap="rnd">
+            <a:solidFill>
+              <a:srgbClr val="FFC000"/>
+            </a:solidFill>
+            <a:round/>
+          </a:ln>
+        </p:spPr>
+        <p:style>
+          <a:lnRef idx="2">
+            <a:schemeClr val="accent1">
+              <a:shade val="15000"/>
+            </a:schemeClr>
+          </a:lnRef>
+          <a:fillRef idx="1">
+            <a:schemeClr val="accent1"/>
+          </a:fillRef>
+          <a:effectRef idx="0">
+            <a:schemeClr val="accent1"/>
+          </a:effectRef>
+          <a:fontRef idx="minor">
+            <a:schemeClr val="lt1"/>
+          </a:fontRef>
+        </p:style>
+        <p:txBody>
+          <a:bodyPr rtlCol="0" anchor="ctr"/>
+          <a:lstStyle/>
+          <a:p>
+            <a:pPr algn="ctr"/>
+            <a:endParaRPr lang="de-DE"/>
+          </a:p>
+        </p:txBody>
+      </p:sp>
+      <p:sp>
+        <p:nvSpPr>
+          <p:cNvPr id="17" name="Freihandform: Form 16">
+            <a:extLst>
+              <a:ext uri="{FF2B5EF4-FFF2-40B4-BE49-F238E27FC236}">
+                <a16:creationId xmlns:a16="http://schemas.microsoft.com/office/drawing/2014/main" id="{1F2DC713-9D3E-8DD1-7D55-A97A6E82F75E}"/>
+              </a:ext>
+            </a:extLst>
+          </p:cNvPr>
+          <p:cNvSpPr/>
+          <p:nvPr/>
+        </p:nvSpPr>
+        <p:spPr>
+          <a:xfrm>
+            <a:off x="1042988" y="871714"/>
+            <a:ext cx="1725215" cy="1410890"/>
+          </a:xfrm>
+          <a:custGeom>
+            <a:avLst/>
+            <a:gdLst>
+              <a:gd name="csX0" fmla="*/ 0 w 1725215"/>
+              <a:gd name="csY0" fmla="*/ 0 h 1410890"/>
+              <a:gd name="csX1" fmla="*/ 646509 w 1725215"/>
+              <a:gd name="csY1" fmla="*/ 985836 h 1410890"/>
+              <a:gd name="csX2" fmla="*/ 1725215 w 1725215"/>
+              <a:gd name="csY2" fmla="*/ 1410890 h 1410890"/>
+            </a:gdLst>
+            <a:ahLst/>
+            <a:cxnLst>
+              <a:cxn ang="0">
+                <a:pos x="csX0" y="csY0"/>
+              </a:cxn>
+              <a:cxn ang="0">
+                <a:pos x="csX1" y="csY1"/>
+              </a:cxn>
+              <a:cxn ang="0">
+                <a:pos x="csX2" y="csY2"/>
+              </a:cxn>
+            </a:cxnLst>
+            <a:rect l="l" t="t" r="r" b="b"/>
+            <a:pathLst>
+              <a:path w="1725215" h="1410890">
+                <a:moveTo>
+                  <a:pt x="0" y="0"/>
+                </a:moveTo>
+                <a:cubicBezTo>
+                  <a:pt x="103287" y="308074"/>
+                  <a:pt x="358973" y="750688"/>
+                  <a:pt x="646509" y="985836"/>
+                </a:cubicBezTo>
+                <a:cubicBezTo>
+                  <a:pt x="934045" y="1220984"/>
+                  <a:pt x="1409104" y="1371004"/>
+                  <a:pt x="1725215" y="1410890"/>
+                </a:cubicBezTo>
+              </a:path>
+            </a:pathLst>
+          </a:custGeom>
+          <a:noFill/>
+          <a:ln w="15875" cap="rnd">
+            <a:solidFill>
+              <a:schemeClr val="accent6"/>
+            </a:solidFill>
+            <a:round/>
+          </a:ln>
+        </p:spPr>
+        <p:style>
+          <a:lnRef idx="2">
+            <a:schemeClr val="accent1">
+              <a:shade val="15000"/>
+            </a:schemeClr>
+          </a:lnRef>
+          <a:fillRef idx="1">
+            <a:schemeClr val="accent1"/>
+          </a:fillRef>
+          <a:effectRef idx="0">
+            <a:schemeClr val="accent1"/>
+          </a:effectRef>
+          <a:fontRef idx="minor">
+            <a:schemeClr val="lt1"/>
+          </a:fontRef>
+        </p:style>
+        <p:txBody>
+          <a:bodyPr rtlCol="0" anchor="ctr"/>
+          <a:lstStyle/>
+          <a:p>
+            <a:pPr algn="ctr"/>
+            <a:endParaRPr lang="de-DE"/>
+          </a:p>
+        </p:txBody>
+      </p:sp>
+      <p:sp>
+        <p:nvSpPr>
+          <p:cNvPr id="19" name="Freihandform: Form 18">
+            <a:extLst>
+              <a:ext uri="{FF2B5EF4-FFF2-40B4-BE49-F238E27FC236}">
+                <a16:creationId xmlns:a16="http://schemas.microsoft.com/office/drawing/2014/main" id="{5C392C91-09C6-61F0-3635-8543ADE3B582}"/>
+              </a:ext>
+            </a:extLst>
+          </p:cNvPr>
+          <p:cNvSpPr/>
+          <p:nvPr/>
+        </p:nvSpPr>
+        <p:spPr>
+          <a:xfrm>
+            <a:off x="596503" y="1067990"/>
+            <a:ext cx="2168128" cy="1053703"/>
+          </a:xfrm>
+          <a:custGeom>
+            <a:avLst/>
+            <a:gdLst>
+              <a:gd name="csX0" fmla="*/ 0 w 2168128"/>
+              <a:gd name="csY0" fmla="*/ 0 h 1053703"/>
+              <a:gd name="csX1" fmla="*/ 1082278 w 2168128"/>
+              <a:gd name="csY1" fmla="*/ 782239 h 1053703"/>
+              <a:gd name="csX2" fmla="*/ 2168128 w 2168128"/>
+              <a:gd name="csY2" fmla="*/ 1053703 h 1053703"/>
+            </a:gdLst>
+            <a:ahLst/>
+            <a:cxnLst>
+              <a:cxn ang="0">
+                <a:pos x="csX0" y="csY0"/>
+              </a:cxn>
+              <a:cxn ang="0">
+                <a:pos x="csX1" y="csY1"/>
+              </a:cxn>
+              <a:cxn ang="0">
+                <a:pos x="csX2" y="csY2"/>
+              </a:cxn>
+            </a:cxnLst>
+            <a:rect l="l" t="t" r="r" b="b"/>
+            <a:pathLst>
+              <a:path w="2168128" h="1053703">
+                <a:moveTo>
+                  <a:pt x="0" y="0"/>
+                </a:moveTo>
+                <a:cubicBezTo>
+                  <a:pt x="185441" y="236637"/>
+                  <a:pt x="795932" y="660200"/>
+                  <a:pt x="1082278" y="782239"/>
+                </a:cubicBezTo>
+                <a:cubicBezTo>
+                  <a:pt x="1368624" y="904278"/>
+                  <a:pt x="1898450" y="1028105"/>
+                  <a:pt x="2168128" y="1053703"/>
+                </a:cubicBezTo>
+              </a:path>
+            </a:pathLst>
+          </a:custGeom>
+          <a:noFill/>
+          <a:ln w="15875" cap="rnd">
+            <a:solidFill>
+              <a:srgbClr val="FF0000"/>
+            </a:solidFill>
+            <a:round/>
+          </a:ln>
+        </p:spPr>
+        <p:style>
+          <a:lnRef idx="2">
+            <a:schemeClr val="accent1">
+              <a:shade val="15000"/>
+            </a:schemeClr>
+          </a:lnRef>
+          <a:fillRef idx="1">
+            <a:schemeClr val="accent1"/>
+          </a:fillRef>
+          <a:effectRef idx="0">
+            <a:schemeClr val="accent1"/>
+          </a:effectRef>
+          <a:fontRef idx="minor">
+            <a:schemeClr val="lt1"/>
+          </a:fontRef>
+        </p:style>
+        <p:txBody>
+          <a:bodyPr rtlCol="0" anchor="ctr"/>
+          <a:lstStyle/>
+          <a:p>
+            <a:pPr algn="ctr"/>
+            <a:endParaRPr lang="de-DE"/>
+          </a:p>
+        </p:txBody>
+      </p:sp>
+      <p:sp>
+        <p:nvSpPr>
+          <p:cNvPr id="20" name="Textfeld 19">
+            <a:extLst>
+              <a:ext uri="{FF2B5EF4-FFF2-40B4-BE49-F238E27FC236}">
+                <a16:creationId xmlns:a16="http://schemas.microsoft.com/office/drawing/2014/main" id="{90A911B4-C666-DA2F-9FB0-92973EA0C239}"/>
+              </a:ext>
+            </a:extLst>
+          </p:cNvPr>
+          <p:cNvSpPr txBox="1"/>
+          <p:nvPr/>
+        </p:nvSpPr>
+        <p:spPr>
+          <a:xfrm>
+            <a:off x="2080624" y="683880"/>
+            <a:ext cx="716155" cy="900246"/>
+          </a:xfrm>
+          <a:prstGeom prst="rect">
+            <a:avLst/>
+          </a:prstGeom>
+          <a:noFill/>
+        </p:spPr>
+        <p:txBody>
+          <a:bodyPr wrap="square" rtlCol="0">
+            <a:spAutoFit/>
+          </a:bodyPr>
+          <a:lstStyle/>
+          <a:p>
+            <a:r>
+              <a:rPr lang="de-DE" sz="1050" dirty="0">
+                <a:latin typeface="CMU Serif" panose="02000603000000000000" pitchFamily="2" charset="0"/>
+                <a:ea typeface="CMU Serif" panose="02000603000000000000" pitchFamily="2" charset="0"/>
+                <a:cs typeface="CMU Serif" panose="02000603000000000000" pitchFamily="2" charset="0"/>
+              </a:rPr>
+              <a:t>Isochor</a:t>
+            </a:r>
+          </a:p>
+          <a:p>
+            <a:r>
+              <a:rPr lang="de-DE" sz="1050" dirty="0">
+                <a:latin typeface="CMU Serif" panose="02000603000000000000" pitchFamily="2" charset="0"/>
+                <a:ea typeface="CMU Serif" panose="02000603000000000000" pitchFamily="2" charset="0"/>
+                <a:cs typeface="CMU Serif" panose="02000603000000000000" pitchFamily="2" charset="0"/>
+              </a:rPr>
+              <a:t>Isobar</a:t>
+            </a:r>
+          </a:p>
+          <a:p>
+            <a:r>
+              <a:rPr lang="de-DE" sz="1050" dirty="0">
+                <a:latin typeface="CMU Serif" panose="02000603000000000000" pitchFamily="2" charset="0"/>
+                <a:ea typeface="CMU Serif" panose="02000603000000000000" pitchFamily="2" charset="0"/>
+                <a:cs typeface="CMU Serif" panose="02000603000000000000" pitchFamily="2" charset="0"/>
+              </a:rPr>
+              <a:t>Isotherm</a:t>
+            </a:r>
+          </a:p>
+          <a:p>
+            <a:r>
+              <a:rPr lang="de-DE" sz="1050" dirty="0">
+                <a:latin typeface="CMU Serif" panose="02000603000000000000" pitchFamily="2" charset="0"/>
+                <a:ea typeface="CMU Serif" panose="02000603000000000000" pitchFamily="2" charset="0"/>
+                <a:cs typeface="CMU Serif" panose="02000603000000000000" pitchFamily="2" charset="0"/>
+              </a:rPr>
+              <a:t>Polytrop</a:t>
+            </a:r>
+          </a:p>
+          <a:p>
+            <a:r>
+              <a:rPr lang="de-DE" sz="1050" dirty="0">
+                <a:latin typeface="CMU Serif" panose="02000603000000000000" pitchFamily="2" charset="0"/>
+                <a:ea typeface="CMU Serif" panose="02000603000000000000" pitchFamily="2" charset="0"/>
+                <a:cs typeface="CMU Serif" panose="02000603000000000000" pitchFamily="2" charset="0"/>
+              </a:rPr>
+              <a:t>Isentrop</a:t>
+            </a:r>
+          </a:p>
+        </p:txBody>
+      </p:sp>
+      <p:sp>
+        <p:nvSpPr>
+          <p:cNvPr id="22" name="Textfeld 21">
+            <a:extLst>
+              <a:ext uri="{FF2B5EF4-FFF2-40B4-BE49-F238E27FC236}">
+                <a16:creationId xmlns:a16="http://schemas.microsoft.com/office/drawing/2014/main" id="{09C8203E-1370-1FA0-F7B6-43500132B434}"/>
+              </a:ext>
+            </a:extLst>
+          </p:cNvPr>
+          <p:cNvSpPr txBox="1"/>
+          <p:nvPr/>
+        </p:nvSpPr>
+        <p:spPr>
+          <a:xfrm>
+            <a:off x="2690820" y="680129"/>
+            <a:ext cx="817707" cy="900246"/>
+          </a:xfrm>
+          <a:prstGeom prst="rect">
+            <a:avLst/>
+          </a:prstGeom>
+          <a:noFill/>
+        </p:spPr>
+        <p:txBody>
+          <a:bodyPr wrap="square" rtlCol="0">
+            <a:spAutoFit/>
+          </a:bodyPr>
+          <a:lstStyle/>
+          <a:p>
+            <a:endParaRPr lang="de-DE" sz="1050" dirty="0">
+              <a:latin typeface="CMU Serif" panose="02000603000000000000" pitchFamily="2" charset="0"/>
+              <a:ea typeface="CMU Serif" panose="02000603000000000000" pitchFamily="2" charset="0"/>
+              <a:cs typeface="CMU Serif" panose="02000603000000000000" pitchFamily="2" charset="0"/>
+            </a:endParaRPr>
+          </a:p>
+          <a:p>
+            <a:r>
+              <a:rPr lang="de-DE" sz="1050" dirty="0">
+                <a:latin typeface="CMU Serif" panose="02000603000000000000" pitchFamily="2" charset="0"/>
+                <a:ea typeface="CMU Serif" panose="02000603000000000000" pitchFamily="2" charset="0"/>
+                <a:cs typeface="CMU Serif" panose="02000603000000000000" pitchFamily="2" charset="0"/>
+              </a:rPr>
+              <a:t>(</a:t>
+            </a:r>
+            <a:r>
+              <a:rPr lang="de-DE" sz="1050" i="1" dirty="0">
+                <a:latin typeface="CMU Serif" panose="02000603000000000000" pitchFamily="2" charset="0"/>
+                <a:ea typeface="CMU Serif" panose="02000603000000000000" pitchFamily="2" charset="0"/>
+                <a:cs typeface="CMU Serif" panose="02000603000000000000" pitchFamily="2" charset="0"/>
+              </a:rPr>
+              <a:t>n</a:t>
+            </a:r>
+            <a:r>
+              <a:rPr lang="de-DE" sz="1050" dirty="0">
+                <a:latin typeface="CMU Serif" panose="02000603000000000000" pitchFamily="2" charset="0"/>
+                <a:ea typeface="CMU Serif" panose="02000603000000000000" pitchFamily="2" charset="0"/>
+                <a:cs typeface="CMU Serif" panose="02000603000000000000" pitchFamily="2" charset="0"/>
+              </a:rPr>
+              <a:t> = 0)</a:t>
+            </a:r>
+          </a:p>
+          <a:p>
+            <a:r>
+              <a:rPr lang="de-DE" sz="1050" dirty="0">
+                <a:latin typeface="CMU Serif" panose="02000603000000000000" pitchFamily="2" charset="0"/>
+                <a:ea typeface="CMU Serif" panose="02000603000000000000" pitchFamily="2" charset="0"/>
+                <a:cs typeface="CMU Serif" panose="02000603000000000000" pitchFamily="2" charset="0"/>
+              </a:rPr>
+              <a:t>(</a:t>
+            </a:r>
+            <a:r>
+              <a:rPr lang="de-DE" sz="1050" i="1" dirty="0">
+                <a:latin typeface="CMU Serif" panose="02000603000000000000" pitchFamily="2" charset="0"/>
+                <a:ea typeface="CMU Serif" panose="02000603000000000000" pitchFamily="2" charset="0"/>
+                <a:cs typeface="CMU Serif" panose="02000603000000000000" pitchFamily="2" charset="0"/>
+              </a:rPr>
+              <a:t>n</a:t>
+            </a:r>
+            <a:r>
+              <a:rPr lang="de-DE" sz="1050" dirty="0">
+                <a:latin typeface="CMU Serif" panose="02000603000000000000" pitchFamily="2" charset="0"/>
+                <a:ea typeface="CMU Serif" panose="02000603000000000000" pitchFamily="2" charset="0"/>
+                <a:cs typeface="CMU Serif" panose="02000603000000000000" pitchFamily="2" charset="0"/>
+              </a:rPr>
+              <a:t> = 1)</a:t>
+            </a:r>
+          </a:p>
+          <a:p>
+            <a:r>
+              <a:rPr lang="de-DE" sz="1050" dirty="0">
+                <a:latin typeface="CMU Serif" panose="02000603000000000000" pitchFamily="2" charset="0"/>
+                <a:ea typeface="CMU Serif" panose="02000603000000000000" pitchFamily="2" charset="0"/>
+                <a:cs typeface="CMU Serif" panose="02000603000000000000" pitchFamily="2" charset="0"/>
+              </a:rPr>
+              <a:t>(</a:t>
+            </a:r>
+            <a:r>
+              <a:rPr lang="de-DE" sz="1050" i="1" dirty="0">
+                <a:latin typeface="CMU Serif" panose="02000603000000000000" pitchFamily="2" charset="0"/>
+                <a:ea typeface="CMU Serif" panose="02000603000000000000" pitchFamily="2" charset="0"/>
+                <a:cs typeface="CMU Serif" panose="02000603000000000000" pitchFamily="2" charset="0"/>
+              </a:rPr>
+              <a:t>n</a:t>
+            </a:r>
+            <a:r>
+              <a:rPr lang="de-DE" sz="1050" dirty="0">
+                <a:latin typeface="CMU Serif" panose="02000603000000000000" pitchFamily="2" charset="0"/>
+                <a:ea typeface="CMU Serif" panose="02000603000000000000" pitchFamily="2" charset="0"/>
+                <a:cs typeface="CMU Serif" panose="02000603000000000000" pitchFamily="2" charset="0"/>
+              </a:rPr>
+              <a:t> = </a:t>
+            </a:r>
+            <a:r>
+              <a:rPr lang="de-DE" sz="1050" i="1" dirty="0">
+                <a:latin typeface="CMU Serif" panose="02000603000000000000" pitchFamily="2" charset="0"/>
+                <a:ea typeface="CMU Serif" panose="02000603000000000000" pitchFamily="2" charset="0"/>
+                <a:cs typeface="CMU Serif" panose="02000603000000000000" pitchFamily="2" charset="0"/>
+              </a:rPr>
+              <a:t>n</a:t>
+            </a:r>
+            <a:r>
+              <a:rPr lang="de-DE" sz="1050" dirty="0">
+                <a:latin typeface="CMU Serif" panose="02000603000000000000" pitchFamily="2" charset="0"/>
+                <a:ea typeface="CMU Serif" panose="02000603000000000000" pitchFamily="2" charset="0"/>
+                <a:cs typeface="CMU Serif" panose="02000603000000000000" pitchFamily="2" charset="0"/>
+              </a:rPr>
+              <a:t>)</a:t>
+            </a:r>
+          </a:p>
+          <a:p>
+            <a:r>
+              <a:rPr lang="de-DE" sz="1050" dirty="0">
+                <a:latin typeface="CMU Serif" panose="02000603000000000000" pitchFamily="2" charset="0"/>
+                <a:ea typeface="CMU Serif" panose="02000603000000000000" pitchFamily="2" charset="0"/>
+                <a:cs typeface="CMU Serif" panose="02000603000000000000" pitchFamily="2" charset="0"/>
+              </a:rPr>
+              <a:t>(</a:t>
+            </a:r>
+            <a:r>
+              <a:rPr lang="de-DE" sz="1050" i="1" dirty="0">
+                <a:latin typeface="CMU Serif" panose="02000603000000000000" pitchFamily="2" charset="0"/>
+                <a:ea typeface="CMU Serif" panose="02000603000000000000" pitchFamily="2" charset="0"/>
+                <a:cs typeface="CMU Serif" panose="02000603000000000000" pitchFamily="2" charset="0"/>
+              </a:rPr>
+              <a:t>n</a:t>
+            </a:r>
+            <a:r>
+              <a:rPr lang="de-DE" sz="1050" dirty="0">
+                <a:latin typeface="CMU Serif" panose="02000603000000000000" pitchFamily="2" charset="0"/>
+                <a:ea typeface="CMU Serif" panose="02000603000000000000" pitchFamily="2" charset="0"/>
+                <a:cs typeface="CMU Serif" panose="02000603000000000000" pitchFamily="2" charset="0"/>
+              </a:rPr>
+              <a:t> = </a:t>
+            </a:r>
+            <a:r>
+              <a:rPr lang="de-DE" sz="1050" i="1" dirty="0">
+                <a:latin typeface="CMU Serif" panose="02000603000000000000" pitchFamily="2" charset="0"/>
+                <a:ea typeface="CMU Serif" panose="02000603000000000000" pitchFamily="2" charset="0"/>
+                <a:cs typeface="CMU Serif" panose="02000603000000000000" pitchFamily="2" charset="0"/>
+              </a:rPr>
+              <a:t>k</a:t>
+            </a:r>
+            <a:r>
+              <a:rPr lang="de-DE" sz="1050" dirty="0">
+                <a:latin typeface="CMU Serif" panose="02000603000000000000" pitchFamily="2" charset="0"/>
+                <a:ea typeface="CMU Serif" panose="02000603000000000000" pitchFamily="2" charset="0"/>
+                <a:cs typeface="CMU Serif" panose="02000603000000000000" pitchFamily="2" charset="0"/>
+              </a:rPr>
+              <a:t>)</a:t>
+            </a:r>
+          </a:p>
+        </p:txBody>
+      </p:sp>
+      <p:sp>
+        <p:nvSpPr>
+          <p:cNvPr id="24" name="Textfeld 23">
+            <a:extLst>
+              <a:ext uri="{FF2B5EF4-FFF2-40B4-BE49-F238E27FC236}">
+                <a16:creationId xmlns:a16="http://schemas.microsoft.com/office/drawing/2014/main" id="{E74E54B0-F8AB-7E41-1D83-879CE18805C7}"/>
+              </a:ext>
+            </a:extLst>
+          </p:cNvPr>
+          <p:cNvSpPr txBox="1"/>
+          <p:nvPr/>
+        </p:nvSpPr>
+        <p:spPr>
+          <a:xfrm>
+            <a:off x="2690820" y="697632"/>
+            <a:ext cx="1800224" cy="253916"/>
+          </a:xfrm>
+          <a:prstGeom prst="rect">
+            <a:avLst/>
+          </a:prstGeom>
+          <a:noFill/>
+        </p:spPr>
+        <p:txBody>
+          <a:bodyPr wrap="square">
+            <a:spAutoFit/>
+          </a:bodyPr>
+          <a:lstStyle/>
+          <a:p>
+            <a:r>
+              <a:rPr lang="de-DE" sz="1050" dirty="0">
+                <a:latin typeface="CMU Serif" panose="02000603000000000000" pitchFamily="2" charset="0"/>
+                <a:ea typeface="CMU Serif" panose="02000603000000000000" pitchFamily="2" charset="0"/>
+                <a:cs typeface="CMU Serif" panose="02000603000000000000" pitchFamily="2" charset="0"/>
+              </a:rPr>
+              <a:t>(</a:t>
+            </a:r>
+            <a:r>
+              <a:rPr lang="de-DE" sz="1050" i="1" dirty="0">
+                <a:latin typeface="CMU Serif" panose="02000603000000000000" pitchFamily="2" charset="0"/>
+                <a:ea typeface="CMU Serif" panose="02000603000000000000" pitchFamily="2" charset="0"/>
+                <a:cs typeface="CMU Serif" panose="02000603000000000000" pitchFamily="2" charset="0"/>
+              </a:rPr>
+              <a:t>n</a:t>
+            </a:r>
+            <a:r>
+              <a:rPr lang="de-DE" sz="1050" dirty="0">
+                <a:latin typeface="CMU Serif" panose="02000603000000000000" pitchFamily="2" charset="0"/>
+                <a:ea typeface="CMU Serif" panose="02000603000000000000" pitchFamily="2" charset="0"/>
+                <a:cs typeface="CMU Serif" panose="02000603000000000000" pitchFamily="2" charset="0"/>
+              </a:rPr>
+              <a:t> = </a:t>
+            </a:r>
+            <a:r>
+              <a:rPr lang="de-DE" sz="1050" dirty="0">
+                <a:latin typeface="Latin Modern Math" panose="02000503000000000000" pitchFamily="50" charset="0"/>
+                <a:ea typeface="Latin Modern Math" panose="02000503000000000000" pitchFamily="50" charset="0"/>
+                <a:cs typeface="CMU Serif" panose="02000603000000000000" pitchFamily="2" charset="0"/>
+              </a:rPr>
+              <a:t>∞</a:t>
+            </a:r>
+            <a:r>
+              <a:rPr lang="de-DE" sz="1050" dirty="0">
+                <a:latin typeface="CMU Serif" panose="02000603000000000000" pitchFamily="2" charset="0"/>
+                <a:ea typeface="CMU Serif" panose="02000603000000000000" pitchFamily="2" charset="0"/>
+                <a:cs typeface="CMU Serif" panose="02000603000000000000" pitchFamily="2" charset="0"/>
+              </a:rPr>
+              <a:t>)</a:t>
+            </a:r>
+          </a:p>
+        </p:txBody>
+      </p:sp>
+      <p:cxnSp>
+        <p:nvCxnSpPr>
+          <p:cNvPr id="25" name="Gerade Verbindung mit Pfeil 24">
+            <a:extLst>
+              <a:ext uri="{FF2B5EF4-FFF2-40B4-BE49-F238E27FC236}">
+                <a16:creationId xmlns:a16="http://schemas.microsoft.com/office/drawing/2014/main" id="{4BA58E27-D274-5EAE-0097-B21992969242}"/>
+              </a:ext>
+            </a:extLst>
+          </p:cNvPr>
+          <p:cNvCxnSpPr>
+            <a:cxnSpLocks/>
+          </p:cNvCxnSpPr>
+          <p:nvPr/>
+        </p:nvCxnSpPr>
+        <p:spPr>
+          <a:xfrm>
+            <a:off x="1944599" y="803015"/>
+            <a:ext cx="153582" cy="0"/>
+          </a:xfrm>
+          <a:prstGeom prst="straightConnector1">
+            <a:avLst/>
+          </a:prstGeom>
+          <a:ln w="15875" cap="rnd">
+            <a:solidFill>
+              <a:schemeClr val="tx1"/>
+            </a:solidFill>
+            <a:round/>
+            <a:tailEnd type="none"/>
+          </a:ln>
+        </p:spPr>
+        <p:style>
+          <a:lnRef idx="2">
+            <a:schemeClr val="accent1"/>
+          </a:lnRef>
+          <a:fillRef idx="0">
+            <a:schemeClr val="accent1"/>
+          </a:fillRef>
+          <a:effectRef idx="1">
+            <a:schemeClr val="accent1"/>
+          </a:effectRef>
+          <a:fontRef idx="minor">
+            <a:schemeClr val="tx1"/>
+          </a:fontRef>
+        </p:style>
+      </p:cxnSp>
+      <p:cxnSp>
+        <p:nvCxnSpPr>
+          <p:cNvPr id="28" name="Gerade Verbindung mit Pfeil 27">
+            <a:extLst>
+              <a:ext uri="{FF2B5EF4-FFF2-40B4-BE49-F238E27FC236}">
+                <a16:creationId xmlns:a16="http://schemas.microsoft.com/office/drawing/2014/main" id="{6CFBD370-3769-0048-3991-BF7714B4FA40}"/>
+              </a:ext>
+            </a:extLst>
+          </p:cNvPr>
+          <p:cNvCxnSpPr>
+            <a:cxnSpLocks/>
+          </p:cNvCxnSpPr>
+          <p:nvPr/>
+        </p:nvCxnSpPr>
+        <p:spPr>
+          <a:xfrm>
+            <a:off x="1944599" y="962559"/>
+            <a:ext cx="153582" cy="0"/>
+          </a:xfrm>
+          <a:prstGeom prst="straightConnector1">
+            <a:avLst/>
+          </a:prstGeom>
+          <a:ln w="15875" cap="rnd">
+            <a:solidFill>
+              <a:srgbClr val="0070C0"/>
+            </a:solidFill>
+            <a:round/>
+            <a:tailEnd type="none"/>
+          </a:ln>
+        </p:spPr>
+        <p:style>
+          <a:lnRef idx="2">
+            <a:schemeClr val="accent1"/>
+          </a:lnRef>
+          <a:fillRef idx="0">
+            <a:schemeClr val="accent1"/>
+          </a:fillRef>
+          <a:effectRef idx="1">
+            <a:schemeClr val="accent1"/>
+          </a:effectRef>
+          <a:fontRef idx="minor">
+            <a:schemeClr val="tx1"/>
+          </a:fontRef>
+        </p:style>
+      </p:cxnSp>
+      <p:cxnSp>
+        <p:nvCxnSpPr>
+          <p:cNvPr id="29" name="Gerade Verbindung mit Pfeil 28">
+            <a:extLst>
+              <a:ext uri="{FF2B5EF4-FFF2-40B4-BE49-F238E27FC236}">
+                <a16:creationId xmlns:a16="http://schemas.microsoft.com/office/drawing/2014/main" id="{A95445D9-485A-1B9B-F463-F9D7B2077F44}"/>
+              </a:ext>
+            </a:extLst>
+          </p:cNvPr>
+          <p:cNvCxnSpPr>
+            <a:cxnSpLocks/>
+          </p:cNvCxnSpPr>
+          <p:nvPr/>
+        </p:nvCxnSpPr>
+        <p:spPr>
+          <a:xfrm>
+            <a:off x="1944599" y="1122103"/>
+            <a:ext cx="153582" cy="0"/>
+          </a:xfrm>
+          <a:prstGeom prst="straightConnector1">
+            <a:avLst/>
+          </a:prstGeom>
+          <a:ln w="15875" cap="rnd">
+            <a:solidFill>
+              <a:srgbClr val="FF0000"/>
+            </a:solidFill>
+            <a:round/>
+            <a:tailEnd type="none"/>
+          </a:ln>
+        </p:spPr>
+        <p:style>
+          <a:lnRef idx="2">
+            <a:schemeClr val="accent1"/>
+          </a:lnRef>
+          <a:fillRef idx="0">
+            <a:schemeClr val="accent1"/>
+          </a:fillRef>
+          <a:effectRef idx="1">
+            <a:schemeClr val="accent1"/>
+          </a:effectRef>
+          <a:fontRef idx="minor">
+            <a:schemeClr val="tx1"/>
+          </a:fontRef>
+        </p:style>
+      </p:cxnSp>
+      <p:cxnSp>
+        <p:nvCxnSpPr>
+          <p:cNvPr id="30" name="Gerade Verbindung mit Pfeil 29">
+            <a:extLst>
+              <a:ext uri="{FF2B5EF4-FFF2-40B4-BE49-F238E27FC236}">
+                <a16:creationId xmlns:a16="http://schemas.microsoft.com/office/drawing/2014/main" id="{82D7FF2B-E40C-D288-2281-DC7ADA36EE1C}"/>
+              </a:ext>
+            </a:extLst>
+          </p:cNvPr>
+          <p:cNvCxnSpPr>
+            <a:cxnSpLocks/>
+          </p:cNvCxnSpPr>
+          <p:nvPr/>
+        </p:nvCxnSpPr>
+        <p:spPr>
+          <a:xfrm>
+            <a:off x="1944599" y="1281647"/>
+            <a:ext cx="153582" cy="0"/>
+          </a:xfrm>
+          <a:prstGeom prst="straightConnector1">
+            <a:avLst/>
+          </a:prstGeom>
+          <a:ln w="15875" cap="rnd">
+            <a:solidFill>
+              <a:schemeClr val="accent6"/>
+            </a:solidFill>
+            <a:round/>
+            <a:tailEnd type="none"/>
+          </a:ln>
+        </p:spPr>
+        <p:style>
+          <a:lnRef idx="2">
+            <a:schemeClr val="accent1"/>
+          </a:lnRef>
+          <a:fillRef idx="0">
+            <a:schemeClr val="accent1"/>
+          </a:fillRef>
+          <a:effectRef idx="1">
+            <a:schemeClr val="accent1"/>
+          </a:effectRef>
+          <a:fontRef idx="minor">
+            <a:schemeClr val="tx1"/>
+          </a:fontRef>
+        </p:style>
+      </p:cxnSp>
+      <p:cxnSp>
+        <p:nvCxnSpPr>
+          <p:cNvPr id="31" name="Gerade Verbindung mit Pfeil 30">
+            <a:extLst>
+              <a:ext uri="{FF2B5EF4-FFF2-40B4-BE49-F238E27FC236}">
+                <a16:creationId xmlns:a16="http://schemas.microsoft.com/office/drawing/2014/main" id="{1C7E35D8-B5AF-B3F3-A43A-5E8AD7DC1656}"/>
+              </a:ext>
+            </a:extLst>
+          </p:cNvPr>
+          <p:cNvCxnSpPr>
+            <a:cxnSpLocks/>
+          </p:cNvCxnSpPr>
+          <p:nvPr/>
+        </p:nvCxnSpPr>
+        <p:spPr>
+          <a:xfrm>
+            <a:off x="1944599" y="1441190"/>
+            <a:ext cx="153582" cy="0"/>
+          </a:xfrm>
+          <a:prstGeom prst="straightConnector1">
+            <a:avLst/>
+          </a:prstGeom>
+          <a:ln w="15875" cap="rnd">
+            <a:solidFill>
+              <a:srgbClr val="FFC000"/>
+            </a:solidFill>
+            <a:round/>
+            <a:tailEnd type="none"/>
+          </a:ln>
+        </p:spPr>
+        <p:style>
+          <a:lnRef idx="2">
+            <a:schemeClr val="accent1"/>
+          </a:lnRef>
+          <a:fillRef idx="0">
+            <a:schemeClr val="accent1"/>
+          </a:fillRef>
+          <a:effectRef idx="1">
+            <a:schemeClr val="accent1"/>
+          </a:effectRef>
+          <a:fontRef idx="minor">
+            <a:schemeClr val="tx1"/>
+          </a:fontRef>
+        </p:style>
+      </p:cxnSp>
     </p:spTree>
     <p:extLst>
       <p:ext uri="{BB962C8B-B14F-4D97-AF65-F5344CB8AC3E}">
         <p14:creationId xmlns:p14="http://schemas.microsoft.com/office/powerpoint/2010/main" val="2864739827"/>
+      </p:ext>
+    </p:extLst>
+  </p:cSld>
+  <p:clrMapOvr>
+    <a:masterClrMapping/>
+  </p:clrMapOvr>
+</p:sld>
+</file>
+
+<file path=ppt/slides/slide5.xml><?xml version="1.0" encoding="utf-8"?>
+<p:sld xmlns:a="http://schemas.openxmlformats.org/drawingml/2006/main" xmlns:r="http://schemas.openxmlformats.org/officeDocument/2006/relationships" xmlns:p="http://schemas.openxmlformats.org/presentationml/2006/main">
+  <p:cSld>
+    <p:spTree>
+      <p:nvGrpSpPr>
+        <p:cNvPr id="1" name="">
+          <a:extLst>
+            <a:ext uri="{FF2B5EF4-FFF2-40B4-BE49-F238E27FC236}">
+              <a16:creationId xmlns:a16="http://schemas.microsoft.com/office/drawing/2014/main" id="{FBDC39E8-72CE-F71D-1C2C-6F3187CA2AC7}"/>
+            </a:ext>
+          </a:extLst>
+        </p:cNvPr>
+        <p:cNvGrpSpPr/>
+        <p:nvPr/>
+      </p:nvGrpSpPr>
+      <p:grpSpPr>
+        <a:xfrm>
+          <a:off x="0" y="0"/>
+          <a:ext cx="0" cy="0"/>
+          <a:chOff x="0" y="0"/>
+          <a:chExt cx="0" cy="0"/>
+        </a:xfrm>
+      </p:grpSpPr>
+    </p:spTree>
+    <p:extLst>
+      <p:ext uri="{BB962C8B-B14F-4D97-AF65-F5344CB8AC3E}">
+        <p14:creationId xmlns:p14="http://schemas.microsoft.com/office/powerpoint/2010/main" val="900053020"/>
       </p:ext>
     </p:extLst>
   </p:cSld>

</xml_diff>

<commit_message>
continued Impulssatz in SL1
</commit_message>
<xml_diff>
--- a/LaTeX B.Sc. LRT/Strömungslehre 1/images/SL1-Images.pptx
+++ b/LaTeX B.Sc. LRT/Strömungslehre 1/images/SL1-Images.pptx
@@ -12,6 +12,8 @@
     <p:sldId id="260" r:id="rId6"/>
     <p:sldId id="261" r:id="rId7"/>
     <p:sldId id="262" r:id="rId8"/>
+    <p:sldId id="263" r:id="rId9"/>
+    <p:sldId id="264" r:id="rId10"/>
   </p:sldIdLst>
   <p:sldSz cx="3600450" cy="3600450"/>
   <p:notesSz cx="6858000" cy="9144000"/>
@@ -249,7 +251,7 @@
           <a:p>
             <a:fld id="{0F04D7A0-D8C8-4B74-9611-9A000801FA36}" type="datetimeFigureOut">
               <a:rPr lang="de-DE" smtClean="0"/>
-              <a:t>08.09.2026</a:t>
+              <a:t>09.09.2026</a:t>
             </a:fld>
             <a:endParaRPr lang="de-DE"/>
           </a:p>
@@ -419,7 +421,7 @@
           <a:p>
             <a:fld id="{0F04D7A0-D8C8-4B74-9611-9A000801FA36}" type="datetimeFigureOut">
               <a:rPr lang="de-DE" smtClean="0"/>
-              <a:t>08.09.2026</a:t>
+              <a:t>09.09.2026</a:t>
             </a:fld>
             <a:endParaRPr lang="de-DE"/>
           </a:p>
@@ -599,7 +601,7 @@
           <a:p>
             <a:fld id="{0F04D7A0-D8C8-4B74-9611-9A000801FA36}" type="datetimeFigureOut">
               <a:rPr lang="de-DE" smtClean="0"/>
-              <a:t>08.09.2026</a:t>
+              <a:t>09.09.2026</a:t>
             </a:fld>
             <a:endParaRPr lang="de-DE"/>
           </a:p>
@@ -769,7 +771,7 @@
           <a:p>
             <a:fld id="{0F04D7A0-D8C8-4B74-9611-9A000801FA36}" type="datetimeFigureOut">
               <a:rPr lang="de-DE" smtClean="0"/>
-              <a:t>08.09.2026</a:t>
+              <a:t>09.09.2026</a:t>
             </a:fld>
             <a:endParaRPr lang="de-DE"/>
           </a:p>
@@ -1015,7 +1017,7 @@
           <a:p>
             <a:fld id="{0F04D7A0-D8C8-4B74-9611-9A000801FA36}" type="datetimeFigureOut">
               <a:rPr lang="de-DE" smtClean="0"/>
-              <a:t>08.09.2026</a:t>
+              <a:t>09.09.2026</a:t>
             </a:fld>
             <a:endParaRPr lang="de-DE"/>
           </a:p>
@@ -1247,7 +1249,7 @@
           <a:p>
             <a:fld id="{0F04D7A0-D8C8-4B74-9611-9A000801FA36}" type="datetimeFigureOut">
               <a:rPr lang="de-DE" smtClean="0"/>
-              <a:t>08.09.2026</a:t>
+              <a:t>09.09.2026</a:t>
             </a:fld>
             <a:endParaRPr lang="de-DE"/>
           </a:p>
@@ -1614,7 +1616,7 @@
           <a:p>
             <a:fld id="{0F04D7A0-D8C8-4B74-9611-9A000801FA36}" type="datetimeFigureOut">
               <a:rPr lang="de-DE" smtClean="0"/>
-              <a:t>08.09.2026</a:t>
+              <a:t>09.09.2026</a:t>
             </a:fld>
             <a:endParaRPr lang="de-DE"/>
           </a:p>
@@ -1732,7 +1734,7 @@
           <a:p>
             <a:fld id="{0F04D7A0-D8C8-4B74-9611-9A000801FA36}" type="datetimeFigureOut">
               <a:rPr lang="de-DE" smtClean="0"/>
-              <a:t>08.09.2026</a:t>
+              <a:t>09.09.2026</a:t>
             </a:fld>
             <a:endParaRPr lang="de-DE"/>
           </a:p>
@@ -1827,7 +1829,7 @@
           <a:p>
             <a:fld id="{0F04D7A0-D8C8-4B74-9611-9A000801FA36}" type="datetimeFigureOut">
               <a:rPr lang="de-DE" smtClean="0"/>
-              <a:t>08.09.2026</a:t>
+              <a:t>09.09.2026</a:t>
             </a:fld>
             <a:endParaRPr lang="de-DE"/>
           </a:p>
@@ -2104,7 +2106,7 @@
           <a:p>
             <a:fld id="{0F04D7A0-D8C8-4B74-9611-9A000801FA36}" type="datetimeFigureOut">
               <a:rPr lang="de-DE" smtClean="0"/>
-              <a:t>08.09.2026</a:t>
+              <a:t>09.09.2026</a:t>
             </a:fld>
             <a:endParaRPr lang="de-DE"/>
           </a:p>
@@ -2361,7 +2363,7 @@
           <a:p>
             <a:fld id="{0F04D7A0-D8C8-4B74-9611-9A000801FA36}" type="datetimeFigureOut">
               <a:rPr lang="de-DE" smtClean="0"/>
-              <a:t>08.09.2026</a:t>
+              <a:t>09.09.2026</a:t>
             </a:fld>
             <a:endParaRPr lang="de-DE"/>
           </a:p>
@@ -2574,7 +2576,7 @@
           <a:p>
             <a:fld id="{0F04D7A0-D8C8-4B74-9611-9A000801FA36}" type="datetimeFigureOut">
               <a:rPr lang="de-DE" smtClean="0"/>
-              <a:t>08.09.2026</a:t>
+              <a:t>09.09.2026</a:t>
             </a:fld>
             <a:endParaRPr lang="de-DE"/>
           </a:p>
@@ -12080,7 +12082,7 @@
             <a:lstStyle/>
             <a:p>
               <a:pPr algn="ctr"/>
-              <a:endParaRPr lang="de-DE" sz="1200"/>
+              <a:endParaRPr lang="de-DE" sz="1200" dirty="0"/>
             </a:p>
           </p:txBody>
         </p:sp>
@@ -13147,10 +13149,2657 @@
           <a:chExt cx="0" cy="0"/>
         </a:xfrm>
       </p:grpSpPr>
+      <p:sp>
+        <p:nvSpPr>
+          <p:cNvPr id="2" name="Rechteck 1">
+            <a:extLst>
+              <a:ext uri="{FF2B5EF4-FFF2-40B4-BE49-F238E27FC236}">
+                <a16:creationId xmlns:a16="http://schemas.microsoft.com/office/drawing/2014/main" id="{5A8331B9-4009-8FFB-E984-388C4C09E5A4}"/>
+              </a:ext>
+            </a:extLst>
+          </p:cNvPr>
+          <p:cNvSpPr/>
+          <p:nvPr/>
+        </p:nvSpPr>
+        <p:spPr>
+          <a:xfrm>
+            <a:off x="204627" y="1199257"/>
+            <a:ext cx="1913494" cy="1201935"/>
+          </a:xfrm>
+          <a:prstGeom prst="rect">
+            <a:avLst/>
+          </a:prstGeom>
+          <a:noFill/>
+          <a:ln w="12700" cap="rnd">
+            <a:solidFill>
+              <a:schemeClr val="tx1"/>
+            </a:solidFill>
+            <a:prstDash val="lgDashDot"/>
+            <a:round/>
+          </a:ln>
+        </p:spPr>
+        <p:style>
+          <a:lnRef idx="2">
+            <a:schemeClr val="accent1">
+              <a:shade val="15000"/>
+            </a:schemeClr>
+          </a:lnRef>
+          <a:fillRef idx="1">
+            <a:schemeClr val="accent1"/>
+          </a:fillRef>
+          <a:effectRef idx="0">
+            <a:schemeClr val="accent1"/>
+          </a:effectRef>
+          <a:fontRef idx="minor">
+            <a:schemeClr val="lt1"/>
+          </a:fontRef>
+        </p:style>
+        <p:txBody>
+          <a:bodyPr rtlCol="0" anchor="ctr"/>
+          <a:lstStyle/>
+          <a:p>
+            <a:pPr algn="ctr"/>
+            <a:endParaRPr lang="de-DE"/>
+          </a:p>
+        </p:txBody>
+      </p:sp>
+      <p:sp>
+        <p:nvSpPr>
+          <p:cNvPr id="3" name="Freihandform: Form 2">
+            <a:extLst>
+              <a:ext uri="{FF2B5EF4-FFF2-40B4-BE49-F238E27FC236}">
+                <a16:creationId xmlns:a16="http://schemas.microsoft.com/office/drawing/2014/main" id="{BFCABCF0-B72C-6950-E305-4ADDE73B9E4C}"/>
+              </a:ext>
+            </a:extLst>
+          </p:cNvPr>
+          <p:cNvSpPr/>
+          <p:nvPr/>
+        </p:nvSpPr>
+        <p:spPr>
+          <a:xfrm>
+            <a:off x="909634" y="1734267"/>
+            <a:ext cx="1037989" cy="131913"/>
+          </a:xfrm>
+          <a:custGeom>
+            <a:avLst/>
+            <a:gdLst>
+              <a:gd name="csX0" fmla="*/ 1037989 w 1037989"/>
+              <a:gd name="csY0" fmla="*/ 95074 h 131913"/>
+              <a:gd name="csX1" fmla="*/ 317661 w 1037989"/>
+              <a:gd name="csY1" fmla="*/ 62 h 131913"/>
+              <a:gd name="csX2" fmla="*/ 2 w 1037989"/>
+              <a:gd name="csY2" fmla="*/ 83644 h 131913"/>
+              <a:gd name="csX3" fmla="*/ 319327 w 1037989"/>
+              <a:gd name="csY3" fmla="*/ 131745 h 131913"/>
+              <a:gd name="csX4" fmla="*/ 1037989 w 1037989"/>
+              <a:gd name="csY4" fmla="*/ 95074 h 131913"/>
+            </a:gdLst>
+            <a:ahLst/>
+            <a:cxnLst>
+              <a:cxn ang="0">
+                <a:pos x="csX0" y="csY0"/>
+              </a:cxn>
+              <a:cxn ang="0">
+                <a:pos x="csX1" y="csY1"/>
+              </a:cxn>
+              <a:cxn ang="0">
+                <a:pos x="csX2" y="csY2"/>
+              </a:cxn>
+              <a:cxn ang="0">
+                <a:pos x="csX3" y="csY3"/>
+              </a:cxn>
+              <a:cxn ang="0">
+                <a:pos x="csX4" y="csY4"/>
+              </a:cxn>
+            </a:cxnLst>
+            <a:rect l="l" t="t" r="r" b="b"/>
+            <a:pathLst>
+              <a:path w="1037989" h="131913">
+                <a:moveTo>
+                  <a:pt x="1037989" y="95074"/>
+                </a:moveTo>
+                <a:cubicBezTo>
+                  <a:pt x="793554" y="44234"/>
+                  <a:pt x="490659" y="1967"/>
+                  <a:pt x="317661" y="62"/>
+                </a:cubicBezTo>
+                <a:cubicBezTo>
+                  <a:pt x="144663" y="-1843"/>
+                  <a:pt x="-593" y="40424"/>
+                  <a:pt x="2" y="83644"/>
+                </a:cubicBezTo>
+                <a:cubicBezTo>
+                  <a:pt x="597" y="126864"/>
+                  <a:pt x="146329" y="129840"/>
+                  <a:pt x="319327" y="131745"/>
+                </a:cubicBezTo>
+                <a:cubicBezTo>
+                  <a:pt x="492325" y="133650"/>
+                  <a:pt x="821414" y="119244"/>
+                  <a:pt x="1037989" y="95074"/>
+                </a:cubicBezTo>
+                <a:close/>
+              </a:path>
+            </a:pathLst>
+          </a:custGeom>
+          <a:noFill/>
+          <a:ln>
+            <a:solidFill>
+              <a:schemeClr val="tx1"/>
+            </a:solidFill>
+          </a:ln>
+        </p:spPr>
+        <p:style>
+          <a:lnRef idx="2">
+            <a:schemeClr val="accent1">
+              <a:shade val="15000"/>
+            </a:schemeClr>
+          </a:lnRef>
+          <a:fillRef idx="1">
+            <a:schemeClr val="accent1"/>
+          </a:fillRef>
+          <a:effectRef idx="0">
+            <a:schemeClr val="accent1"/>
+          </a:effectRef>
+          <a:fontRef idx="minor">
+            <a:schemeClr val="lt1"/>
+          </a:fontRef>
+        </p:style>
+        <p:txBody>
+          <a:bodyPr rtlCol="0" anchor="ctr"/>
+          <a:lstStyle/>
+          <a:p>
+            <a:pPr algn="ctr"/>
+            <a:endParaRPr lang="de-DE"/>
+          </a:p>
+        </p:txBody>
+      </p:sp>
+      <p:cxnSp>
+        <p:nvCxnSpPr>
+          <p:cNvPr id="5" name="Gerade Verbindung mit Pfeil 4">
+            <a:extLst>
+              <a:ext uri="{FF2B5EF4-FFF2-40B4-BE49-F238E27FC236}">
+                <a16:creationId xmlns:a16="http://schemas.microsoft.com/office/drawing/2014/main" id="{CB2998CD-F526-0181-43B1-DFF384443EE1}"/>
+              </a:ext>
+            </a:extLst>
+          </p:cNvPr>
+          <p:cNvCxnSpPr>
+            <a:cxnSpLocks/>
+          </p:cNvCxnSpPr>
+          <p:nvPr/>
+        </p:nvCxnSpPr>
+        <p:spPr>
+          <a:xfrm flipV="1">
+            <a:off x="1178717" y="1367790"/>
+            <a:ext cx="0" cy="878205"/>
+          </a:xfrm>
+          <a:prstGeom prst="straightConnector1">
+            <a:avLst/>
+          </a:prstGeom>
+          <a:ln cap="rnd">
+            <a:solidFill>
+              <a:srgbClr val="FF0000"/>
+            </a:solidFill>
+            <a:round/>
+            <a:headEnd type="triangle"/>
+            <a:tailEnd type="triangle"/>
+          </a:ln>
+        </p:spPr>
+        <p:style>
+          <a:lnRef idx="2">
+            <a:schemeClr val="accent1"/>
+          </a:lnRef>
+          <a:fillRef idx="0">
+            <a:schemeClr val="accent1"/>
+          </a:fillRef>
+          <a:effectRef idx="1">
+            <a:schemeClr val="accent1"/>
+          </a:effectRef>
+          <a:fontRef idx="minor">
+            <a:schemeClr val="tx1"/>
+          </a:fontRef>
+        </p:style>
+      </p:cxnSp>
+      <p:sp>
+        <p:nvSpPr>
+          <p:cNvPr id="9" name="Ellipse 8">
+            <a:extLst>
+              <a:ext uri="{FF2B5EF4-FFF2-40B4-BE49-F238E27FC236}">
+                <a16:creationId xmlns:a16="http://schemas.microsoft.com/office/drawing/2014/main" id="{286DF4C4-44BB-F2CF-5161-08B954729951}"/>
+              </a:ext>
+            </a:extLst>
+          </p:cNvPr>
+          <p:cNvSpPr/>
+          <p:nvPr/>
+        </p:nvSpPr>
+        <p:spPr>
+          <a:xfrm>
+            <a:off x="1148234" y="1769740"/>
+            <a:ext cx="60966" cy="60966"/>
+          </a:xfrm>
+          <a:prstGeom prst="ellipse">
+            <a:avLst/>
+          </a:prstGeom>
+          <a:solidFill>
+            <a:schemeClr val="tx1"/>
+          </a:solidFill>
+          <a:ln>
+            <a:noFill/>
+          </a:ln>
+        </p:spPr>
+        <p:style>
+          <a:lnRef idx="2">
+            <a:schemeClr val="accent1">
+              <a:shade val="15000"/>
+            </a:schemeClr>
+          </a:lnRef>
+          <a:fillRef idx="1">
+            <a:schemeClr val="accent1"/>
+          </a:fillRef>
+          <a:effectRef idx="0">
+            <a:schemeClr val="accent1"/>
+          </a:effectRef>
+          <a:fontRef idx="minor">
+            <a:schemeClr val="lt1"/>
+          </a:fontRef>
+        </p:style>
+        <p:txBody>
+          <a:bodyPr rtlCol="0" anchor="ctr"/>
+          <a:lstStyle/>
+          <a:p>
+            <a:pPr algn="ctr"/>
+            <a:endParaRPr lang="de-DE"/>
+          </a:p>
+        </p:txBody>
+      </p:sp>
+      <p:sp>
+        <p:nvSpPr>
+          <p:cNvPr id="11" name="Textfeld 10">
+            <a:extLst>
+              <a:ext uri="{FF2B5EF4-FFF2-40B4-BE49-F238E27FC236}">
+                <a16:creationId xmlns:a16="http://schemas.microsoft.com/office/drawing/2014/main" id="{A30E9BB5-1572-0A53-1DD2-DF0E417C6CA6}"/>
+              </a:ext>
+            </a:extLst>
+          </p:cNvPr>
+          <p:cNvSpPr txBox="1"/>
+          <p:nvPr/>
+        </p:nvSpPr>
+        <p:spPr>
+          <a:xfrm>
+            <a:off x="1178717" y="1373001"/>
+            <a:ext cx="408249" cy="276999"/>
+          </a:xfrm>
+          <a:prstGeom prst="rect">
+            <a:avLst/>
+          </a:prstGeom>
+          <a:noFill/>
+        </p:spPr>
+        <p:txBody>
+          <a:bodyPr wrap="square" rtlCol="0" anchor="ctr">
+            <a:spAutoFit/>
+          </a:bodyPr>
+          <a:lstStyle/>
+          <a:p>
+            <a:pPr algn="ctr"/>
+            <a:r>
+              <a:rPr lang="de-DE" sz="1200" i="1" dirty="0">
+                <a:solidFill>
+                  <a:srgbClr val="FF0000"/>
+                </a:solidFill>
+                <a:latin typeface="CMU Serif" panose="02000603000000000000" pitchFamily="2" charset="0"/>
+                <a:ea typeface="CMU Serif" panose="02000603000000000000" pitchFamily="2" charset="0"/>
+                <a:cs typeface="CMU Serif" panose="02000603000000000000" pitchFamily="2" charset="0"/>
+              </a:rPr>
+              <a:t>F</a:t>
+            </a:r>
+            <a:r>
+              <a:rPr lang="de-DE" sz="1200" baseline="-25000" dirty="0">
+                <a:solidFill>
+                  <a:srgbClr val="FF0000"/>
+                </a:solidFill>
+                <a:latin typeface="CMU Serif" panose="02000603000000000000" pitchFamily="2" charset="0"/>
+                <a:ea typeface="CMU Serif" panose="02000603000000000000" pitchFamily="2" charset="0"/>
+                <a:cs typeface="CMU Serif" panose="02000603000000000000" pitchFamily="2" charset="0"/>
+              </a:rPr>
+              <a:t>A</a:t>
+            </a:r>
+          </a:p>
+        </p:txBody>
+      </p:sp>
+      <p:sp>
+        <p:nvSpPr>
+          <p:cNvPr id="13" name="Textfeld 12">
+            <a:extLst>
+              <a:ext uri="{FF2B5EF4-FFF2-40B4-BE49-F238E27FC236}">
+                <a16:creationId xmlns:a16="http://schemas.microsoft.com/office/drawing/2014/main" id="{66F7A848-C81C-9050-3ED9-6BEF272B14CE}"/>
+              </a:ext>
+            </a:extLst>
+          </p:cNvPr>
+          <p:cNvSpPr txBox="1"/>
+          <p:nvPr/>
+        </p:nvSpPr>
+        <p:spPr>
+          <a:xfrm>
+            <a:off x="1178716" y="1950447"/>
+            <a:ext cx="408249" cy="276999"/>
+          </a:xfrm>
+          <a:prstGeom prst="rect">
+            <a:avLst/>
+          </a:prstGeom>
+          <a:noFill/>
+        </p:spPr>
+        <p:txBody>
+          <a:bodyPr wrap="square" rtlCol="0" anchor="ctr">
+            <a:spAutoFit/>
+          </a:bodyPr>
+          <a:lstStyle/>
+          <a:p>
+            <a:pPr algn="ctr"/>
+            <a:r>
+              <a:rPr lang="de-DE" sz="1200" i="1" dirty="0">
+                <a:solidFill>
+                  <a:srgbClr val="FF0000"/>
+                </a:solidFill>
+                <a:latin typeface="CMU Serif" panose="02000603000000000000" pitchFamily="2" charset="0"/>
+                <a:ea typeface="CMU Serif" panose="02000603000000000000" pitchFamily="2" charset="0"/>
+                <a:cs typeface="CMU Serif" panose="02000603000000000000" pitchFamily="2" charset="0"/>
+              </a:rPr>
+              <a:t>F</a:t>
+            </a:r>
+            <a:r>
+              <a:rPr lang="de-DE" sz="1200" baseline="-25000" dirty="0">
+                <a:solidFill>
+                  <a:srgbClr val="FF0000"/>
+                </a:solidFill>
+                <a:latin typeface="CMU Serif" panose="02000603000000000000" pitchFamily="2" charset="0"/>
+                <a:ea typeface="CMU Serif" panose="02000603000000000000" pitchFamily="2" charset="0"/>
+                <a:cs typeface="CMU Serif" panose="02000603000000000000" pitchFamily="2" charset="0"/>
+              </a:rPr>
+              <a:t>K</a:t>
+            </a:r>
+          </a:p>
+        </p:txBody>
+      </p:sp>
+      <p:cxnSp>
+        <p:nvCxnSpPr>
+          <p:cNvPr id="14" name="Gerade Verbindung mit Pfeil 13">
+            <a:extLst>
+              <a:ext uri="{FF2B5EF4-FFF2-40B4-BE49-F238E27FC236}">
+                <a16:creationId xmlns:a16="http://schemas.microsoft.com/office/drawing/2014/main" id="{B9885B1C-6B51-8E65-CAEE-D3131B8F3B07}"/>
+              </a:ext>
+            </a:extLst>
+          </p:cNvPr>
+          <p:cNvCxnSpPr>
+            <a:cxnSpLocks/>
+          </p:cNvCxnSpPr>
+          <p:nvPr/>
+        </p:nvCxnSpPr>
+        <p:spPr>
+          <a:xfrm>
+            <a:off x="384967" y="1806892"/>
+            <a:ext cx="384810" cy="0"/>
+          </a:xfrm>
+          <a:prstGeom prst="straightConnector1">
+            <a:avLst/>
+          </a:prstGeom>
+          <a:ln cap="rnd">
+            <a:solidFill>
+              <a:srgbClr val="0070C0"/>
+            </a:solidFill>
+            <a:round/>
+            <a:headEnd type="none"/>
+            <a:tailEnd type="triangle"/>
+          </a:ln>
+        </p:spPr>
+        <p:style>
+          <a:lnRef idx="2">
+            <a:schemeClr val="accent1"/>
+          </a:lnRef>
+          <a:fillRef idx="0">
+            <a:schemeClr val="accent1"/>
+          </a:fillRef>
+          <a:effectRef idx="1">
+            <a:schemeClr val="accent1"/>
+          </a:effectRef>
+          <a:fontRef idx="minor">
+            <a:schemeClr val="tx1"/>
+          </a:fontRef>
+        </p:style>
+      </p:cxnSp>
+      <p:sp>
+        <p:nvSpPr>
+          <p:cNvPr id="18" name="Textfeld 17">
+            <a:extLst>
+              <a:ext uri="{FF2B5EF4-FFF2-40B4-BE49-F238E27FC236}">
+                <a16:creationId xmlns:a16="http://schemas.microsoft.com/office/drawing/2014/main" id="{1DBE7CB0-3FF8-13F4-11B7-208E537C6997}"/>
+              </a:ext>
+            </a:extLst>
+          </p:cNvPr>
+          <p:cNvSpPr txBox="1"/>
+          <p:nvPr/>
+        </p:nvSpPr>
+        <p:spPr>
+          <a:xfrm>
+            <a:off x="331737" y="1511500"/>
+            <a:ext cx="408249" cy="276999"/>
+          </a:xfrm>
+          <a:prstGeom prst="rect">
+            <a:avLst/>
+          </a:prstGeom>
+          <a:noFill/>
+        </p:spPr>
+        <p:txBody>
+          <a:bodyPr wrap="square" rtlCol="0" anchor="ctr">
+            <a:spAutoFit/>
+          </a:bodyPr>
+          <a:lstStyle/>
+          <a:p>
+            <a:pPr algn="ctr"/>
+            <a:r>
+              <a:rPr lang="de-DE" sz="1200" i="1" dirty="0">
+                <a:solidFill>
+                  <a:srgbClr val="0070C0"/>
+                </a:solidFill>
+                <a:latin typeface="CMU Serif" panose="02000603000000000000" pitchFamily="2" charset="0"/>
+                <a:ea typeface="CMU Serif" panose="02000603000000000000" pitchFamily="2" charset="0"/>
+                <a:cs typeface="CMU Serif" panose="02000603000000000000" pitchFamily="2" charset="0"/>
+              </a:rPr>
+              <a:t>v</a:t>
+            </a:r>
+            <a:endParaRPr lang="de-DE" sz="1200" baseline="-25000" dirty="0">
+              <a:solidFill>
+                <a:srgbClr val="0070C0"/>
+              </a:solidFill>
+              <a:latin typeface="CMU Serif" panose="02000603000000000000" pitchFamily="2" charset="0"/>
+              <a:ea typeface="CMU Serif" panose="02000603000000000000" pitchFamily="2" charset="0"/>
+              <a:cs typeface="CMU Serif" panose="02000603000000000000" pitchFamily="2" charset="0"/>
+            </a:endParaRPr>
+          </a:p>
+        </p:txBody>
+      </p:sp>
+      <p:sp>
+        <p:nvSpPr>
+          <p:cNvPr id="20" name="Textfeld 19">
+            <a:extLst>
+              <a:ext uri="{FF2B5EF4-FFF2-40B4-BE49-F238E27FC236}">
+                <a16:creationId xmlns:a16="http://schemas.microsoft.com/office/drawing/2014/main" id="{20763E28-42D2-6170-B2A4-CAC4211FF7C1}"/>
+              </a:ext>
+            </a:extLst>
+          </p:cNvPr>
+          <p:cNvSpPr txBox="1"/>
+          <p:nvPr/>
+        </p:nvSpPr>
+        <p:spPr>
+          <a:xfrm>
+            <a:off x="2208294" y="1090189"/>
+            <a:ext cx="1272352" cy="923330"/>
+          </a:xfrm>
+          <a:prstGeom prst="rect">
+            <a:avLst/>
+          </a:prstGeom>
+          <a:noFill/>
+        </p:spPr>
+        <p:txBody>
+          <a:bodyPr wrap="square" rtlCol="0" anchor="ctr">
+            <a:spAutoFit/>
+          </a:bodyPr>
+          <a:lstStyle/>
+          <a:p>
+            <a:pPr algn="ctr">
+              <a:lnSpc>
+                <a:spcPct val="150000"/>
+              </a:lnSpc>
+            </a:pPr>
+            <a:r>
+              <a:rPr lang="de-DE" sz="1200" dirty="0">
+                <a:solidFill>
+                  <a:srgbClr val="FF0000"/>
+                </a:solidFill>
+                <a:latin typeface="CMU Serif" panose="02000603000000000000" pitchFamily="2" charset="0"/>
+                <a:ea typeface="CMU Serif" panose="02000603000000000000" pitchFamily="2" charset="0"/>
+                <a:cs typeface="CMU Serif" panose="02000603000000000000" pitchFamily="2" charset="0"/>
+              </a:rPr>
+              <a:t>|</a:t>
+            </a:r>
+            <a:r>
+              <a:rPr lang="de-DE" sz="1200" i="1" dirty="0">
+                <a:solidFill>
+                  <a:srgbClr val="FF0000"/>
+                </a:solidFill>
+                <a:latin typeface="CMU Serif" panose="02000603000000000000" pitchFamily="2" charset="0"/>
+                <a:ea typeface="CMU Serif" panose="02000603000000000000" pitchFamily="2" charset="0"/>
+                <a:cs typeface="CMU Serif" panose="02000603000000000000" pitchFamily="2" charset="0"/>
+              </a:rPr>
+              <a:t>F</a:t>
+            </a:r>
+            <a:r>
+              <a:rPr lang="de-DE" sz="1200" baseline="-25000" dirty="0">
+                <a:solidFill>
+                  <a:srgbClr val="FF0000"/>
+                </a:solidFill>
+                <a:latin typeface="CMU Serif" panose="02000603000000000000" pitchFamily="2" charset="0"/>
+                <a:ea typeface="CMU Serif" panose="02000603000000000000" pitchFamily="2" charset="0"/>
+                <a:cs typeface="CMU Serif" panose="02000603000000000000" pitchFamily="2" charset="0"/>
+              </a:rPr>
+              <a:t>A</a:t>
+            </a:r>
+            <a:r>
+              <a:rPr lang="de-DE" sz="1200" dirty="0">
+                <a:solidFill>
+                  <a:srgbClr val="FF0000"/>
+                </a:solidFill>
+                <a:latin typeface="CMU Serif" panose="02000603000000000000" pitchFamily="2" charset="0"/>
+                <a:ea typeface="CMU Serif" panose="02000603000000000000" pitchFamily="2" charset="0"/>
+                <a:cs typeface="CMU Serif" panose="02000603000000000000" pitchFamily="2" charset="0"/>
+              </a:rPr>
+              <a:t>| = |</a:t>
+            </a:r>
+            <a:r>
+              <a:rPr lang="de-DE" sz="1200" i="1" dirty="0">
+                <a:solidFill>
+                  <a:srgbClr val="FF0000"/>
+                </a:solidFill>
+                <a:latin typeface="CMU Serif" panose="02000603000000000000" pitchFamily="2" charset="0"/>
+                <a:ea typeface="CMU Serif" panose="02000603000000000000" pitchFamily="2" charset="0"/>
+                <a:cs typeface="CMU Serif" panose="02000603000000000000" pitchFamily="2" charset="0"/>
+              </a:rPr>
+              <a:t>F</a:t>
+            </a:r>
+            <a:r>
+              <a:rPr lang="de-DE" sz="1200" baseline="-25000" dirty="0">
+                <a:solidFill>
+                  <a:srgbClr val="FF0000"/>
+                </a:solidFill>
+                <a:latin typeface="CMU Serif" panose="02000603000000000000" pitchFamily="2" charset="0"/>
+                <a:ea typeface="CMU Serif" panose="02000603000000000000" pitchFamily="2" charset="0"/>
+                <a:cs typeface="CMU Serif" panose="02000603000000000000" pitchFamily="2" charset="0"/>
+              </a:rPr>
+              <a:t>K</a:t>
+            </a:r>
+            <a:r>
+              <a:rPr lang="de-DE" sz="1200" dirty="0">
+                <a:solidFill>
+                  <a:srgbClr val="FF0000"/>
+                </a:solidFill>
+                <a:latin typeface="CMU Serif" panose="02000603000000000000" pitchFamily="2" charset="0"/>
+                <a:ea typeface="CMU Serif" panose="02000603000000000000" pitchFamily="2" charset="0"/>
+                <a:cs typeface="CMU Serif" panose="02000603000000000000" pitchFamily="2" charset="0"/>
+              </a:rPr>
+              <a:t>|</a:t>
+            </a:r>
+          </a:p>
+          <a:p>
+            <a:pPr algn="ctr">
+              <a:lnSpc>
+                <a:spcPct val="150000"/>
+              </a:lnSpc>
+            </a:pPr>
+            <a:r>
+              <a:rPr lang="de-DE" sz="1200" dirty="0">
+                <a:latin typeface="CMU Serif" panose="02000603000000000000" pitchFamily="2" charset="0"/>
+                <a:ea typeface="CMU Serif" panose="02000603000000000000" pitchFamily="2" charset="0"/>
+                <a:cs typeface="CMU Serif" panose="02000603000000000000" pitchFamily="2" charset="0"/>
+              </a:rPr>
+              <a:t>Actio = </a:t>
+            </a:r>
+            <a:r>
+              <a:rPr lang="de-DE" sz="1200" dirty="0" err="1">
+                <a:latin typeface="CMU Serif" panose="02000603000000000000" pitchFamily="2" charset="0"/>
+                <a:ea typeface="CMU Serif" panose="02000603000000000000" pitchFamily="2" charset="0"/>
+                <a:cs typeface="CMU Serif" panose="02000603000000000000" pitchFamily="2" charset="0"/>
+              </a:rPr>
+              <a:t>Reactio</a:t>
+            </a:r>
+            <a:endParaRPr lang="de-DE" sz="1200" dirty="0">
+              <a:latin typeface="CMU Serif" panose="02000603000000000000" pitchFamily="2" charset="0"/>
+              <a:ea typeface="CMU Serif" panose="02000603000000000000" pitchFamily="2" charset="0"/>
+              <a:cs typeface="CMU Serif" panose="02000603000000000000" pitchFamily="2" charset="0"/>
+            </a:endParaRPr>
+          </a:p>
+          <a:p>
+            <a:pPr algn="ctr">
+              <a:lnSpc>
+                <a:spcPct val="150000"/>
+              </a:lnSpc>
+            </a:pPr>
+            <a:r>
+              <a:rPr lang="de-DE" sz="1200" dirty="0">
+                <a:latin typeface="CMU Serif" panose="02000603000000000000" pitchFamily="2" charset="0"/>
+                <a:ea typeface="CMU Serif" panose="02000603000000000000" pitchFamily="2" charset="0"/>
+                <a:cs typeface="CMU Serif" panose="02000603000000000000" pitchFamily="2" charset="0"/>
+              </a:rPr>
+              <a:t>Fluid </a:t>
+            </a:r>
+            <a:r>
+              <a:rPr lang="de-DE" sz="1200" dirty="0">
+                <a:latin typeface="Latin Modern Math" panose="02000503000000000000" pitchFamily="50" charset="0"/>
+                <a:ea typeface="Latin Modern Math" panose="02000503000000000000" pitchFamily="50" charset="0"/>
+                <a:cs typeface="CMU Serif" panose="02000603000000000000" pitchFamily="2" charset="0"/>
+              </a:rPr>
+              <a:t>⇔</a:t>
+            </a:r>
+            <a:r>
+              <a:rPr lang="de-DE" sz="1200" dirty="0">
+                <a:latin typeface="CMU Serif" panose="02000603000000000000" pitchFamily="2" charset="0"/>
+                <a:ea typeface="CMU Serif" panose="02000603000000000000" pitchFamily="2" charset="0"/>
+                <a:cs typeface="CMU Serif" panose="02000603000000000000" pitchFamily="2" charset="0"/>
+              </a:rPr>
+              <a:t> Körper</a:t>
+            </a:r>
+          </a:p>
+        </p:txBody>
+      </p:sp>
+      <p:sp>
+        <p:nvSpPr>
+          <p:cNvPr id="21" name="Freihandform: Form 20">
+            <a:extLst>
+              <a:ext uri="{FF2B5EF4-FFF2-40B4-BE49-F238E27FC236}">
+                <a16:creationId xmlns:a16="http://schemas.microsoft.com/office/drawing/2014/main" id="{2132F023-9DD6-EE88-A9B3-AA3AD5D33163}"/>
+              </a:ext>
+            </a:extLst>
+          </p:cNvPr>
+          <p:cNvSpPr/>
+          <p:nvPr/>
+        </p:nvSpPr>
+        <p:spPr>
+          <a:xfrm>
+            <a:off x="2118121" y="2186940"/>
+            <a:ext cx="217409" cy="97155"/>
+          </a:xfrm>
+          <a:custGeom>
+            <a:avLst/>
+            <a:gdLst>
+              <a:gd name="csX0" fmla="*/ 0 w 375285"/>
+              <a:gd name="csY0" fmla="*/ 0 h 177297"/>
+              <a:gd name="csX1" fmla="*/ 188595 w 375285"/>
+              <a:gd name="csY1" fmla="*/ 163830 h 177297"/>
+              <a:gd name="csX2" fmla="*/ 375285 w 375285"/>
+              <a:gd name="csY2" fmla="*/ 156210 h 177297"/>
+            </a:gdLst>
+            <a:ahLst/>
+            <a:cxnLst>
+              <a:cxn ang="0">
+                <a:pos x="csX0" y="csY0"/>
+              </a:cxn>
+              <a:cxn ang="0">
+                <a:pos x="csX1" y="csY1"/>
+              </a:cxn>
+              <a:cxn ang="0">
+                <a:pos x="csX2" y="csY2"/>
+              </a:cxn>
+            </a:cxnLst>
+            <a:rect l="l" t="t" r="r" b="b"/>
+            <a:pathLst>
+              <a:path w="375285" h="177297">
+                <a:moveTo>
+                  <a:pt x="0" y="0"/>
+                </a:moveTo>
+                <a:cubicBezTo>
+                  <a:pt x="63023" y="68897"/>
+                  <a:pt x="126047" y="137795"/>
+                  <a:pt x="188595" y="163830"/>
+                </a:cubicBezTo>
+                <a:cubicBezTo>
+                  <a:pt x="251143" y="189865"/>
+                  <a:pt x="313214" y="173037"/>
+                  <a:pt x="375285" y="156210"/>
+                </a:cubicBezTo>
+              </a:path>
+            </a:pathLst>
+          </a:custGeom>
+          <a:noFill/>
+          <a:ln w="9525" cap="rnd">
+            <a:solidFill>
+              <a:schemeClr val="tx1"/>
+            </a:solidFill>
+            <a:round/>
+          </a:ln>
+        </p:spPr>
+        <p:style>
+          <a:lnRef idx="2">
+            <a:schemeClr val="accent1">
+              <a:shade val="15000"/>
+            </a:schemeClr>
+          </a:lnRef>
+          <a:fillRef idx="1">
+            <a:schemeClr val="accent1"/>
+          </a:fillRef>
+          <a:effectRef idx="0">
+            <a:schemeClr val="accent1"/>
+          </a:effectRef>
+          <a:fontRef idx="minor">
+            <a:schemeClr val="lt1"/>
+          </a:fontRef>
+        </p:style>
+        <p:txBody>
+          <a:bodyPr rtlCol="0" anchor="ctr"/>
+          <a:lstStyle/>
+          <a:p>
+            <a:pPr algn="ctr"/>
+            <a:endParaRPr lang="de-DE"/>
+          </a:p>
+        </p:txBody>
+      </p:sp>
+      <p:sp>
+        <p:nvSpPr>
+          <p:cNvPr id="23" name="Textfeld 22">
+            <a:extLst>
+              <a:ext uri="{FF2B5EF4-FFF2-40B4-BE49-F238E27FC236}">
+                <a16:creationId xmlns:a16="http://schemas.microsoft.com/office/drawing/2014/main" id="{87A47435-D237-7DE1-ABAF-4BE2E5F86E06}"/>
+              </a:ext>
+            </a:extLst>
+          </p:cNvPr>
+          <p:cNvSpPr txBox="1"/>
+          <p:nvPr/>
+        </p:nvSpPr>
+        <p:spPr>
+          <a:xfrm>
+            <a:off x="2253218" y="2162041"/>
+            <a:ext cx="1021715" cy="215444"/>
+          </a:xfrm>
+          <a:prstGeom prst="rect">
+            <a:avLst/>
+          </a:prstGeom>
+          <a:noFill/>
+        </p:spPr>
+        <p:txBody>
+          <a:bodyPr wrap="square" rtlCol="0" anchor="ctr">
+            <a:spAutoFit/>
+          </a:bodyPr>
+          <a:lstStyle/>
+          <a:p>
+            <a:pPr algn="ctr"/>
+            <a:r>
+              <a:rPr lang="de-DE" sz="800" dirty="0">
+                <a:latin typeface="CMU Serif" panose="02000603000000000000" pitchFamily="2" charset="0"/>
+                <a:ea typeface="CMU Serif" panose="02000603000000000000" pitchFamily="2" charset="0"/>
+                <a:cs typeface="CMU Serif" panose="02000603000000000000" pitchFamily="2" charset="0"/>
+              </a:rPr>
+              <a:t>Kontrollvolumen</a:t>
+            </a:r>
+            <a:endParaRPr lang="de-DE" sz="800" baseline="-25000" dirty="0">
+              <a:latin typeface="CMU Serif" panose="02000603000000000000" pitchFamily="2" charset="0"/>
+              <a:ea typeface="CMU Serif" panose="02000603000000000000" pitchFamily="2" charset="0"/>
+              <a:cs typeface="CMU Serif" panose="02000603000000000000" pitchFamily="2" charset="0"/>
+            </a:endParaRPr>
+          </a:p>
+        </p:txBody>
+      </p:sp>
+      <p:cxnSp>
+        <p:nvCxnSpPr>
+          <p:cNvPr id="25" name="Gerader Verbinder 24">
+            <a:extLst>
+              <a:ext uri="{FF2B5EF4-FFF2-40B4-BE49-F238E27FC236}">
+                <a16:creationId xmlns:a16="http://schemas.microsoft.com/office/drawing/2014/main" id="{B43743DD-9ACB-7CB4-D1F1-83D274BB9F47}"/>
+              </a:ext>
+            </a:extLst>
+          </p:cNvPr>
+          <p:cNvCxnSpPr>
+            <a:cxnSpLocks/>
+          </p:cNvCxnSpPr>
+          <p:nvPr/>
+        </p:nvCxnSpPr>
+        <p:spPr>
+          <a:xfrm>
+            <a:off x="1297907" y="1569720"/>
+            <a:ext cx="100363" cy="0"/>
+          </a:xfrm>
+          <a:prstGeom prst="line">
+            <a:avLst/>
+          </a:prstGeom>
+          <a:ln w="6350" cap="rnd">
+            <a:solidFill>
+              <a:srgbClr val="FF0000"/>
+            </a:solidFill>
+            <a:round/>
+          </a:ln>
+        </p:spPr>
+        <p:style>
+          <a:lnRef idx="2">
+            <a:schemeClr val="accent1"/>
+          </a:lnRef>
+          <a:fillRef idx="0">
+            <a:schemeClr val="accent1"/>
+          </a:fillRef>
+          <a:effectRef idx="1">
+            <a:schemeClr val="accent1"/>
+          </a:effectRef>
+          <a:fontRef idx="minor">
+            <a:schemeClr val="tx1"/>
+          </a:fontRef>
+        </p:style>
+      </p:cxnSp>
+      <p:cxnSp>
+        <p:nvCxnSpPr>
+          <p:cNvPr id="27" name="Gerader Verbinder 26">
+            <a:extLst>
+              <a:ext uri="{FF2B5EF4-FFF2-40B4-BE49-F238E27FC236}">
+                <a16:creationId xmlns:a16="http://schemas.microsoft.com/office/drawing/2014/main" id="{BBE2C669-1A64-9F14-F9FD-F30FA62ED364}"/>
+              </a:ext>
+            </a:extLst>
+          </p:cNvPr>
+          <p:cNvCxnSpPr>
+            <a:cxnSpLocks/>
+          </p:cNvCxnSpPr>
+          <p:nvPr/>
+        </p:nvCxnSpPr>
+        <p:spPr>
+          <a:xfrm>
+            <a:off x="1297907" y="2148840"/>
+            <a:ext cx="100363" cy="0"/>
+          </a:xfrm>
+          <a:prstGeom prst="line">
+            <a:avLst/>
+          </a:prstGeom>
+          <a:ln w="6350" cap="rnd">
+            <a:solidFill>
+              <a:srgbClr val="FF0000"/>
+            </a:solidFill>
+            <a:round/>
+          </a:ln>
+        </p:spPr>
+        <p:style>
+          <a:lnRef idx="2">
+            <a:schemeClr val="accent1"/>
+          </a:lnRef>
+          <a:fillRef idx="0">
+            <a:schemeClr val="accent1"/>
+          </a:fillRef>
+          <a:effectRef idx="1">
+            <a:schemeClr val="accent1"/>
+          </a:effectRef>
+          <a:fontRef idx="minor">
+            <a:schemeClr val="tx1"/>
+          </a:fontRef>
+        </p:style>
+      </p:cxnSp>
+      <p:cxnSp>
+        <p:nvCxnSpPr>
+          <p:cNvPr id="28" name="Gerader Verbinder 27">
+            <a:extLst>
+              <a:ext uri="{FF2B5EF4-FFF2-40B4-BE49-F238E27FC236}">
+                <a16:creationId xmlns:a16="http://schemas.microsoft.com/office/drawing/2014/main" id="{3CCF5329-3422-BEB2-FD67-F55801D233E9}"/>
+              </a:ext>
+            </a:extLst>
+          </p:cNvPr>
+          <p:cNvCxnSpPr>
+            <a:cxnSpLocks/>
+          </p:cNvCxnSpPr>
+          <p:nvPr/>
+        </p:nvCxnSpPr>
+        <p:spPr>
+          <a:xfrm>
+            <a:off x="2519012" y="1358265"/>
+            <a:ext cx="100363" cy="0"/>
+          </a:xfrm>
+          <a:prstGeom prst="line">
+            <a:avLst/>
+          </a:prstGeom>
+          <a:ln w="6350" cap="rnd">
+            <a:solidFill>
+              <a:srgbClr val="FF0000"/>
+            </a:solidFill>
+            <a:round/>
+          </a:ln>
+        </p:spPr>
+        <p:style>
+          <a:lnRef idx="2">
+            <a:schemeClr val="accent1"/>
+          </a:lnRef>
+          <a:fillRef idx="0">
+            <a:schemeClr val="accent1"/>
+          </a:fillRef>
+          <a:effectRef idx="1">
+            <a:schemeClr val="accent1"/>
+          </a:effectRef>
+          <a:fontRef idx="minor">
+            <a:schemeClr val="tx1"/>
+          </a:fontRef>
+        </p:style>
+      </p:cxnSp>
+      <p:cxnSp>
+        <p:nvCxnSpPr>
+          <p:cNvPr id="29" name="Gerader Verbinder 28">
+            <a:extLst>
+              <a:ext uri="{FF2B5EF4-FFF2-40B4-BE49-F238E27FC236}">
+                <a16:creationId xmlns:a16="http://schemas.microsoft.com/office/drawing/2014/main" id="{EA929A1A-89AC-3C09-BBE6-88782F6E9D24}"/>
+              </a:ext>
+            </a:extLst>
+          </p:cNvPr>
+          <p:cNvCxnSpPr>
+            <a:cxnSpLocks/>
+          </p:cNvCxnSpPr>
+          <p:nvPr/>
+        </p:nvCxnSpPr>
+        <p:spPr>
+          <a:xfrm>
+            <a:off x="3002882" y="1358265"/>
+            <a:ext cx="100363" cy="0"/>
+          </a:xfrm>
+          <a:prstGeom prst="line">
+            <a:avLst/>
+          </a:prstGeom>
+          <a:ln w="6350" cap="rnd">
+            <a:solidFill>
+              <a:srgbClr val="FF0000"/>
+            </a:solidFill>
+            <a:round/>
+          </a:ln>
+        </p:spPr>
+        <p:style>
+          <a:lnRef idx="2">
+            <a:schemeClr val="accent1"/>
+          </a:lnRef>
+          <a:fillRef idx="0">
+            <a:schemeClr val="accent1"/>
+          </a:fillRef>
+          <a:effectRef idx="1">
+            <a:schemeClr val="accent1"/>
+          </a:effectRef>
+          <a:fontRef idx="minor">
+            <a:schemeClr val="tx1"/>
+          </a:fontRef>
+        </p:style>
+      </p:cxnSp>
+      <p:cxnSp>
+        <p:nvCxnSpPr>
+          <p:cNvPr id="30" name="Gerader Verbinder 29">
+            <a:extLst>
+              <a:ext uri="{FF2B5EF4-FFF2-40B4-BE49-F238E27FC236}">
+                <a16:creationId xmlns:a16="http://schemas.microsoft.com/office/drawing/2014/main" id="{5218D696-6151-2C82-5FC6-489B3254D42D}"/>
+              </a:ext>
+            </a:extLst>
+          </p:cNvPr>
+          <p:cNvCxnSpPr>
+            <a:cxnSpLocks/>
+          </p:cNvCxnSpPr>
+          <p:nvPr/>
+        </p:nvCxnSpPr>
+        <p:spPr>
+          <a:xfrm>
+            <a:off x="507332" y="1708785"/>
+            <a:ext cx="73693" cy="0"/>
+          </a:xfrm>
+          <a:prstGeom prst="line">
+            <a:avLst/>
+          </a:prstGeom>
+          <a:ln w="6350" cap="rnd">
+            <a:solidFill>
+              <a:srgbClr val="0070C0"/>
+            </a:solidFill>
+            <a:round/>
+          </a:ln>
+        </p:spPr>
+        <p:style>
+          <a:lnRef idx="2">
+            <a:schemeClr val="accent1"/>
+          </a:lnRef>
+          <a:fillRef idx="0">
+            <a:schemeClr val="accent1"/>
+          </a:fillRef>
+          <a:effectRef idx="1">
+            <a:schemeClr val="accent1"/>
+          </a:effectRef>
+          <a:fontRef idx="minor">
+            <a:schemeClr val="tx1"/>
+          </a:fontRef>
+        </p:style>
+      </p:cxnSp>
     </p:spTree>
     <p:extLst>
       <p:ext uri="{BB962C8B-B14F-4D97-AF65-F5344CB8AC3E}">
         <p14:creationId xmlns:p14="http://schemas.microsoft.com/office/powerpoint/2010/main" val="831582293"/>
+      </p:ext>
+    </p:extLst>
+  </p:cSld>
+  <p:clrMapOvr>
+    <a:masterClrMapping/>
+  </p:clrMapOvr>
+</p:sld>
+</file>
+
+<file path=ppt/slides/slide8.xml><?xml version="1.0" encoding="utf-8"?>
+<p:sld xmlns:a="http://schemas.openxmlformats.org/drawingml/2006/main" xmlns:r="http://schemas.openxmlformats.org/officeDocument/2006/relationships" xmlns:p="http://schemas.openxmlformats.org/presentationml/2006/main">
+  <p:cSld>
+    <p:spTree>
+      <p:nvGrpSpPr>
+        <p:cNvPr id="1" name="">
+          <a:extLst>
+            <a:ext uri="{FF2B5EF4-FFF2-40B4-BE49-F238E27FC236}">
+              <a16:creationId xmlns:a16="http://schemas.microsoft.com/office/drawing/2014/main" id="{AFBDDB1C-BBDA-2CED-C5ED-23B774824AAF}"/>
+            </a:ext>
+          </a:extLst>
+        </p:cNvPr>
+        <p:cNvGrpSpPr/>
+        <p:nvPr/>
+      </p:nvGrpSpPr>
+      <p:grpSpPr>
+        <a:xfrm>
+          <a:off x="0" y="0"/>
+          <a:ext cx="0" cy="0"/>
+          <a:chOff x="0" y="0"/>
+          <a:chExt cx="0" cy="0"/>
+        </a:xfrm>
+      </p:grpSpPr>
+      <p:sp>
+        <p:nvSpPr>
+          <p:cNvPr id="8" name="Rechteck 7">
+            <a:extLst>
+              <a:ext uri="{FF2B5EF4-FFF2-40B4-BE49-F238E27FC236}">
+                <a16:creationId xmlns:a16="http://schemas.microsoft.com/office/drawing/2014/main" id="{BEEF1FE8-54E3-FAAE-341C-D6CCBC6A3E48}"/>
+              </a:ext>
+            </a:extLst>
+          </p:cNvPr>
+          <p:cNvSpPr/>
+          <p:nvPr/>
+        </p:nvSpPr>
+        <p:spPr>
+          <a:xfrm>
+            <a:off x="806744" y="1320702"/>
+            <a:ext cx="1835943" cy="872429"/>
+          </a:xfrm>
+          <a:prstGeom prst="rect">
+            <a:avLst/>
+          </a:prstGeom>
+          <a:noFill/>
+          <a:ln w="12700" cap="rnd">
+            <a:solidFill>
+              <a:schemeClr val="tx1"/>
+            </a:solidFill>
+            <a:prstDash val="lgDashDot"/>
+            <a:round/>
+          </a:ln>
+        </p:spPr>
+        <p:style>
+          <a:lnRef idx="2">
+            <a:schemeClr val="accent1">
+              <a:shade val="15000"/>
+            </a:schemeClr>
+          </a:lnRef>
+          <a:fillRef idx="1">
+            <a:schemeClr val="accent1"/>
+          </a:fillRef>
+          <a:effectRef idx="0">
+            <a:schemeClr val="accent1"/>
+          </a:effectRef>
+          <a:fontRef idx="minor">
+            <a:schemeClr val="lt1"/>
+          </a:fontRef>
+        </p:style>
+        <p:txBody>
+          <a:bodyPr rtlCol="0" anchor="ctr"/>
+          <a:lstStyle/>
+          <a:p>
+            <a:pPr algn="ctr"/>
+            <a:endParaRPr lang="de-DE"/>
+          </a:p>
+        </p:txBody>
+      </p:sp>
+      <p:cxnSp>
+        <p:nvCxnSpPr>
+          <p:cNvPr id="19" name="Gerade Verbindung mit Pfeil 18">
+            <a:extLst>
+              <a:ext uri="{FF2B5EF4-FFF2-40B4-BE49-F238E27FC236}">
+                <a16:creationId xmlns:a16="http://schemas.microsoft.com/office/drawing/2014/main" id="{EEB2C29E-2EDC-F667-2345-14FAAA7362E1}"/>
+              </a:ext>
+            </a:extLst>
+          </p:cNvPr>
+          <p:cNvCxnSpPr>
+            <a:cxnSpLocks/>
+          </p:cNvCxnSpPr>
+          <p:nvPr/>
+        </p:nvCxnSpPr>
+        <p:spPr>
+          <a:xfrm>
+            <a:off x="1241799" y="2054621"/>
+            <a:ext cx="322580" cy="0"/>
+          </a:xfrm>
+          <a:prstGeom prst="straightConnector1">
+            <a:avLst/>
+          </a:prstGeom>
+          <a:ln cap="rnd">
+            <a:solidFill>
+              <a:srgbClr val="0070C0"/>
+            </a:solidFill>
+            <a:round/>
+            <a:headEnd type="none"/>
+            <a:tailEnd type="triangle"/>
+          </a:ln>
+        </p:spPr>
+        <p:style>
+          <a:lnRef idx="2">
+            <a:schemeClr val="accent1"/>
+          </a:lnRef>
+          <a:fillRef idx="0">
+            <a:schemeClr val="accent1"/>
+          </a:fillRef>
+          <a:effectRef idx="1">
+            <a:schemeClr val="accent1"/>
+          </a:effectRef>
+          <a:fontRef idx="minor">
+            <a:schemeClr val="tx1"/>
+          </a:fontRef>
+        </p:style>
+      </p:cxnSp>
+      <p:cxnSp>
+        <p:nvCxnSpPr>
+          <p:cNvPr id="21" name="Gerade Verbindung mit Pfeil 20">
+            <a:extLst>
+              <a:ext uri="{FF2B5EF4-FFF2-40B4-BE49-F238E27FC236}">
+                <a16:creationId xmlns:a16="http://schemas.microsoft.com/office/drawing/2014/main" id="{A0E33B43-C083-B5B8-593A-6FDDB7E1F665}"/>
+              </a:ext>
+            </a:extLst>
+          </p:cNvPr>
+          <p:cNvCxnSpPr>
+            <a:cxnSpLocks/>
+          </p:cNvCxnSpPr>
+          <p:nvPr/>
+        </p:nvCxnSpPr>
+        <p:spPr>
+          <a:xfrm>
+            <a:off x="1241799" y="1900068"/>
+            <a:ext cx="441960" cy="0"/>
+          </a:xfrm>
+          <a:prstGeom prst="straightConnector1">
+            <a:avLst/>
+          </a:prstGeom>
+          <a:ln cap="rnd">
+            <a:solidFill>
+              <a:srgbClr val="0070C0"/>
+            </a:solidFill>
+            <a:round/>
+            <a:headEnd type="none"/>
+            <a:tailEnd type="triangle"/>
+          </a:ln>
+        </p:spPr>
+        <p:style>
+          <a:lnRef idx="2">
+            <a:schemeClr val="accent1"/>
+          </a:lnRef>
+          <a:fillRef idx="0">
+            <a:schemeClr val="accent1"/>
+          </a:fillRef>
+          <a:effectRef idx="1">
+            <a:schemeClr val="accent1"/>
+          </a:effectRef>
+          <a:fontRef idx="minor">
+            <a:schemeClr val="tx1"/>
+          </a:fontRef>
+        </p:style>
+      </p:cxnSp>
+      <p:cxnSp>
+        <p:nvCxnSpPr>
+          <p:cNvPr id="23" name="Gerade Verbindung mit Pfeil 22">
+            <a:extLst>
+              <a:ext uri="{FF2B5EF4-FFF2-40B4-BE49-F238E27FC236}">
+                <a16:creationId xmlns:a16="http://schemas.microsoft.com/office/drawing/2014/main" id="{3ADD4CB1-3F9B-FBA8-2072-D021EC4D49E2}"/>
+              </a:ext>
+            </a:extLst>
+          </p:cNvPr>
+          <p:cNvCxnSpPr>
+            <a:cxnSpLocks/>
+          </p:cNvCxnSpPr>
+          <p:nvPr/>
+        </p:nvCxnSpPr>
+        <p:spPr>
+          <a:xfrm>
+            <a:off x="1241799" y="1745513"/>
+            <a:ext cx="500380" cy="0"/>
+          </a:xfrm>
+          <a:prstGeom prst="straightConnector1">
+            <a:avLst/>
+          </a:prstGeom>
+          <a:ln cap="rnd">
+            <a:solidFill>
+              <a:srgbClr val="0070C0"/>
+            </a:solidFill>
+            <a:round/>
+            <a:headEnd type="none"/>
+            <a:tailEnd type="triangle"/>
+          </a:ln>
+        </p:spPr>
+        <p:style>
+          <a:lnRef idx="2">
+            <a:schemeClr val="accent1"/>
+          </a:lnRef>
+          <a:fillRef idx="0">
+            <a:schemeClr val="accent1"/>
+          </a:fillRef>
+          <a:effectRef idx="1">
+            <a:schemeClr val="accent1"/>
+          </a:effectRef>
+          <a:fontRef idx="minor">
+            <a:schemeClr val="tx1"/>
+          </a:fontRef>
+        </p:style>
+      </p:cxnSp>
+      <p:cxnSp>
+        <p:nvCxnSpPr>
+          <p:cNvPr id="25" name="Gerade Verbindung mit Pfeil 24">
+            <a:extLst>
+              <a:ext uri="{FF2B5EF4-FFF2-40B4-BE49-F238E27FC236}">
+                <a16:creationId xmlns:a16="http://schemas.microsoft.com/office/drawing/2014/main" id="{8FA6542E-217B-4C1F-6D23-50BDFF3B982D}"/>
+              </a:ext>
+            </a:extLst>
+          </p:cNvPr>
+          <p:cNvCxnSpPr>
+            <a:cxnSpLocks/>
+          </p:cNvCxnSpPr>
+          <p:nvPr/>
+        </p:nvCxnSpPr>
+        <p:spPr>
+          <a:xfrm>
+            <a:off x="1241799" y="1590958"/>
+            <a:ext cx="528320" cy="0"/>
+          </a:xfrm>
+          <a:prstGeom prst="straightConnector1">
+            <a:avLst/>
+          </a:prstGeom>
+          <a:ln cap="rnd">
+            <a:solidFill>
+              <a:srgbClr val="0070C0"/>
+            </a:solidFill>
+            <a:round/>
+            <a:headEnd type="none"/>
+            <a:tailEnd type="triangle"/>
+          </a:ln>
+        </p:spPr>
+        <p:style>
+          <a:lnRef idx="2">
+            <a:schemeClr val="accent1"/>
+          </a:lnRef>
+          <a:fillRef idx="0">
+            <a:schemeClr val="accent1"/>
+          </a:fillRef>
+          <a:effectRef idx="1">
+            <a:schemeClr val="accent1"/>
+          </a:effectRef>
+          <a:fontRef idx="minor">
+            <a:schemeClr val="tx1"/>
+          </a:fontRef>
+        </p:style>
+      </p:cxnSp>
+      <p:cxnSp>
+        <p:nvCxnSpPr>
+          <p:cNvPr id="27" name="Gerade Verbindung mit Pfeil 26">
+            <a:extLst>
+              <a:ext uri="{FF2B5EF4-FFF2-40B4-BE49-F238E27FC236}">
+                <a16:creationId xmlns:a16="http://schemas.microsoft.com/office/drawing/2014/main" id="{3EF97753-1734-D219-373A-9DBDA573ED12}"/>
+              </a:ext>
+            </a:extLst>
+          </p:cNvPr>
+          <p:cNvCxnSpPr>
+            <a:cxnSpLocks/>
+          </p:cNvCxnSpPr>
+          <p:nvPr/>
+        </p:nvCxnSpPr>
+        <p:spPr>
+          <a:xfrm>
+            <a:off x="1241799" y="1436403"/>
+            <a:ext cx="543560" cy="0"/>
+          </a:xfrm>
+          <a:prstGeom prst="straightConnector1">
+            <a:avLst/>
+          </a:prstGeom>
+          <a:ln cap="rnd">
+            <a:solidFill>
+              <a:srgbClr val="0070C0"/>
+            </a:solidFill>
+            <a:round/>
+            <a:headEnd type="none"/>
+            <a:tailEnd type="triangle"/>
+          </a:ln>
+        </p:spPr>
+        <p:style>
+          <a:lnRef idx="2">
+            <a:schemeClr val="accent1"/>
+          </a:lnRef>
+          <a:fillRef idx="0">
+            <a:schemeClr val="accent1"/>
+          </a:fillRef>
+          <a:effectRef idx="1">
+            <a:schemeClr val="accent1"/>
+          </a:effectRef>
+          <a:fontRef idx="minor">
+            <a:schemeClr val="tx1"/>
+          </a:fontRef>
+        </p:style>
+      </p:cxnSp>
+      <p:cxnSp>
+        <p:nvCxnSpPr>
+          <p:cNvPr id="29" name="Gerade Verbindung mit Pfeil 28">
+            <a:extLst>
+              <a:ext uri="{FF2B5EF4-FFF2-40B4-BE49-F238E27FC236}">
+                <a16:creationId xmlns:a16="http://schemas.microsoft.com/office/drawing/2014/main" id="{BA9EE248-2314-243D-9B3A-074978F623FC}"/>
+              </a:ext>
+            </a:extLst>
+          </p:cNvPr>
+          <p:cNvCxnSpPr>
+            <a:cxnSpLocks/>
+          </p:cNvCxnSpPr>
+          <p:nvPr/>
+        </p:nvCxnSpPr>
+        <p:spPr>
+          <a:xfrm>
+            <a:off x="1241799" y="1281848"/>
+            <a:ext cx="548640" cy="0"/>
+          </a:xfrm>
+          <a:prstGeom prst="straightConnector1">
+            <a:avLst/>
+          </a:prstGeom>
+          <a:ln cap="rnd">
+            <a:solidFill>
+              <a:srgbClr val="0070C0"/>
+            </a:solidFill>
+            <a:round/>
+            <a:headEnd type="none"/>
+            <a:tailEnd type="triangle"/>
+          </a:ln>
+        </p:spPr>
+        <p:style>
+          <a:lnRef idx="2">
+            <a:schemeClr val="accent1"/>
+          </a:lnRef>
+          <a:fillRef idx="0">
+            <a:schemeClr val="accent1"/>
+          </a:fillRef>
+          <a:effectRef idx="1">
+            <a:schemeClr val="accent1"/>
+          </a:effectRef>
+          <a:fontRef idx="minor">
+            <a:schemeClr val="tx1"/>
+          </a:fontRef>
+        </p:style>
+      </p:cxnSp>
+      <p:sp>
+        <p:nvSpPr>
+          <p:cNvPr id="18" name="Freihandform: Form 17">
+            <a:extLst>
+              <a:ext uri="{FF2B5EF4-FFF2-40B4-BE49-F238E27FC236}">
+                <a16:creationId xmlns:a16="http://schemas.microsoft.com/office/drawing/2014/main" id="{5FAF9D8E-32A1-CCB4-24E6-EEBCDFC337AE}"/>
+              </a:ext>
+            </a:extLst>
+          </p:cNvPr>
+          <p:cNvSpPr/>
+          <p:nvPr/>
+        </p:nvSpPr>
+        <p:spPr>
+          <a:xfrm>
+            <a:off x="1244339" y="1195308"/>
+            <a:ext cx="546100" cy="1000760"/>
+          </a:xfrm>
+          <a:custGeom>
+            <a:avLst/>
+            <a:gdLst>
+              <a:gd name="csX0" fmla="*/ 0 w 546100"/>
+              <a:gd name="csY0" fmla="*/ 1000760 h 1000760"/>
+              <a:gd name="csX1" fmla="*/ 340360 w 546100"/>
+              <a:gd name="csY1" fmla="*/ 843280 h 1000760"/>
+              <a:gd name="csX2" fmla="*/ 508000 w 546100"/>
+              <a:gd name="csY2" fmla="*/ 505460 h 1000760"/>
+              <a:gd name="csX3" fmla="*/ 546100 w 546100"/>
+              <a:gd name="csY3" fmla="*/ 0 h 1000760"/>
+            </a:gdLst>
+            <a:ahLst/>
+            <a:cxnLst>
+              <a:cxn ang="0">
+                <a:pos x="csX0" y="csY0"/>
+              </a:cxn>
+              <a:cxn ang="0">
+                <a:pos x="csX1" y="csY1"/>
+              </a:cxn>
+              <a:cxn ang="0">
+                <a:pos x="csX2" y="csY2"/>
+              </a:cxn>
+              <a:cxn ang="0">
+                <a:pos x="csX3" y="csY3"/>
+              </a:cxn>
+            </a:cxnLst>
+            <a:rect l="l" t="t" r="r" b="b"/>
+            <a:pathLst>
+              <a:path w="546100" h="1000760">
+                <a:moveTo>
+                  <a:pt x="0" y="1000760"/>
+                </a:moveTo>
+                <a:cubicBezTo>
+                  <a:pt x="102235" y="976418"/>
+                  <a:pt x="255693" y="925830"/>
+                  <a:pt x="340360" y="843280"/>
+                </a:cubicBezTo>
+                <a:cubicBezTo>
+                  <a:pt x="425027" y="760730"/>
+                  <a:pt x="479637" y="643890"/>
+                  <a:pt x="508000" y="505460"/>
+                </a:cubicBezTo>
+                <a:cubicBezTo>
+                  <a:pt x="536363" y="367030"/>
+                  <a:pt x="543771" y="189865"/>
+                  <a:pt x="546100" y="0"/>
+                </a:cubicBezTo>
+              </a:path>
+            </a:pathLst>
+          </a:custGeom>
+          <a:noFill/>
+          <a:ln cap="rnd">
+            <a:solidFill>
+              <a:srgbClr val="0070C0"/>
+            </a:solidFill>
+            <a:round/>
+          </a:ln>
+        </p:spPr>
+        <p:style>
+          <a:lnRef idx="2">
+            <a:schemeClr val="accent1">
+              <a:shade val="15000"/>
+            </a:schemeClr>
+          </a:lnRef>
+          <a:fillRef idx="1">
+            <a:schemeClr val="accent1"/>
+          </a:fillRef>
+          <a:effectRef idx="0">
+            <a:schemeClr val="accent1"/>
+          </a:effectRef>
+          <a:fontRef idx="minor">
+            <a:schemeClr val="lt1"/>
+          </a:fontRef>
+        </p:style>
+        <p:txBody>
+          <a:bodyPr rtlCol="0" anchor="ctr"/>
+          <a:lstStyle/>
+          <a:p>
+            <a:pPr algn="ctr"/>
+            <a:endParaRPr lang="de-DE"/>
+          </a:p>
+        </p:txBody>
+      </p:sp>
+      <p:cxnSp>
+        <p:nvCxnSpPr>
+          <p:cNvPr id="15" name="Gerader Verbinder 14">
+            <a:extLst>
+              <a:ext uri="{FF2B5EF4-FFF2-40B4-BE49-F238E27FC236}">
+                <a16:creationId xmlns:a16="http://schemas.microsoft.com/office/drawing/2014/main" id="{0E25042D-7B4C-80BE-E2BC-0E88EB000337}"/>
+              </a:ext>
+            </a:extLst>
+          </p:cNvPr>
+          <p:cNvCxnSpPr>
+            <a:cxnSpLocks/>
+          </p:cNvCxnSpPr>
+          <p:nvPr/>
+        </p:nvCxnSpPr>
+        <p:spPr>
+          <a:xfrm flipV="1">
+            <a:off x="1241799" y="1200388"/>
+            <a:ext cx="0" cy="992743"/>
+          </a:xfrm>
+          <a:prstGeom prst="line">
+            <a:avLst/>
+          </a:prstGeom>
+          <a:ln cap="rnd">
+            <a:solidFill>
+              <a:srgbClr val="0070C0"/>
+            </a:solidFill>
+            <a:round/>
+          </a:ln>
+        </p:spPr>
+        <p:style>
+          <a:lnRef idx="2">
+            <a:schemeClr val="accent1"/>
+          </a:lnRef>
+          <a:fillRef idx="0">
+            <a:schemeClr val="accent1"/>
+          </a:fillRef>
+          <a:effectRef idx="1">
+            <a:schemeClr val="accent1"/>
+          </a:effectRef>
+          <a:fontRef idx="minor">
+            <a:schemeClr val="tx1"/>
+          </a:fontRef>
+        </p:style>
+      </p:cxnSp>
+      <p:sp>
+        <p:nvSpPr>
+          <p:cNvPr id="3" name="Rechteck 2">
+            <a:extLst>
+              <a:ext uri="{FF2B5EF4-FFF2-40B4-BE49-F238E27FC236}">
+                <a16:creationId xmlns:a16="http://schemas.microsoft.com/office/drawing/2014/main" id="{D959A433-CFDC-E748-9D3C-DEE89E321806}"/>
+              </a:ext>
+            </a:extLst>
+          </p:cNvPr>
+          <p:cNvSpPr/>
+          <p:nvPr/>
+        </p:nvSpPr>
+        <p:spPr>
+          <a:xfrm>
+            <a:off x="338829" y="2193133"/>
+            <a:ext cx="2771775" cy="274318"/>
+          </a:xfrm>
+          <a:prstGeom prst="rect">
+            <a:avLst/>
+          </a:prstGeom>
+          <a:solidFill>
+            <a:schemeClr val="bg1">
+              <a:lumMod val="75000"/>
+            </a:schemeClr>
+          </a:solidFill>
+          <a:ln>
+            <a:noFill/>
+          </a:ln>
+        </p:spPr>
+        <p:style>
+          <a:lnRef idx="2">
+            <a:schemeClr val="accent1">
+              <a:shade val="15000"/>
+            </a:schemeClr>
+          </a:lnRef>
+          <a:fillRef idx="1">
+            <a:schemeClr val="accent1"/>
+          </a:fillRef>
+          <a:effectRef idx="0">
+            <a:schemeClr val="accent1"/>
+          </a:effectRef>
+          <a:fontRef idx="minor">
+            <a:schemeClr val="lt1"/>
+          </a:fontRef>
+        </p:style>
+        <p:txBody>
+          <a:bodyPr rtlCol="0" anchor="ctr"/>
+          <a:lstStyle/>
+          <a:p>
+            <a:pPr algn="ctr"/>
+            <a:endParaRPr lang="de-DE" sz="1200" dirty="0">
+              <a:solidFill>
+                <a:schemeClr val="tx1"/>
+              </a:solidFill>
+              <a:latin typeface="CMU Serif" panose="02000603000000000000" pitchFamily="2" charset="0"/>
+              <a:ea typeface="CMU Serif" panose="02000603000000000000" pitchFamily="2" charset="0"/>
+              <a:cs typeface="CMU Serif" panose="02000603000000000000" pitchFamily="2" charset="0"/>
+            </a:endParaRPr>
+          </a:p>
+        </p:txBody>
+      </p:sp>
+      <p:cxnSp>
+        <p:nvCxnSpPr>
+          <p:cNvPr id="4" name="Gerader Verbinder 3">
+            <a:extLst>
+              <a:ext uri="{FF2B5EF4-FFF2-40B4-BE49-F238E27FC236}">
+                <a16:creationId xmlns:a16="http://schemas.microsoft.com/office/drawing/2014/main" id="{BC17D54C-95F2-D764-231F-FD2390E7B3EE}"/>
+              </a:ext>
+            </a:extLst>
+          </p:cNvPr>
+          <p:cNvCxnSpPr>
+            <a:cxnSpLocks/>
+          </p:cNvCxnSpPr>
+          <p:nvPr/>
+        </p:nvCxnSpPr>
+        <p:spPr>
+          <a:xfrm flipH="1">
+            <a:off x="347878" y="2193132"/>
+            <a:ext cx="2753915" cy="0"/>
+          </a:xfrm>
+          <a:prstGeom prst="line">
+            <a:avLst/>
+          </a:prstGeom>
+          <a:ln cap="rnd">
+            <a:solidFill>
+              <a:schemeClr val="tx1">
+                <a:lumMod val="75000"/>
+                <a:lumOff val="25000"/>
+              </a:schemeClr>
+            </a:solidFill>
+            <a:round/>
+          </a:ln>
+        </p:spPr>
+        <p:style>
+          <a:lnRef idx="2">
+            <a:schemeClr val="accent1"/>
+          </a:lnRef>
+          <a:fillRef idx="0">
+            <a:schemeClr val="accent1"/>
+          </a:fillRef>
+          <a:effectRef idx="1">
+            <a:schemeClr val="accent1"/>
+          </a:effectRef>
+          <a:fontRef idx="minor">
+            <a:schemeClr val="tx1"/>
+          </a:fontRef>
+        </p:style>
+      </p:cxnSp>
+      <p:cxnSp>
+        <p:nvCxnSpPr>
+          <p:cNvPr id="11" name="Gerade Verbindung mit Pfeil 10">
+            <a:extLst>
+              <a:ext uri="{FF2B5EF4-FFF2-40B4-BE49-F238E27FC236}">
+                <a16:creationId xmlns:a16="http://schemas.microsoft.com/office/drawing/2014/main" id="{54EA27D7-981C-FBC1-352B-60D2DA994899}"/>
+              </a:ext>
+            </a:extLst>
+          </p:cNvPr>
+          <p:cNvCxnSpPr>
+            <a:cxnSpLocks/>
+          </p:cNvCxnSpPr>
+          <p:nvPr/>
+        </p:nvCxnSpPr>
+        <p:spPr>
+          <a:xfrm>
+            <a:off x="222066" y="1767601"/>
+            <a:ext cx="384810" cy="0"/>
+          </a:xfrm>
+          <a:prstGeom prst="straightConnector1">
+            <a:avLst/>
+          </a:prstGeom>
+          <a:ln cap="rnd">
+            <a:solidFill>
+              <a:srgbClr val="0070C0"/>
+            </a:solidFill>
+            <a:round/>
+            <a:headEnd type="none"/>
+            <a:tailEnd type="triangle"/>
+          </a:ln>
+        </p:spPr>
+        <p:style>
+          <a:lnRef idx="2">
+            <a:schemeClr val="accent1"/>
+          </a:lnRef>
+          <a:fillRef idx="0">
+            <a:schemeClr val="accent1"/>
+          </a:fillRef>
+          <a:effectRef idx="1">
+            <a:schemeClr val="accent1"/>
+          </a:effectRef>
+          <a:fontRef idx="minor">
+            <a:schemeClr val="tx1"/>
+          </a:fontRef>
+        </p:style>
+      </p:cxnSp>
+      <p:sp>
+        <p:nvSpPr>
+          <p:cNvPr id="12" name="Textfeld 11">
+            <a:extLst>
+              <a:ext uri="{FF2B5EF4-FFF2-40B4-BE49-F238E27FC236}">
+                <a16:creationId xmlns:a16="http://schemas.microsoft.com/office/drawing/2014/main" id="{A3CD8FB0-2D10-7876-68D4-F6F46204BB2A}"/>
+              </a:ext>
+            </a:extLst>
+          </p:cNvPr>
+          <p:cNvSpPr txBox="1"/>
+          <p:nvPr/>
+        </p:nvSpPr>
+        <p:spPr>
+          <a:xfrm>
+            <a:off x="168836" y="1472209"/>
+            <a:ext cx="408249" cy="276999"/>
+          </a:xfrm>
+          <a:prstGeom prst="rect">
+            <a:avLst/>
+          </a:prstGeom>
+          <a:noFill/>
+        </p:spPr>
+        <p:txBody>
+          <a:bodyPr wrap="square" rtlCol="0" anchor="ctr">
+            <a:spAutoFit/>
+          </a:bodyPr>
+          <a:lstStyle/>
+          <a:p>
+            <a:pPr algn="ctr"/>
+            <a:r>
+              <a:rPr lang="de-DE" sz="1200" i="1" dirty="0">
+                <a:solidFill>
+                  <a:srgbClr val="0070C0"/>
+                </a:solidFill>
+                <a:latin typeface="CMU Serif" panose="02000603000000000000" pitchFamily="2" charset="0"/>
+                <a:ea typeface="CMU Serif" panose="02000603000000000000" pitchFamily="2" charset="0"/>
+                <a:cs typeface="CMU Serif" panose="02000603000000000000" pitchFamily="2" charset="0"/>
+              </a:rPr>
+              <a:t>v</a:t>
+            </a:r>
+            <a:endParaRPr lang="de-DE" sz="1200" baseline="-25000" dirty="0">
+              <a:solidFill>
+                <a:srgbClr val="0070C0"/>
+              </a:solidFill>
+              <a:latin typeface="CMU Serif" panose="02000603000000000000" pitchFamily="2" charset="0"/>
+              <a:ea typeface="CMU Serif" panose="02000603000000000000" pitchFamily="2" charset="0"/>
+              <a:cs typeface="CMU Serif" panose="02000603000000000000" pitchFamily="2" charset="0"/>
+            </a:endParaRPr>
+          </a:p>
+        </p:txBody>
+      </p:sp>
+      <p:cxnSp>
+        <p:nvCxnSpPr>
+          <p:cNvPr id="13" name="Gerader Verbinder 12">
+            <a:extLst>
+              <a:ext uri="{FF2B5EF4-FFF2-40B4-BE49-F238E27FC236}">
+                <a16:creationId xmlns:a16="http://schemas.microsoft.com/office/drawing/2014/main" id="{53096510-EB3A-921A-E183-57DC4954D69D}"/>
+              </a:ext>
+            </a:extLst>
+          </p:cNvPr>
+          <p:cNvCxnSpPr>
+            <a:cxnSpLocks/>
+          </p:cNvCxnSpPr>
+          <p:nvPr/>
+        </p:nvCxnSpPr>
+        <p:spPr>
+          <a:xfrm>
+            <a:off x="344431" y="1669494"/>
+            <a:ext cx="73693" cy="0"/>
+          </a:xfrm>
+          <a:prstGeom prst="line">
+            <a:avLst/>
+          </a:prstGeom>
+          <a:ln w="6350" cap="rnd">
+            <a:solidFill>
+              <a:srgbClr val="0070C0"/>
+            </a:solidFill>
+            <a:round/>
+          </a:ln>
+        </p:spPr>
+        <p:style>
+          <a:lnRef idx="2">
+            <a:schemeClr val="accent1"/>
+          </a:lnRef>
+          <a:fillRef idx="0">
+            <a:schemeClr val="accent1"/>
+          </a:fillRef>
+          <a:effectRef idx="1">
+            <a:schemeClr val="accent1"/>
+          </a:effectRef>
+          <a:fontRef idx="minor">
+            <a:schemeClr val="tx1"/>
+          </a:fontRef>
+        </p:style>
+      </p:cxnSp>
+      <p:sp>
+        <p:nvSpPr>
+          <p:cNvPr id="32" name="Textfeld 31">
+            <a:extLst>
+              <a:ext uri="{FF2B5EF4-FFF2-40B4-BE49-F238E27FC236}">
+                <a16:creationId xmlns:a16="http://schemas.microsoft.com/office/drawing/2014/main" id="{6892FFB6-5F8C-EC69-26AD-40E4265D5319}"/>
+              </a:ext>
+            </a:extLst>
+          </p:cNvPr>
+          <p:cNvSpPr txBox="1"/>
+          <p:nvPr/>
+        </p:nvSpPr>
+        <p:spPr>
+          <a:xfrm>
+            <a:off x="1292494" y="1039641"/>
+            <a:ext cx="408249" cy="276999"/>
+          </a:xfrm>
+          <a:prstGeom prst="rect">
+            <a:avLst/>
+          </a:prstGeom>
+          <a:noFill/>
+        </p:spPr>
+        <p:txBody>
+          <a:bodyPr wrap="square" rtlCol="0" anchor="ctr">
+            <a:spAutoFit/>
+          </a:bodyPr>
+          <a:lstStyle/>
+          <a:p>
+            <a:pPr algn="ctr"/>
+            <a:r>
+              <a:rPr lang="de-DE" sz="1200" i="1" dirty="0">
+                <a:solidFill>
+                  <a:srgbClr val="0070C0"/>
+                </a:solidFill>
+                <a:latin typeface="CMU Serif" panose="02000603000000000000" pitchFamily="2" charset="0"/>
+                <a:ea typeface="CMU Serif" panose="02000603000000000000" pitchFamily="2" charset="0"/>
+                <a:cs typeface="CMU Serif" panose="02000603000000000000" pitchFamily="2" charset="0"/>
+              </a:rPr>
+              <a:t>v</a:t>
+            </a:r>
+            <a:endParaRPr lang="de-DE" sz="1200" baseline="-25000" dirty="0">
+              <a:solidFill>
+                <a:srgbClr val="0070C0"/>
+              </a:solidFill>
+              <a:latin typeface="CMU Serif" panose="02000603000000000000" pitchFamily="2" charset="0"/>
+              <a:ea typeface="CMU Serif" panose="02000603000000000000" pitchFamily="2" charset="0"/>
+              <a:cs typeface="CMU Serif" panose="02000603000000000000" pitchFamily="2" charset="0"/>
+            </a:endParaRPr>
+          </a:p>
+        </p:txBody>
+      </p:sp>
+      <p:cxnSp>
+        <p:nvCxnSpPr>
+          <p:cNvPr id="33" name="Gerader Verbinder 32">
+            <a:extLst>
+              <a:ext uri="{FF2B5EF4-FFF2-40B4-BE49-F238E27FC236}">
+                <a16:creationId xmlns:a16="http://schemas.microsoft.com/office/drawing/2014/main" id="{1C5A879F-CB0C-C8BF-232B-BCF82E4F4D30}"/>
+              </a:ext>
+            </a:extLst>
+          </p:cNvPr>
+          <p:cNvCxnSpPr>
+            <a:cxnSpLocks/>
+          </p:cNvCxnSpPr>
+          <p:nvPr/>
+        </p:nvCxnSpPr>
+        <p:spPr>
+          <a:xfrm>
+            <a:off x="1468089" y="1236926"/>
+            <a:ext cx="73693" cy="0"/>
+          </a:xfrm>
+          <a:prstGeom prst="line">
+            <a:avLst/>
+          </a:prstGeom>
+          <a:ln w="6350" cap="rnd">
+            <a:solidFill>
+              <a:srgbClr val="0070C0"/>
+            </a:solidFill>
+            <a:round/>
+          </a:ln>
+        </p:spPr>
+        <p:style>
+          <a:lnRef idx="2">
+            <a:schemeClr val="accent1"/>
+          </a:lnRef>
+          <a:fillRef idx="0">
+            <a:schemeClr val="accent1"/>
+          </a:fillRef>
+          <a:effectRef idx="1">
+            <a:schemeClr val="accent1"/>
+          </a:effectRef>
+          <a:fontRef idx="minor">
+            <a:schemeClr val="tx1"/>
+          </a:fontRef>
+        </p:style>
+      </p:cxnSp>
+      <p:sp>
+        <p:nvSpPr>
+          <p:cNvPr id="37" name="Textfeld 36">
+            <a:extLst>
+              <a:ext uri="{FF2B5EF4-FFF2-40B4-BE49-F238E27FC236}">
+                <a16:creationId xmlns:a16="http://schemas.microsoft.com/office/drawing/2014/main" id="{774666BB-A26E-A7B3-2CD7-A23FD36D939B}"/>
+              </a:ext>
+            </a:extLst>
+          </p:cNvPr>
+          <p:cNvSpPr txBox="1"/>
+          <p:nvPr/>
+        </p:nvSpPr>
+        <p:spPr>
+          <a:xfrm>
+            <a:off x="2045072" y="1101322"/>
+            <a:ext cx="1021715" cy="215444"/>
+          </a:xfrm>
+          <a:prstGeom prst="rect">
+            <a:avLst/>
+          </a:prstGeom>
+          <a:noFill/>
+        </p:spPr>
+        <p:txBody>
+          <a:bodyPr wrap="square" rtlCol="0" anchor="ctr">
+            <a:spAutoFit/>
+          </a:bodyPr>
+          <a:lstStyle/>
+          <a:p>
+            <a:pPr algn="ctr"/>
+            <a:r>
+              <a:rPr lang="de-DE" sz="800" dirty="0">
+                <a:latin typeface="CMU Serif" panose="02000603000000000000" pitchFamily="2" charset="0"/>
+                <a:ea typeface="CMU Serif" panose="02000603000000000000" pitchFamily="2" charset="0"/>
+                <a:cs typeface="CMU Serif" panose="02000603000000000000" pitchFamily="2" charset="0"/>
+              </a:rPr>
+              <a:t>Kontrollvolumen</a:t>
+            </a:r>
+            <a:endParaRPr lang="de-DE" sz="800" baseline="-25000" dirty="0">
+              <a:latin typeface="CMU Serif" panose="02000603000000000000" pitchFamily="2" charset="0"/>
+              <a:ea typeface="CMU Serif" panose="02000603000000000000" pitchFamily="2" charset="0"/>
+              <a:cs typeface="CMU Serif" panose="02000603000000000000" pitchFamily="2" charset="0"/>
+            </a:endParaRPr>
+          </a:p>
+        </p:txBody>
+      </p:sp>
+      <p:sp>
+        <p:nvSpPr>
+          <p:cNvPr id="39" name="Freihandform: Form 38">
+            <a:extLst>
+              <a:ext uri="{FF2B5EF4-FFF2-40B4-BE49-F238E27FC236}">
+                <a16:creationId xmlns:a16="http://schemas.microsoft.com/office/drawing/2014/main" id="{A481870B-10F4-C95E-309E-A3EE795BCDD3}"/>
+              </a:ext>
+            </a:extLst>
+          </p:cNvPr>
+          <p:cNvSpPr/>
+          <p:nvPr/>
+        </p:nvSpPr>
+        <p:spPr>
+          <a:xfrm>
+            <a:off x="1990464" y="1204198"/>
+            <a:ext cx="152400" cy="110490"/>
+          </a:xfrm>
+          <a:custGeom>
+            <a:avLst/>
+            <a:gdLst>
+              <a:gd name="csX0" fmla="*/ 0 w 152400"/>
+              <a:gd name="csY0" fmla="*/ 110490 h 110490"/>
+              <a:gd name="csX1" fmla="*/ 66675 w 152400"/>
+              <a:gd name="csY1" fmla="*/ 24765 h 110490"/>
+              <a:gd name="csX2" fmla="*/ 152400 w 152400"/>
+              <a:gd name="csY2" fmla="*/ 0 h 110490"/>
+            </a:gdLst>
+            <a:ahLst/>
+            <a:cxnLst>
+              <a:cxn ang="0">
+                <a:pos x="csX0" y="csY0"/>
+              </a:cxn>
+              <a:cxn ang="0">
+                <a:pos x="csX1" y="csY1"/>
+              </a:cxn>
+              <a:cxn ang="0">
+                <a:pos x="csX2" y="csY2"/>
+              </a:cxn>
+            </a:cxnLst>
+            <a:rect l="l" t="t" r="r" b="b"/>
+            <a:pathLst>
+              <a:path w="152400" h="110490">
+                <a:moveTo>
+                  <a:pt x="0" y="110490"/>
+                </a:moveTo>
+                <a:cubicBezTo>
+                  <a:pt x="20637" y="76835"/>
+                  <a:pt x="41275" y="43180"/>
+                  <a:pt x="66675" y="24765"/>
+                </a:cubicBezTo>
+                <a:cubicBezTo>
+                  <a:pt x="92075" y="6350"/>
+                  <a:pt x="122237" y="3175"/>
+                  <a:pt x="152400" y="0"/>
+                </a:cubicBezTo>
+              </a:path>
+            </a:pathLst>
+          </a:custGeom>
+          <a:noFill/>
+          <a:ln w="9525" cap="rnd">
+            <a:solidFill>
+              <a:schemeClr val="tx1"/>
+            </a:solidFill>
+            <a:round/>
+          </a:ln>
+        </p:spPr>
+        <p:style>
+          <a:lnRef idx="2">
+            <a:schemeClr val="accent1">
+              <a:shade val="15000"/>
+            </a:schemeClr>
+          </a:lnRef>
+          <a:fillRef idx="1">
+            <a:schemeClr val="accent1"/>
+          </a:fillRef>
+          <a:effectRef idx="0">
+            <a:schemeClr val="accent1"/>
+          </a:effectRef>
+          <a:fontRef idx="minor">
+            <a:schemeClr val="lt1"/>
+          </a:fontRef>
+        </p:style>
+        <p:txBody>
+          <a:bodyPr rtlCol="0" anchor="ctr"/>
+          <a:lstStyle/>
+          <a:p>
+            <a:pPr algn="ctr"/>
+            <a:endParaRPr lang="de-DE"/>
+          </a:p>
+        </p:txBody>
+      </p:sp>
+      <p:cxnSp>
+        <p:nvCxnSpPr>
+          <p:cNvPr id="40" name="Gerade Verbindung mit Pfeil 39">
+            <a:extLst>
+              <a:ext uri="{FF2B5EF4-FFF2-40B4-BE49-F238E27FC236}">
+                <a16:creationId xmlns:a16="http://schemas.microsoft.com/office/drawing/2014/main" id="{4B9B3B3D-B791-EC16-3BF7-BA6B4E39FE1C}"/>
+              </a:ext>
+            </a:extLst>
+          </p:cNvPr>
+          <p:cNvCxnSpPr>
+            <a:cxnSpLocks/>
+          </p:cNvCxnSpPr>
+          <p:nvPr/>
+        </p:nvCxnSpPr>
+        <p:spPr>
+          <a:xfrm flipH="1">
+            <a:off x="1863688" y="2148601"/>
+            <a:ext cx="401320" cy="0"/>
+          </a:xfrm>
+          <a:prstGeom prst="straightConnector1">
+            <a:avLst/>
+          </a:prstGeom>
+          <a:ln cap="rnd">
+            <a:solidFill>
+              <a:srgbClr val="FF0000"/>
+            </a:solidFill>
+            <a:round/>
+            <a:headEnd type="none"/>
+            <a:tailEnd type="triangle"/>
+          </a:ln>
+        </p:spPr>
+        <p:style>
+          <a:lnRef idx="2">
+            <a:schemeClr val="accent1"/>
+          </a:lnRef>
+          <a:fillRef idx="0">
+            <a:schemeClr val="accent1"/>
+          </a:fillRef>
+          <a:effectRef idx="1">
+            <a:schemeClr val="accent1"/>
+          </a:effectRef>
+          <a:fontRef idx="minor">
+            <a:schemeClr val="tx1"/>
+          </a:fontRef>
+        </p:style>
+      </p:cxnSp>
+      <p:sp>
+        <p:nvSpPr>
+          <p:cNvPr id="42" name="Textfeld 41">
+            <a:extLst>
+              <a:ext uri="{FF2B5EF4-FFF2-40B4-BE49-F238E27FC236}">
+                <a16:creationId xmlns:a16="http://schemas.microsoft.com/office/drawing/2014/main" id="{9C1AF063-5E2E-B08C-C340-247974604256}"/>
+              </a:ext>
+            </a:extLst>
+          </p:cNvPr>
+          <p:cNvSpPr txBox="1"/>
+          <p:nvPr/>
+        </p:nvSpPr>
+        <p:spPr>
+          <a:xfrm>
+            <a:off x="1896909" y="1874142"/>
+            <a:ext cx="408249" cy="276999"/>
+          </a:xfrm>
+          <a:prstGeom prst="rect">
+            <a:avLst/>
+          </a:prstGeom>
+          <a:noFill/>
+        </p:spPr>
+        <p:txBody>
+          <a:bodyPr wrap="square" rtlCol="0" anchor="ctr">
+            <a:spAutoFit/>
+          </a:bodyPr>
+          <a:lstStyle/>
+          <a:p>
+            <a:pPr algn="ctr"/>
+            <a:r>
+              <a:rPr lang="de-DE" sz="1200" i="1" dirty="0">
+                <a:solidFill>
+                  <a:srgbClr val="FF0000"/>
+                </a:solidFill>
+                <a:latin typeface="CMU Serif" panose="02000603000000000000" pitchFamily="2" charset="0"/>
+                <a:ea typeface="CMU Serif" panose="02000603000000000000" pitchFamily="2" charset="0"/>
+                <a:cs typeface="CMU Serif" panose="02000603000000000000" pitchFamily="2" charset="0"/>
+              </a:rPr>
+              <a:t>F</a:t>
+            </a:r>
+            <a:r>
+              <a:rPr lang="de-DE" sz="1200" baseline="-25000" dirty="0">
+                <a:solidFill>
+                  <a:srgbClr val="FF0000"/>
+                </a:solidFill>
+                <a:latin typeface="CMU Serif" panose="02000603000000000000" pitchFamily="2" charset="0"/>
+                <a:ea typeface="CMU Serif" panose="02000603000000000000" pitchFamily="2" charset="0"/>
+                <a:cs typeface="CMU Serif" panose="02000603000000000000" pitchFamily="2" charset="0"/>
+              </a:rPr>
+              <a:t>R</a:t>
+            </a:r>
+          </a:p>
+        </p:txBody>
+      </p:sp>
+      <p:cxnSp>
+        <p:nvCxnSpPr>
+          <p:cNvPr id="43" name="Gerader Verbinder 42">
+            <a:extLst>
+              <a:ext uri="{FF2B5EF4-FFF2-40B4-BE49-F238E27FC236}">
+                <a16:creationId xmlns:a16="http://schemas.microsoft.com/office/drawing/2014/main" id="{A1E36F9E-6C3D-D63D-DF16-139E78EE8A74}"/>
+              </a:ext>
+            </a:extLst>
+          </p:cNvPr>
+          <p:cNvCxnSpPr>
+            <a:cxnSpLocks/>
+          </p:cNvCxnSpPr>
+          <p:nvPr/>
+        </p:nvCxnSpPr>
+        <p:spPr>
+          <a:xfrm>
+            <a:off x="2016099" y="2070861"/>
+            <a:ext cx="100363" cy="0"/>
+          </a:xfrm>
+          <a:prstGeom prst="line">
+            <a:avLst/>
+          </a:prstGeom>
+          <a:ln w="6350" cap="rnd">
+            <a:solidFill>
+              <a:srgbClr val="FF0000"/>
+            </a:solidFill>
+            <a:round/>
+          </a:ln>
+        </p:spPr>
+        <p:style>
+          <a:lnRef idx="2">
+            <a:schemeClr val="accent1"/>
+          </a:lnRef>
+          <a:fillRef idx="0">
+            <a:schemeClr val="accent1"/>
+          </a:fillRef>
+          <a:effectRef idx="1">
+            <a:schemeClr val="accent1"/>
+          </a:effectRef>
+          <a:fontRef idx="minor">
+            <a:schemeClr val="tx1"/>
+          </a:fontRef>
+        </p:style>
+      </p:cxnSp>
+      <p:sp>
+        <p:nvSpPr>
+          <p:cNvPr id="45" name="Textfeld 44">
+            <a:extLst>
+              <a:ext uri="{FF2B5EF4-FFF2-40B4-BE49-F238E27FC236}">
+                <a16:creationId xmlns:a16="http://schemas.microsoft.com/office/drawing/2014/main" id="{6B092FF6-0E4B-CE93-D326-054DA825D96C}"/>
+              </a:ext>
+            </a:extLst>
+          </p:cNvPr>
+          <p:cNvSpPr txBox="1"/>
+          <p:nvPr/>
+        </p:nvSpPr>
+        <p:spPr>
+          <a:xfrm>
+            <a:off x="936144" y="2203153"/>
+            <a:ext cx="712700" cy="276999"/>
+          </a:xfrm>
+          <a:prstGeom prst="rect">
+            <a:avLst/>
+          </a:prstGeom>
+          <a:noFill/>
+        </p:spPr>
+        <p:txBody>
+          <a:bodyPr wrap="square">
+            <a:spAutoFit/>
+          </a:bodyPr>
+          <a:lstStyle/>
+          <a:p>
+            <a:pPr algn="ctr"/>
+            <a:r>
+              <a:rPr lang="de-DE" sz="1200" dirty="0">
+                <a:solidFill>
+                  <a:schemeClr val="tx1">
+                    <a:lumMod val="75000"/>
+                    <a:lumOff val="25000"/>
+                  </a:schemeClr>
+                </a:solidFill>
+                <a:latin typeface="CMU Serif" panose="02000603000000000000" pitchFamily="2" charset="0"/>
+                <a:ea typeface="CMU Serif" panose="02000603000000000000" pitchFamily="2" charset="0"/>
+                <a:cs typeface="CMU Serif" panose="02000603000000000000" pitchFamily="2" charset="0"/>
+              </a:rPr>
+              <a:t>Wand</a:t>
+            </a:r>
+          </a:p>
+        </p:txBody>
+      </p:sp>
+      <p:cxnSp>
+        <p:nvCxnSpPr>
+          <p:cNvPr id="46" name="Gerade Verbindung mit Pfeil 45">
+            <a:extLst>
+              <a:ext uri="{FF2B5EF4-FFF2-40B4-BE49-F238E27FC236}">
+                <a16:creationId xmlns:a16="http://schemas.microsoft.com/office/drawing/2014/main" id="{D9C918C7-88A2-038F-48A9-F6E3BE6827F2}"/>
+              </a:ext>
+            </a:extLst>
+          </p:cNvPr>
+          <p:cNvCxnSpPr>
+            <a:cxnSpLocks/>
+          </p:cNvCxnSpPr>
+          <p:nvPr/>
+        </p:nvCxnSpPr>
+        <p:spPr>
+          <a:xfrm flipH="1">
+            <a:off x="1983068" y="2242581"/>
+            <a:ext cx="401320" cy="0"/>
+          </a:xfrm>
+          <a:prstGeom prst="straightConnector1">
+            <a:avLst/>
+          </a:prstGeom>
+          <a:ln cap="rnd">
+            <a:solidFill>
+              <a:srgbClr val="FF0000"/>
+            </a:solidFill>
+            <a:round/>
+            <a:headEnd type="triangle"/>
+            <a:tailEnd type="none"/>
+          </a:ln>
+        </p:spPr>
+        <p:style>
+          <a:lnRef idx="2">
+            <a:schemeClr val="accent1"/>
+          </a:lnRef>
+          <a:fillRef idx="0">
+            <a:schemeClr val="accent1"/>
+          </a:fillRef>
+          <a:effectRef idx="1">
+            <a:schemeClr val="accent1"/>
+          </a:effectRef>
+          <a:fontRef idx="minor">
+            <a:schemeClr val="tx1"/>
+          </a:fontRef>
+        </p:style>
+      </p:cxnSp>
+      <p:sp>
+        <p:nvSpPr>
+          <p:cNvPr id="48" name="Textfeld 47">
+            <a:extLst>
+              <a:ext uri="{FF2B5EF4-FFF2-40B4-BE49-F238E27FC236}">
+                <a16:creationId xmlns:a16="http://schemas.microsoft.com/office/drawing/2014/main" id="{541F987B-E43A-F82C-62F5-6391CEC10110}"/>
+              </a:ext>
+            </a:extLst>
+          </p:cNvPr>
+          <p:cNvSpPr txBox="1"/>
+          <p:nvPr/>
+        </p:nvSpPr>
+        <p:spPr>
+          <a:xfrm>
+            <a:off x="2529976" y="1429047"/>
+            <a:ext cx="1021715" cy="338554"/>
+          </a:xfrm>
+          <a:prstGeom prst="rect">
+            <a:avLst/>
+          </a:prstGeom>
+          <a:noFill/>
+        </p:spPr>
+        <p:txBody>
+          <a:bodyPr wrap="square" rtlCol="0" anchor="ctr">
+            <a:spAutoFit/>
+          </a:bodyPr>
+          <a:lstStyle/>
+          <a:p>
+            <a:pPr algn="ctr"/>
+            <a:r>
+              <a:rPr lang="de-DE" sz="800" dirty="0">
+                <a:solidFill>
+                  <a:srgbClr val="FF0000"/>
+                </a:solidFill>
+                <a:latin typeface="CMU Serif" panose="02000603000000000000" pitchFamily="2" charset="0"/>
+                <a:ea typeface="CMU Serif" panose="02000603000000000000" pitchFamily="2" charset="0"/>
+                <a:cs typeface="CMU Serif" panose="02000603000000000000" pitchFamily="2" charset="0"/>
+              </a:rPr>
+              <a:t>Schubkraft</a:t>
+            </a:r>
+          </a:p>
+          <a:p>
+            <a:pPr algn="ctr"/>
+            <a:r>
+              <a:rPr lang="de-DE" sz="800" dirty="0">
+                <a:solidFill>
+                  <a:srgbClr val="FF0000"/>
+                </a:solidFill>
+                <a:latin typeface="CMU Serif" panose="02000603000000000000" pitchFamily="2" charset="0"/>
+                <a:ea typeface="CMU Serif" panose="02000603000000000000" pitchFamily="2" charset="0"/>
+                <a:cs typeface="CMU Serif" panose="02000603000000000000" pitchFamily="2" charset="0"/>
+              </a:rPr>
+              <a:t>auf das Fluid</a:t>
+            </a:r>
+            <a:endParaRPr lang="de-DE" sz="800" baseline="-25000" dirty="0">
+              <a:solidFill>
+                <a:srgbClr val="FF0000"/>
+              </a:solidFill>
+              <a:latin typeface="CMU Serif" panose="02000603000000000000" pitchFamily="2" charset="0"/>
+              <a:ea typeface="CMU Serif" panose="02000603000000000000" pitchFamily="2" charset="0"/>
+              <a:cs typeface="CMU Serif" panose="02000603000000000000" pitchFamily="2" charset="0"/>
+            </a:endParaRPr>
+          </a:p>
+        </p:txBody>
+      </p:sp>
+      <p:sp>
+        <p:nvSpPr>
+          <p:cNvPr id="49" name="Freihandform: Form 48">
+            <a:extLst>
+              <a:ext uri="{FF2B5EF4-FFF2-40B4-BE49-F238E27FC236}">
+                <a16:creationId xmlns:a16="http://schemas.microsoft.com/office/drawing/2014/main" id="{5B49D90A-BBD9-2B96-3603-43F5B9050704}"/>
+              </a:ext>
+            </a:extLst>
+          </p:cNvPr>
+          <p:cNvSpPr/>
+          <p:nvPr/>
+        </p:nvSpPr>
+        <p:spPr>
+          <a:xfrm>
+            <a:off x="2170486" y="1536701"/>
+            <a:ext cx="566658" cy="386079"/>
+          </a:xfrm>
+          <a:custGeom>
+            <a:avLst/>
+            <a:gdLst>
+              <a:gd name="csX0" fmla="*/ 0 w 533400"/>
+              <a:gd name="csY0" fmla="*/ 236220 h 236220"/>
+              <a:gd name="csX1" fmla="*/ 223520 w 533400"/>
+              <a:gd name="csY1" fmla="*/ 63500 h 236220"/>
+              <a:gd name="csX2" fmla="*/ 533400 w 533400"/>
+              <a:gd name="csY2" fmla="*/ 0 h 236220"/>
+            </a:gdLst>
+            <a:ahLst/>
+            <a:cxnLst>
+              <a:cxn ang="0">
+                <a:pos x="csX0" y="csY0"/>
+              </a:cxn>
+              <a:cxn ang="0">
+                <a:pos x="csX1" y="csY1"/>
+              </a:cxn>
+              <a:cxn ang="0">
+                <a:pos x="csX2" y="csY2"/>
+              </a:cxn>
+            </a:cxnLst>
+            <a:rect l="l" t="t" r="r" b="b"/>
+            <a:pathLst>
+              <a:path w="533400" h="236220">
+                <a:moveTo>
+                  <a:pt x="0" y="236220"/>
+                </a:moveTo>
+                <a:cubicBezTo>
+                  <a:pt x="67310" y="169545"/>
+                  <a:pt x="134620" y="102870"/>
+                  <a:pt x="223520" y="63500"/>
+                </a:cubicBezTo>
+                <a:cubicBezTo>
+                  <a:pt x="312420" y="24130"/>
+                  <a:pt x="422910" y="12065"/>
+                  <a:pt x="533400" y="0"/>
+                </a:cubicBezTo>
+              </a:path>
+            </a:pathLst>
+          </a:custGeom>
+          <a:noFill/>
+          <a:ln w="9525" cap="rnd">
+            <a:solidFill>
+              <a:srgbClr val="FF0000"/>
+            </a:solidFill>
+            <a:round/>
+          </a:ln>
+        </p:spPr>
+        <p:style>
+          <a:lnRef idx="2">
+            <a:schemeClr val="accent1">
+              <a:shade val="15000"/>
+            </a:schemeClr>
+          </a:lnRef>
+          <a:fillRef idx="1">
+            <a:schemeClr val="accent1"/>
+          </a:fillRef>
+          <a:effectRef idx="0">
+            <a:schemeClr val="accent1"/>
+          </a:effectRef>
+          <a:fontRef idx="minor">
+            <a:schemeClr val="lt1"/>
+          </a:fontRef>
+        </p:style>
+        <p:txBody>
+          <a:bodyPr rtlCol="0" anchor="ctr"/>
+          <a:lstStyle/>
+          <a:p>
+            <a:pPr algn="ctr"/>
+            <a:endParaRPr lang="de-DE"/>
+          </a:p>
+        </p:txBody>
+      </p:sp>
+      <p:sp>
+        <p:nvSpPr>
+          <p:cNvPr id="51" name="Textfeld 50">
+            <a:extLst>
+              <a:ext uri="{FF2B5EF4-FFF2-40B4-BE49-F238E27FC236}">
+                <a16:creationId xmlns:a16="http://schemas.microsoft.com/office/drawing/2014/main" id="{7C569DF0-AB53-26E0-15DA-5BCBAAB80B60}"/>
+              </a:ext>
+            </a:extLst>
+          </p:cNvPr>
+          <p:cNvSpPr txBox="1"/>
+          <p:nvPr/>
+        </p:nvSpPr>
+        <p:spPr>
+          <a:xfrm>
+            <a:off x="319730" y="2394049"/>
+            <a:ext cx="2777726" cy="369332"/>
+          </a:xfrm>
+          <a:prstGeom prst="rect">
+            <a:avLst/>
+          </a:prstGeom>
+          <a:noFill/>
+        </p:spPr>
+        <p:txBody>
+          <a:bodyPr wrap="square" rtlCol="0" anchor="ctr">
+            <a:spAutoFit/>
+          </a:bodyPr>
+          <a:lstStyle/>
+          <a:p>
+            <a:pPr algn="ctr">
+              <a:lnSpc>
+                <a:spcPct val="150000"/>
+              </a:lnSpc>
+            </a:pPr>
+            <a:r>
+              <a:rPr lang="de-DE" sz="1200" dirty="0">
+                <a:latin typeface="CMU Serif" panose="02000603000000000000" pitchFamily="2" charset="0"/>
+                <a:ea typeface="CMU Serif" panose="02000603000000000000" pitchFamily="2" charset="0"/>
+                <a:cs typeface="CMU Serif" panose="02000603000000000000" pitchFamily="2" charset="0"/>
+              </a:rPr>
+              <a:t>Actio = </a:t>
+            </a:r>
+            <a:r>
+              <a:rPr lang="de-DE" sz="1200" dirty="0" err="1">
+                <a:latin typeface="CMU Serif" panose="02000603000000000000" pitchFamily="2" charset="0"/>
+                <a:ea typeface="CMU Serif" panose="02000603000000000000" pitchFamily="2" charset="0"/>
+                <a:cs typeface="CMU Serif" panose="02000603000000000000" pitchFamily="2" charset="0"/>
+              </a:rPr>
+              <a:t>Reactio</a:t>
+            </a:r>
+            <a:r>
+              <a:rPr lang="de-DE" sz="1200" dirty="0">
+                <a:latin typeface="CMU Serif" panose="02000603000000000000" pitchFamily="2" charset="0"/>
+                <a:ea typeface="CMU Serif" panose="02000603000000000000" pitchFamily="2" charset="0"/>
+                <a:cs typeface="CMU Serif" panose="02000603000000000000" pitchFamily="2" charset="0"/>
+              </a:rPr>
+              <a:t>        Fluid </a:t>
+            </a:r>
+            <a:r>
+              <a:rPr lang="de-DE" sz="1200" dirty="0">
+                <a:latin typeface="Latin Modern Math" panose="02000503000000000000" pitchFamily="50" charset="0"/>
+                <a:ea typeface="Latin Modern Math" panose="02000503000000000000" pitchFamily="50" charset="0"/>
+                <a:cs typeface="CMU Serif" panose="02000603000000000000" pitchFamily="2" charset="0"/>
+              </a:rPr>
+              <a:t>⇔</a:t>
+            </a:r>
+            <a:r>
+              <a:rPr lang="de-DE" sz="1200" dirty="0">
+                <a:latin typeface="CMU Serif" panose="02000603000000000000" pitchFamily="2" charset="0"/>
+                <a:ea typeface="CMU Serif" panose="02000603000000000000" pitchFamily="2" charset="0"/>
+                <a:cs typeface="CMU Serif" panose="02000603000000000000" pitchFamily="2" charset="0"/>
+              </a:rPr>
+              <a:t> Wand</a:t>
+            </a:r>
+          </a:p>
+        </p:txBody>
+      </p:sp>
+      <p:sp>
+        <p:nvSpPr>
+          <p:cNvPr id="53" name="Textfeld 52">
+            <a:extLst>
+              <a:ext uri="{FF2B5EF4-FFF2-40B4-BE49-F238E27FC236}">
+                <a16:creationId xmlns:a16="http://schemas.microsoft.com/office/drawing/2014/main" id="{EFF01B52-DFCB-6DCB-BD2B-7CAFBC0B6595}"/>
+              </a:ext>
+            </a:extLst>
+          </p:cNvPr>
+          <p:cNvSpPr txBox="1"/>
+          <p:nvPr/>
+        </p:nvSpPr>
+        <p:spPr>
+          <a:xfrm>
+            <a:off x="2578735" y="1814323"/>
+            <a:ext cx="1021715" cy="338554"/>
+          </a:xfrm>
+          <a:prstGeom prst="rect">
+            <a:avLst/>
+          </a:prstGeom>
+          <a:noFill/>
+        </p:spPr>
+        <p:txBody>
+          <a:bodyPr wrap="square" rtlCol="0" anchor="ctr">
+            <a:spAutoFit/>
+          </a:bodyPr>
+          <a:lstStyle/>
+          <a:p>
+            <a:pPr algn="ctr"/>
+            <a:r>
+              <a:rPr lang="de-DE" sz="800" dirty="0">
+                <a:solidFill>
+                  <a:srgbClr val="FF0000"/>
+                </a:solidFill>
+                <a:latin typeface="CMU Serif" panose="02000603000000000000" pitchFamily="2" charset="0"/>
+                <a:ea typeface="CMU Serif" panose="02000603000000000000" pitchFamily="2" charset="0"/>
+                <a:cs typeface="CMU Serif" panose="02000603000000000000" pitchFamily="2" charset="0"/>
+              </a:rPr>
+              <a:t>Schubkraft</a:t>
+            </a:r>
+          </a:p>
+          <a:p>
+            <a:pPr algn="ctr"/>
+            <a:r>
+              <a:rPr lang="de-DE" sz="800" dirty="0">
+                <a:solidFill>
+                  <a:srgbClr val="FF0000"/>
+                </a:solidFill>
+                <a:latin typeface="CMU Serif" panose="02000603000000000000" pitchFamily="2" charset="0"/>
+                <a:ea typeface="CMU Serif" panose="02000603000000000000" pitchFamily="2" charset="0"/>
+                <a:cs typeface="CMU Serif" panose="02000603000000000000" pitchFamily="2" charset="0"/>
+              </a:rPr>
+              <a:t>auf Wand</a:t>
+            </a:r>
+            <a:endParaRPr lang="de-DE" sz="800" baseline="-25000" dirty="0">
+              <a:solidFill>
+                <a:srgbClr val="FF0000"/>
+              </a:solidFill>
+              <a:latin typeface="CMU Serif" panose="02000603000000000000" pitchFamily="2" charset="0"/>
+              <a:ea typeface="CMU Serif" panose="02000603000000000000" pitchFamily="2" charset="0"/>
+              <a:cs typeface="CMU Serif" panose="02000603000000000000" pitchFamily="2" charset="0"/>
+            </a:endParaRPr>
+          </a:p>
+        </p:txBody>
+      </p:sp>
+      <p:sp>
+        <p:nvSpPr>
+          <p:cNvPr id="55" name="Freihandform: Form 54">
+            <a:extLst>
+              <a:ext uri="{FF2B5EF4-FFF2-40B4-BE49-F238E27FC236}">
+                <a16:creationId xmlns:a16="http://schemas.microsoft.com/office/drawing/2014/main" id="{54009DD3-70B4-9D94-F781-36588EF7B1D0}"/>
+              </a:ext>
+            </a:extLst>
+          </p:cNvPr>
+          <p:cNvSpPr/>
+          <p:nvPr/>
+        </p:nvSpPr>
+        <p:spPr>
+          <a:xfrm>
+            <a:off x="2386385" y="1972228"/>
+            <a:ext cx="401319" cy="245192"/>
+          </a:xfrm>
+          <a:custGeom>
+            <a:avLst/>
+            <a:gdLst>
+              <a:gd name="csX0" fmla="*/ 0 w 533400"/>
+              <a:gd name="csY0" fmla="*/ 236220 h 236220"/>
+              <a:gd name="csX1" fmla="*/ 223520 w 533400"/>
+              <a:gd name="csY1" fmla="*/ 63500 h 236220"/>
+              <a:gd name="csX2" fmla="*/ 533400 w 533400"/>
+              <a:gd name="csY2" fmla="*/ 0 h 236220"/>
+            </a:gdLst>
+            <a:ahLst/>
+            <a:cxnLst>
+              <a:cxn ang="0">
+                <a:pos x="csX0" y="csY0"/>
+              </a:cxn>
+              <a:cxn ang="0">
+                <a:pos x="csX1" y="csY1"/>
+              </a:cxn>
+              <a:cxn ang="0">
+                <a:pos x="csX2" y="csY2"/>
+              </a:cxn>
+            </a:cxnLst>
+            <a:rect l="l" t="t" r="r" b="b"/>
+            <a:pathLst>
+              <a:path w="533400" h="236220">
+                <a:moveTo>
+                  <a:pt x="0" y="236220"/>
+                </a:moveTo>
+                <a:cubicBezTo>
+                  <a:pt x="67310" y="169545"/>
+                  <a:pt x="134620" y="102870"/>
+                  <a:pt x="223520" y="63500"/>
+                </a:cubicBezTo>
+                <a:cubicBezTo>
+                  <a:pt x="312420" y="24130"/>
+                  <a:pt x="422910" y="12065"/>
+                  <a:pt x="533400" y="0"/>
+                </a:cubicBezTo>
+              </a:path>
+            </a:pathLst>
+          </a:custGeom>
+          <a:noFill/>
+          <a:ln w="9525" cap="rnd">
+            <a:solidFill>
+              <a:srgbClr val="FF0000"/>
+            </a:solidFill>
+            <a:round/>
+          </a:ln>
+        </p:spPr>
+        <p:style>
+          <a:lnRef idx="2">
+            <a:schemeClr val="accent1">
+              <a:shade val="15000"/>
+            </a:schemeClr>
+          </a:lnRef>
+          <a:fillRef idx="1">
+            <a:schemeClr val="accent1"/>
+          </a:fillRef>
+          <a:effectRef idx="0">
+            <a:schemeClr val="accent1"/>
+          </a:effectRef>
+          <a:fontRef idx="minor">
+            <a:schemeClr val="lt1"/>
+          </a:fontRef>
+        </p:style>
+        <p:txBody>
+          <a:bodyPr rtlCol="0" anchor="ctr"/>
+          <a:lstStyle/>
+          <a:p>
+            <a:pPr algn="ctr"/>
+            <a:endParaRPr lang="de-DE"/>
+          </a:p>
+        </p:txBody>
+      </p:sp>
+    </p:spTree>
+    <p:extLst>
+      <p:ext uri="{BB962C8B-B14F-4D97-AF65-F5344CB8AC3E}">
+        <p14:creationId xmlns:p14="http://schemas.microsoft.com/office/powerpoint/2010/main" val="3362609332"/>
+      </p:ext>
+    </p:extLst>
+  </p:cSld>
+  <p:clrMapOvr>
+    <a:masterClrMapping/>
+  </p:clrMapOvr>
+</p:sld>
+</file>
+
+<file path=ppt/slides/slide9.xml><?xml version="1.0" encoding="utf-8"?>
+<p:sld xmlns:a="http://schemas.openxmlformats.org/drawingml/2006/main" xmlns:r="http://schemas.openxmlformats.org/officeDocument/2006/relationships" xmlns:p="http://schemas.openxmlformats.org/presentationml/2006/main">
+  <p:cSld>
+    <p:spTree>
+      <p:nvGrpSpPr>
+        <p:cNvPr id="1" name="">
+          <a:extLst>
+            <a:ext uri="{FF2B5EF4-FFF2-40B4-BE49-F238E27FC236}">
+              <a16:creationId xmlns:a16="http://schemas.microsoft.com/office/drawing/2014/main" id="{FAB7C9B2-6F40-2487-74BB-BFB9D5B8D12D}"/>
+            </a:ext>
+          </a:extLst>
+        </p:cNvPr>
+        <p:cNvGrpSpPr/>
+        <p:nvPr/>
+      </p:nvGrpSpPr>
+      <p:grpSpPr>
+        <a:xfrm>
+          <a:off x="0" y="0"/>
+          <a:ext cx="0" cy="0"/>
+          <a:chOff x="0" y="0"/>
+          <a:chExt cx="0" cy="0"/>
+        </a:xfrm>
+      </p:grpSpPr>
+    </p:spTree>
+    <p:extLst>
+      <p:ext uri="{BB962C8B-B14F-4D97-AF65-F5344CB8AC3E}">
+        <p14:creationId xmlns:p14="http://schemas.microsoft.com/office/powerpoint/2010/main" val="3211605948"/>
       </p:ext>
     </p:extLst>
   </p:cSld>

</xml_diff>